<commit_message>
feat: update PPT with real data values + use case metrics
</commit_message>
<xml_diff>
--- a/test_data/PulseAI_Presentation.pptx
+++ b/test_data/PulseAI_Presentation.pptx
@@ -3525,7 +3525,7 @@
                   <a:srgbClr val="3B82F6"/>
                 </a:solidFill>
               </a:rPr>
-              <a:t>200+</a:t>
+              <a:t>3,411+</a:t>
             </a:r>
           </a:p>
         </p:txBody>
@@ -3679,7 +3679,7 @@
                   <a:srgbClr val="3B82F6"/>
                 </a:solidFill>
               </a:rPr>
-              <a:t>6</a:t>
+              <a:t>5</a:t>
             </a:r>
           </a:p>
         </p:txBody>
@@ -3713,7 +3713,7 @@
                   <a:srgbClr val="CBD5E1"/>
                 </a:solidFill>
               </a:rPr>
-              <a:t>Tab Support</a:t>
+              <a:t>Excel Tabs</a:t>
             </a:r>
           </a:p>
         </p:txBody>
@@ -4107,7 +4107,7 @@
                   <a:srgbClr val="3B82F6"/>
                 </a:solidFill>
               </a:rPr>
-              <a:t>$12.4M</a:t>
+              <a:t>$743.9M</a:t>
             </a:r>
           </a:p>
         </p:txBody>
@@ -4141,7 +4141,7 @@
                   <a:srgbClr val="CBD5E1"/>
                 </a:solidFill>
               </a:rPr>
-              <a:t>Total Loans</a:t>
+              <a:t>Total Outstanding</a:t>
             </a:r>
           </a:p>
         </p:txBody>
@@ -4261,7 +4261,7 @@
                   <a:srgbClr val="EF4444"/>
                 </a:solidFill>
               </a:rPr>
-              <a:t>18%</a:t>
+              <a:t>34%</a:t>
             </a:r>
           </a:p>
         </p:txBody>
@@ -4295,7 +4295,7 @@
                   <a:srgbClr val="CBD5E1"/>
                 </a:solidFill>
               </a:rPr>
-              <a:t>Default Rate</a:t>
+              <a:t>Default+Watch Rate</a:t>
             </a:r>
           </a:p>
         </p:txBody>
@@ -4415,7 +4415,7 @@
                   <a:srgbClr val="10B981"/>
                 </a:solidFill>
               </a:rPr>
-              <a:t>742</a:t>
+              <a:t>657</a:t>
             </a:r>
           </a:p>
         </p:txBody>
@@ -4449,7 +4449,7 @@
                   <a:srgbClr val="CBD5E1"/>
                 </a:solidFill>
               </a:rPr>
-              <a:t>Avg Credit</a:t>
+              <a:t>Avg Credit Score</a:t>
             </a:r>
           </a:p>
         </p:txBody>
@@ -8145,7 +8145,7 @@
                   <a:srgbClr val="FFFFFF"/>
                 </a:solidFill>
               </a:rPr>
-              <a:t>Live Example — Finance Dataset</a:t>
+              <a:t>Live Example — Banking Loan Portfolio</a:t>
             </a:r>
           </a:p>
         </p:txBody>
@@ -8179,7 +8179,7 @@
                   <a:srgbClr val="CBD5E1"/>
                 </a:solidFill>
               </a:rPr>
-              <a:t>FinanceData_MultiTab.xlsx — 6 tabs, 2,530 rows, real FK relationships</a:t>
+              <a:t>Banking_LoanPortfolio.xlsx — 5 tabs, 1,820 rows, real FK relationships auto-detected</a:t>
             </a:r>
           </a:p>
         </p:txBody>
@@ -8256,7 +8256,7 @@
                   <a:srgbClr val="000000"/>
                 </a:solidFill>
               </a:rPr>
-              <a:t>DEMO DATA</a:t>
+              <a:t>BANKING DEMO</a:t>
             </a:r>
           </a:p>
         </p:txBody>
@@ -8521,7 +8521,7 @@
                   <a:srgbClr val="CBD5E1"/>
                 </a:solidFill>
               </a:rPr>
-              <a:t>customer_id, segment, city, credit_score, annual_income</a:t>
+              <a:t>customer_id, full_name, age, segment, city, annual_income, kyc_status</a:t>
             </a:r>
           </a:p>
         </p:txBody>
@@ -8684,7 +8684,7 @@
                   <a:srgbClr val="F59E0B"/>
                 </a:solidFill>
               </a:rPr>
-              <a:t>350 rows</a:t>
+              <a:t>300 rows</a:t>
             </a:r>
           </a:p>
         </p:txBody>
@@ -8718,7 +8718,7 @@
                   <a:srgbClr val="FFFFFF"/>
                 </a:solidFill>
               </a:rPr>
-              <a:t>Accounts</a:t>
+              <a:t>Loans</a:t>
             </a:r>
           </a:p>
         </p:txBody>
@@ -8752,7 +8752,7 @@
                   <a:srgbClr val="CBD5E1"/>
                 </a:solidFill>
               </a:rPr>
-              <a:t>account_id, customer_id, type, balance, interest_rate</a:t>
+              <a:t>loan_id, customer_id, loan_type, outstanding_balance, dpd, loan_status, credit_score</a:t>
             </a:r>
           </a:p>
         </p:txBody>
@@ -8915,7 +8915,7 @@
                   <a:srgbClr val="F59E0B"/>
                 </a:solidFill>
               </a:rPr>
-              <a:t>1,000 rows</a:t>
+              <a:t>900 rows</a:t>
             </a:r>
           </a:p>
         </p:txBody>
@@ -8949,7 +8949,7 @@
                   <a:srgbClr val="FFFFFF"/>
                 </a:solidFill>
               </a:rPr>
-              <a:t>Transactions</a:t>
+              <a:t>Loan_Payments</a:t>
             </a:r>
           </a:p>
         </p:txBody>
@@ -8983,7 +8983,7 @@
                   <a:srgbClr val="CBD5E1"/>
                 </a:solidFill>
               </a:rPr>
-              <a:t>transaction_id, account_id, date, amount, DR/CR</a:t>
+              <a:t>payment_id, loan_id, scheduled_emi, amount_paid, delay_days, payment_status</a:t>
             </a:r>
           </a:p>
         </p:txBody>
@@ -9146,7 +9146,7 @@
                   <a:srgbClr val="F59E0B"/>
                 </a:solidFill>
               </a:rPr>
-              <a:t>180 rows</a:t>
+              <a:t>200 rows</a:t>
             </a:r>
           </a:p>
         </p:txBody>
@@ -9180,7 +9180,7 @@
                   <a:srgbClr val="FFFFFF"/>
                 </a:solidFill>
               </a:rPr>
-              <a:t>Loans</a:t>
+              <a:t>Credit_Bureau</a:t>
             </a:r>
           </a:p>
         </p:txBody>
@@ -9214,7 +9214,7 @@
                   <a:srgbClr val="CBD5E1"/>
                 </a:solidFill>
               </a:rPr>
-              <a:t>loan_id, customer_id, type, amount, outstanding, dpd</a:t>
+              <a:t>customer_id, bureau_score, active_loans_count, credit_utilization_pct, dpd_30_count</a:t>
             </a:r>
           </a:p>
         </p:txBody>
@@ -9377,7 +9377,7 @@
                   <a:srgbClr val="F59E0B"/>
                 </a:solidFill>
               </a:rPr>
-              <a:t>600 rows</a:t>
+              <a:t>220 rows</a:t>
             </a:r>
           </a:p>
         </p:txBody>
@@ -9411,7 +9411,7 @@
                   <a:srgbClr val="FFFFFF"/>
                 </a:solidFill>
               </a:rPr>
-              <a:t>Loan_Payments</a:t>
+              <a:t>Collateral</a:t>
             </a:r>
           </a:p>
         </p:txBody>
@@ -9445,21 +9445,55 @@
                   <a:srgbClr val="CBD5E1"/>
                 </a:solidFill>
               </a:rPr>
-              <a:t>payment_id, loan_id, date, scheduled, amount_paid</a:t>
-            </a:r>
-          </a:p>
-        </p:txBody>
-      </p:sp>
-      <p:sp>
-        <p:nvSpPr>
-          <p:cNvPr id="39" name="Rectangle 38"/>
+              <a:t>collateral_id, loan_id, collateral_type, market_value, ltv_ratio, status</a:t>
+            </a:r>
+          </a:p>
+        </p:txBody>
+      </p:sp>
+      <p:sp>
+        <p:nvSpPr>
+          <p:cNvPr id="39" name="TextBox 38"/>
+          <p:cNvSpPr txBox="1"/>
+          <p:nvPr/>
+        </p:nvSpPr>
+        <p:spPr>
+          <a:xfrm>
+            <a:off x="6309360" y="1097280"/>
+            <a:ext cx="5394960" cy="256032"/>
+          </a:xfrm>
+          <a:prstGeom prst="rect">
+            <a:avLst/>
+          </a:prstGeom>
+          <a:noFill/>
+        </p:spPr>
+        <p:txBody>
+          <a:bodyPr wrap="square">
+            <a:spAutoFit/>
+          </a:bodyPr>
+          <a:lstStyle/>
+          <a:p>
+            <a:pPr algn="l"/>
+            <a:r>
+              <a:rPr sz="850" b="1" i="0">
+                <a:solidFill>
+                  <a:srgbClr val="F59E0B"/>
+                </a:solidFill>
+              </a:rPr>
+              <a:t>FK RELATIONSHIPS DETECTED</a:t>
+            </a:r>
+          </a:p>
+        </p:txBody>
+      </p:sp>
+      <p:sp>
+        <p:nvSpPr>
+          <p:cNvPr id="40" name="Rectangle 39"/>
           <p:cNvSpPr/>
           <p:nvPr/>
         </p:nvSpPr>
         <p:spPr>
           <a:xfrm>
-            <a:off x="457200" y="5394959"/>
-            <a:ext cx="5486400" cy="704088"/>
+            <a:off x="6309360" y="1417320"/>
+            <a:ext cx="5486400" cy="804672"/>
           </a:xfrm>
           <a:prstGeom prst="rect">
             <a:avLst/>
@@ -9495,20 +9529,20 @@
       </p:sp>
       <p:sp>
         <p:nvSpPr>
-          <p:cNvPr id="40" name="Rectangle 39"/>
+          <p:cNvPr id="41" name="Rectangle 40"/>
           <p:cNvSpPr/>
           <p:nvPr/>
         </p:nvSpPr>
         <p:spPr>
           <a:xfrm>
-            <a:off x="457200" y="5394959"/>
-            <a:ext cx="36576" cy="704088"/>
-          </a:xfrm>
-          <a:prstGeom prst="rect">
-            <a:avLst/>
-          </a:prstGeom>
-          <a:solidFill>
-            <a:srgbClr val="3B82F6"/>
+            <a:off x="6309360" y="1417320"/>
+            <a:ext cx="36576" cy="804672"/>
+          </a:xfrm>
+          <a:prstGeom prst="rect">
+            <a:avLst/>
+          </a:prstGeom>
+          <a:solidFill>
+            <a:srgbClr val="6366F1"/>
           </a:solidFill>
           <a:ln>
             <a:noFill/>
@@ -9538,20 +9572,156 @@
       </p:sp>
       <p:sp>
         <p:nvSpPr>
-          <p:cNvPr id="41" name="Rectangle 40"/>
+          <p:cNvPr id="42" name="TextBox 41"/>
+          <p:cNvSpPr txBox="1"/>
+          <p:nvPr/>
+        </p:nvSpPr>
+        <p:spPr>
+          <a:xfrm>
+            <a:off x="6446520" y="1463040"/>
+            <a:ext cx="2194560" cy="256032"/>
+          </a:xfrm>
+          <a:prstGeom prst="rect">
+            <a:avLst/>
+          </a:prstGeom>
+          <a:noFill/>
+        </p:spPr>
+        <p:txBody>
+          <a:bodyPr wrap="square">
+            <a:spAutoFit/>
+          </a:bodyPr>
+          <a:lstStyle/>
+          <a:p>
+            <a:pPr algn="l"/>
+            <a:r>
+              <a:rPr sz="900" b="1" i="0">
+                <a:solidFill>
+                  <a:srgbClr val="3B82F6"/>
+                </a:solidFill>
+              </a:rPr>
+              <a:t>Loans.customer_id</a:t>
+            </a:r>
+          </a:p>
+        </p:txBody>
+      </p:sp>
+      <p:sp>
+        <p:nvSpPr>
+          <p:cNvPr id="43" name="TextBox 42"/>
+          <p:cNvSpPr txBox="1"/>
+          <p:nvPr/>
+        </p:nvSpPr>
+        <p:spPr>
+          <a:xfrm>
+            <a:off x="8686800" y="1463040"/>
+            <a:ext cx="365760" cy="256032"/>
+          </a:xfrm>
+          <a:prstGeom prst="rect">
+            <a:avLst/>
+          </a:prstGeom>
+          <a:noFill/>
+        </p:spPr>
+        <p:txBody>
+          <a:bodyPr wrap="square">
+            <a:spAutoFit/>
+          </a:bodyPr>
+          <a:lstStyle/>
+          <a:p>
+            <a:pPr algn="l"/>
+            <a:r>
+              <a:rPr sz="1100" b="1" i="0">
+                <a:solidFill>
+                  <a:srgbClr val="F59E0B"/>
+                </a:solidFill>
+              </a:rPr>
+              <a:t>-&gt;</a:t>
+            </a:r>
+          </a:p>
+        </p:txBody>
+      </p:sp>
+      <p:sp>
+        <p:nvSpPr>
+          <p:cNvPr id="44" name="TextBox 43"/>
+          <p:cNvSpPr txBox="1"/>
+          <p:nvPr/>
+        </p:nvSpPr>
+        <p:spPr>
+          <a:xfrm>
+            <a:off x="9098280" y="1463040"/>
+            <a:ext cx="2194560" cy="256032"/>
+          </a:xfrm>
+          <a:prstGeom prst="rect">
+            <a:avLst/>
+          </a:prstGeom>
+          <a:noFill/>
+        </p:spPr>
+        <p:txBody>
+          <a:bodyPr wrap="square">
+            <a:spAutoFit/>
+          </a:bodyPr>
+          <a:lstStyle/>
+          <a:p>
+            <a:pPr algn="l"/>
+            <a:r>
+              <a:rPr sz="900" b="1" i="0">
+                <a:solidFill>
+                  <a:srgbClr val="6366F1"/>
+                </a:solidFill>
+              </a:rPr>
+              <a:t>Customers.customer_id</a:t>
+            </a:r>
+          </a:p>
+        </p:txBody>
+      </p:sp>
+      <p:sp>
+        <p:nvSpPr>
+          <p:cNvPr id="45" name="TextBox 44"/>
+          <p:cNvSpPr txBox="1"/>
+          <p:nvPr/>
+        </p:nvSpPr>
+        <p:spPr>
+          <a:xfrm>
+            <a:off x="6446520" y="1737360"/>
+            <a:ext cx="5212080" cy="256032"/>
+          </a:xfrm>
+          <a:prstGeom prst="rect">
+            <a:avLst/>
+          </a:prstGeom>
+          <a:noFill/>
+        </p:spPr>
+        <p:txBody>
+          <a:bodyPr wrap="square">
+            <a:spAutoFit/>
+          </a:bodyPr>
+          <a:lstStyle/>
+          <a:p>
+            <a:pPr algn="l"/>
+            <a:r>
+              <a:rPr sz="800" b="0" i="1">
+                <a:solidFill>
+                  <a:srgbClr val="CBD5E1"/>
+                </a:solidFill>
+              </a:rPr>
+              <a:t>One customer → many loans</a:t>
+            </a:r>
+          </a:p>
+        </p:txBody>
+      </p:sp>
+      <p:sp>
+        <p:nvSpPr>
+          <p:cNvPr id="46" name="Rectangle 45"/>
           <p:cNvSpPr/>
           <p:nvPr/>
         </p:nvSpPr>
         <p:spPr>
           <a:xfrm>
-            <a:off x="640080" y="5440679"/>
-            <a:ext cx="868680" cy="256032"/>
-          </a:xfrm>
-          <a:prstGeom prst="rect">
-            <a:avLst/>
-          </a:prstGeom>
-          <a:solidFill>
-            <a:srgbClr val="0F172A"/>
+            <a:off x="6309360" y="2441448"/>
+            <a:ext cx="5486400" cy="804672"/>
+          </a:xfrm>
+          <a:prstGeom prst="rect">
+            <a:avLst/>
+          </a:prstGeom>
+          <a:solidFill>
+            <a:srgbClr val="1E293B"/>
           </a:solidFill>
           <a:ln>
             <a:noFill/>
@@ -9581,156 +9751,20 @@
       </p:sp>
       <p:sp>
         <p:nvSpPr>
-          <p:cNvPr id="42" name="TextBox 41"/>
-          <p:cNvSpPr txBox="1"/>
-          <p:nvPr/>
-        </p:nvSpPr>
-        <p:spPr>
-          <a:xfrm>
-            <a:off x="685800" y="5458967"/>
-            <a:ext cx="777240" cy="219456"/>
-          </a:xfrm>
-          <a:prstGeom prst="rect">
-            <a:avLst/>
-          </a:prstGeom>
-          <a:noFill/>
-        </p:spPr>
-        <p:txBody>
-          <a:bodyPr wrap="square">
-            <a:spAutoFit/>
-          </a:bodyPr>
-          <a:lstStyle/>
-          <a:p>
-            <a:pPr algn="ctr"/>
-            <a:r>
-              <a:rPr sz="700" b="1" i="0">
-                <a:solidFill>
-                  <a:srgbClr val="F59E0B"/>
-                </a:solidFill>
-              </a:rPr>
-              <a:t>200 rows</a:t>
-            </a:r>
-          </a:p>
-        </p:txBody>
-      </p:sp>
-      <p:sp>
-        <p:nvSpPr>
-          <p:cNvPr id="43" name="TextBox 42"/>
-          <p:cNvSpPr txBox="1"/>
-          <p:nvPr/>
-        </p:nvSpPr>
-        <p:spPr>
-          <a:xfrm>
-            <a:off x="1600200" y="5422392"/>
-            <a:ext cx="4206240" cy="274320"/>
-          </a:xfrm>
-          <a:prstGeom prst="rect">
-            <a:avLst/>
-          </a:prstGeom>
-          <a:noFill/>
-        </p:spPr>
-        <p:txBody>
-          <a:bodyPr wrap="square">
-            <a:spAutoFit/>
-          </a:bodyPr>
-          <a:lstStyle/>
-          <a:p>
-            <a:pPr algn="l"/>
-            <a:r>
-              <a:rPr sz="1000" b="1" i="0">
-                <a:solidFill>
-                  <a:srgbClr val="FFFFFF"/>
-                </a:solidFill>
-              </a:rPr>
-              <a:t>Portfolio</a:t>
-            </a:r>
-          </a:p>
-        </p:txBody>
-      </p:sp>
-      <p:sp>
-        <p:nvSpPr>
-          <p:cNvPr id="44" name="TextBox 43"/>
-          <p:cNvSpPr txBox="1"/>
-          <p:nvPr/>
-        </p:nvSpPr>
-        <p:spPr>
-          <a:xfrm>
-            <a:off x="1600200" y="5678424"/>
-            <a:ext cx="4206240" cy="274320"/>
-          </a:xfrm>
-          <a:prstGeom prst="rect">
-            <a:avLst/>
-          </a:prstGeom>
-          <a:noFill/>
-        </p:spPr>
-        <p:txBody>
-          <a:bodyPr wrap="square">
-            <a:spAutoFit/>
-          </a:bodyPr>
-          <a:lstStyle/>
-          <a:p>
-            <a:pPr algn="l"/>
-            <a:r>
-              <a:rPr sz="750" b="0" i="0">
-                <a:solidFill>
-                  <a:srgbClr val="CBD5E1"/>
-                </a:solidFill>
-              </a:rPr>
-              <a:t>customer_id, total_balance, total_loans, net_worth, LTV</a:t>
-            </a:r>
-          </a:p>
-        </p:txBody>
-      </p:sp>
-      <p:sp>
-        <p:nvSpPr>
-          <p:cNvPr id="45" name="TextBox 44"/>
-          <p:cNvSpPr txBox="1"/>
-          <p:nvPr/>
-        </p:nvSpPr>
-        <p:spPr>
-          <a:xfrm>
-            <a:off x="6309360" y="1097280"/>
-            <a:ext cx="5394960" cy="256032"/>
-          </a:xfrm>
-          <a:prstGeom prst="rect">
-            <a:avLst/>
-          </a:prstGeom>
-          <a:noFill/>
-        </p:spPr>
-        <p:txBody>
-          <a:bodyPr wrap="square">
-            <a:spAutoFit/>
-          </a:bodyPr>
-          <a:lstStyle/>
-          <a:p>
-            <a:pPr algn="l"/>
-            <a:r>
-              <a:rPr sz="850" b="1" i="0">
-                <a:solidFill>
-                  <a:srgbClr val="F59E0B"/>
-                </a:solidFill>
-              </a:rPr>
-              <a:t>FK RELATIONSHIPS DETECTED</a:t>
-            </a:r>
-          </a:p>
-        </p:txBody>
-      </p:sp>
-      <p:sp>
-        <p:nvSpPr>
-          <p:cNvPr id="46" name="Rectangle 45"/>
+          <p:cNvPr id="47" name="Rectangle 46"/>
           <p:cNvSpPr/>
           <p:nvPr/>
         </p:nvSpPr>
         <p:spPr>
           <a:xfrm>
-            <a:off x="6309360" y="1417320"/>
-            <a:ext cx="5486400" cy="804672"/>
-          </a:xfrm>
-          <a:prstGeom prst="rect">
-            <a:avLst/>
-          </a:prstGeom>
-          <a:solidFill>
-            <a:srgbClr val="1E293B"/>
+            <a:off x="6309360" y="2441448"/>
+            <a:ext cx="36576" cy="804672"/>
+          </a:xfrm>
+          <a:prstGeom prst="rect">
+            <a:avLst/>
+          </a:prstGeom>
+          <a:solidFill>
+            <a:srgbClr val="6366F1"/>
           </a:solidFill>
           <a:ln>
             <a:noFill/>
@@ -9760,20 +9794,156 @@
       </p:sp>
       <p:sp>
         <p:nvSpPr>
-          <p:cNvPr id="47" name="Rectangle 46"/>
+          <p:cNvPr id="48" name="TextBox 47"/>
+          <p:cNvSpPr txBox="1"/>
+          <p:nvPr/>
+        </p:nvSpPr>
+        <p:spPr>
+          <a:xfrm>
+            <a:off x="6446520" y="2487168"/>
+            <a:ext cx="2194560" cy="256032"/>
+          </a:xfrm>
+          <a:prstGeom prst="rect">
+            <a:avLst/>
+          </a:prstGeom>
+          <a:noFill/>
+        </p:spPr>
+        <p:txBody>
+          <a:bodyPr wrap="square">
+            <a:spAutoFit/>
+          </a:bodyPr>
+          <a:lstStyle/>
+          <a:p>
+            <a:pPr algn="l"/>
+            <a:r>
+              <a:rPr sz="900" b="1" i="0">
+                <a:solidFill>
+                  <a:srgbClr val="3B82F6"/>
+                </a:solidFill>
+              </a:rPr>
+              <a:t>Loan_Payments.loan_id</a:t>
+            </a:r>
+          </a:p>
+        </p:txBody>
+      </p:sp>
+      <p:sp>
+        <p:nvSpPr>
+          <p:cNvPr id="49" name="TextBox 48"/>
+          <p:cNvSpPr txBox="1"/>
+          <p:nvPr/>
+        </p:nvSpPr>
+        <p:spPr>
+          <a:xfrm>
+            <a:off x="8686800" y="2487168"/>
+            <a:ext cx="365760" cy="256032"/>
+          </a:xfrm>
+          <a:prstGeom prst="rect">
+            <a:avLst/>
+          </a:prstGeom>
+          <a:noFill/>
+        </p:spPr>
+        <p:txBody>
+          <a:bodyPr wrap="square">
+            <a:spAutoFit/>
+          </a:bodyPr>
+          <a:lstStyle/>
+          <a:p>
+            <a:pPr algn="l"/>
+            <a:r>
+              <a:rPr sz="1100" b="1" i="0">
+                <a:solidFill>
+                  <a:srgbClr val="F59E0B"/>
+                </a:solidFill>
+              </a:rPr>
+              <a:t>-&gt;</a:t>
+            </a:r>
+          </a:p>
+        </p:txBody>
+      </p:sp>
+      <p:sp>
+        <p:nvSpPr>
+          <p:cNvPr id="50" name="TextBox 49"/>
+          <p:cNvSpPr txBox="1"/>
+          <p:nvPr/>
+        </p:nvSpPr>
+        <p:spPr>
+          <a:xfrm>
+            <a:off x="9098280" y="2487168"/>
+            <a:ext cx="2194560" cy="256032"/>
+          </a:xfrm>
+          <a:prstGeom prst="rect">
+            <a:avLst/>
+          </a:prstGeom>
+          <a:noFill/>
+        </p:spPr>
+        <p:txBody>
+          <a:bodyPr wrap="square">
+            <a:spAutoFit/>
+          </a:bodyPr>
+          <a:lstStyle/>
+          <a:p>
+            <a:pPr algn="l"/>
+            <a:r>
+              <a:rPr sz="900" b="1" i="0">
+                <a:solidFill>
+                  <a:srgbClr val="6366F1"/>
+                </a:solidFill>
+              </a:rPr>
+              <a:t>Loans.loan_id</a:t>
+            </a:r>
+          </a:p>
+        </p:txBody>
+      </p:sp>
+      <p:sp>
+        <p:nvSpPr>
+          <p:cNvPr id="51" name="TextBox 50"/>
+          <p:cNvSpPr txBox="1"/>
+          <p:nvPr/>
+        </p:nvSpPr>
+        <p:spPr>
+          <a:xfrm>
+            <a:off x="6446520" y="2761488"/>
+            <a:ext cx="5212080" cy="256032"/>
+          </a:xfrm>
+          <a:prstGeom prst="rect">
+            <a:avLst/>
+          </a:prstGeom>
+          <a:noFill/>
+        </p:spPr>
+        <p:txBody>
+          <a:bodyPr wrap="square">
+            <a:spAutoFit/>
+          </a:bodyPr>
+          <a:lstStyle/>
+          <a:p>
+            <a:pPr algn="l"/>
+            <a:r>
+              <a:rPr sz="800" b="0" i="1">
+                <a:solidFill>
+                  <a:srgbClr val="CBD5E1"/>
+                </a:solidFill>
+              </a:rPr>
+              <a:t>One loan → many EMI payments</a:t>
+            </a:r>
+          </a:p>
+        </p:txBody>
+      </p:sp>
+      <p:sp>
+        <p:nvSpPr>
+          <p:cNvPr id="52" name="Rectangle 51"/>
           <p:cNvSpPr/>
           <p:nvPr/>
         </p:nvSpPr>
         <p:spPr>
           <a:xfrm>
-            <a:off x="6309360" y="1417320"/>
-            <a:ext cx="36576" cy="804672"/>
-          </a:xfrm>
-          <a:prstGeom prst="rect">
-            <a:avLst/>
-          </a:prstGeom>
-          <a:solidFill>
-            <a:srgbClr val="6366F1"/>
+            <a:off x="6309360" y="3465576"/>
+            <a:ext cx="5486400" cy="804672"/>
+          </a:xfrm>
+          <a:prstGeom prst="rect">
+            <a:avLst/>
+          </a:prstGeom>
+          <a:solidFill>
+            <a:srgbClr val="1E293B"/>
           </a:solidFill>
           <a:ln>
             <a:noFill/>
@@ -9803,156 +9973,20 @@
       </p:sp>
       <p:sp>
         <p:nvSpPr>
-          <p:cNvPr id="48" name="TextBox 47"/>
-          <p:cNvSpPr txBox="1"/>
-          <p:nvPr/>
-        </p:nvSpPr>
-        <p:spPr>
-          <a:xfrm>
-            <a:off x="6446520" y="1463040"/>
-            <a:ext cx="2194560" cy="256032"/>
-          </a:xfrm>
-          <a:prstGeom prst="rect">
-            <a:avLst/>
-          </a:prstGeom>
-          <a:noFill/>
-        </p:spPr>
-        <p:txBody>
-          <a:bodyPr wrap="square">
-            <a:spAutoFit/>
-          </a:bodyPr>
-          <a:lstStyle/>
-          <a:p>
-            <a:pPr algn="l"/>
-            <a:r>
-              <a:rPr sz="900" b="1" i="0">
-                <a:solidFill>
-                  <a:srgbClr val="3B82F6"/>
-                </a:solidFill>
-              </a:rPr>
-              <a:t>Accounts.customer_id</a:t>
-            </a:r>
-          </a:p>
-        </p:txBody>
-      </p:sp>
-      <p:sp>
-        <p:nvSpPr>
-          <p:cNvPr id="49" name="TextBox 48"/>
-          <p:cNvSpPr txBox="1"/>
-          <p:nvPr/>
-        </p:nvSpPr>
-        <p:spPr>
-          <a:xfrm>
-            <a:off x="8686800" y="1463040"/>
-            <a:ext cx="365760" cy="256032"/>
-          </a:xfrm>
-          <a:prstGeom prst="rect">
-            <a:avLst/>
-          </a:prstGeom>
-          <a:noFill/>
-        </p:spPr>
-        <p:txBody>
-          <a:bodyPr wrap="square">
-            <a:spAutoFit/>
-          </a:bodyPr>
-          <a:lstStyle/>
-          <a:p>
-            <a:pPr algn="l"/>
-            <a:r>
-              <a:rPr sz="1100" b="1" i="0">
-                <a:solidFill>
-                  <a:srgbClr val="F59E0B"/>
-                </a:solidFill>
-              </a:rPr>
-              <a:t>-&gt;</a:t>
-            </a:r>
-          </a:p>
-        </p:txBody>
-      </p:sp>
-      <p:sp>
-        <p:nvSpPr>
-          <p:cNvPr id="50" name="TextBox 49"/>
-          <p:cNvSpPr txBox="1"/>
-          <p:nvPr/>
-        </p:nvSpPr>
-        <p:spPr>
-          <a:xfrm>
-            <a:off x="9098280" y="1463040"/>
-            <a:ext cx="2194560" cy="256032"/>
-          </a:xfrm>
-          <a:prstGeom prst="rect">
-            <a:avLst/>
-          </a:prstGeom>
-          <a:noFill/>
-        </p:spPr>
-        <p:txBody>
-          <a:bodyPr wrap="square">
-            <a:spAutoFit/>
-          </a:bodyPr>
-          <a:lstStyle/>
-          <a:p>
-            <a:pPr algn="l"/>
-            <a:r>
-              <a:rPr sz="900" b="1" i="0">
-                <a:solidFill>
-                  <a:srgbClr val="6366F1"/>
-                </a:solidFill>
-              </a:rPr>
-              <a:t>Customers.customer_id</a:t>
-            </a:r>
-          </a:p>
-        </p:txBody>
-      </p:sp>
-      <p:sp>
-        <p:nvSpPr>
-          <p:cNvPr id="51" name="TextBox 50"/>
-          <p:cNvSpPr txBox="1"/>
-          <p:nvPr/>
-        </p:nvSpPr>
-        <p:spPr>
-          <a:xfrm>
-            <a:off x="6446520" y="1737360"/>
-            <a:ext cx="5212080" cy="256032"/>
-          </a:xfrm>
-          <a:prstGeom prst="rect">
-            <a:avLst/>
-          </a:prstGeom>
-          <a:noFill/>
-        </p:spPr>
-        <p:txBody>
-          <a:bodyPr wrap="square">
-            <a:spAutoFit/>
-          </a:bodyPr>
-          <a:lstStyle/>
-          <a:p>
-            <a:pPr algn="l"/>
-            <a:r>
-              <a:rPr sz="800" b="0" i="1">
-                <a:solidFill>
-                  <a:srgbClr val="CBD5E1"/>
-                </a:solidFill>
-              </a:rPr>
-              <a:t>One customer, many accounts</a:t>
-            </a:r>
-          </a:p>
-        </p:txBody>
-      </p:sp>
-      <p:sp>
-        <p:nvSpPr>
-          <p:cNvPr id="52" name="Rectangle 51"/>
+          <p:cNvPr id="53" name="Rectangle 52"/>
           <p:cNvSpPr/>
           <p:nvPr/>
         </p:nvSpPr>
         <p:spPr>
           <a:xfrm>
-            <a:off x="6309360" y="2350008"/>
-            <a:ext cx="5486400" cy="804672"/>
-          </a:xfrm>
-          <a:prstGeom prst="rect">
-            <a:avLst/>
-          </a:prstGeom>
-          <a:solidFill>
-            <a:srgbClr val="1E293B"/>
+            <a:off x="6309360" y="3465576"/>
+            <a:ext cx="36576" cy="804672"/>
+          </a:xfrm>
+          <a:prstGeom prst="rect">
+            <a:avLst/>
+          </a:prstGeom>
+          <a:solidFill>
+            <a:srgbClr val="6366F1"/>
           </a:solidFill>
           <a:ln>
             <a:noFill/>
@@ -9982,20 +10016,156 @@
       </p:sp>
       <p:sp>
         <p:nvSpPr>
-          <p:cNvPr id="53" name="Rectangle 52"/>
+          <p:cNvPr id="54" name="TextBox 53"/>
+          <p:cNvSpPr txBox="1"/>
+          <p:nvPr/>
+        </p:nvSpPr>
+        <p:spPr>
+          <a:xfrm>
+            <a:off x="6446520" y="3511296"/>
+            <a:ext cx="2194560" cy="256032"/>
+          </a:xfrm>
+          <a:prstGeom prst="rect">
+            <a:avLst/>
+          </a:prstGeom>
+          <a:noFill/>
+        </p:spPr>
+        <p:txBody>
+          <a:bodyPr wrap="square">
+            <a:spAutoFit/>
+          </a:bodyPr>
+          <a:lstStyle/>
+          <a:p>
+            <a:pPr algn="l"/>
+            <a:r>
+              <a:rPr sz="900" b="1" i="0">
+                <a:solidFill>
+                  <a:srgbClr val="3B82F6"/>
+                </a:solidFill>
+              </a:rPr>
+              <a:t>Credit_Bureau.customer_id</a:t>
+            </a:r>
+          </a:p>
+        </p:txBody>
+      </p:sp>
+      <p:sp>
+        <p:nvSpPr>
+          <p:cNvPr id="55" name="TextBox 54"/>
+          <p:cNvSpPr txBox="1"/>
+          <p:nvPr/>
+        </p:nvSpPr>
+        <p:spPr>
+          <a:xfrm>
+            <a:off x="8686800" y="3511296"/>
+            <a:ext cx="365760" cy="256032"/>
+          </a:xfrm>
+          <a:prstGeom prst="rect">
+            <a:avLst/>
+          </a:prstGeom>
+          <a:noFill/>
+        </p:spPr>
+        <p:txBody>
+          <a:bodyPr wrap="square">
+            <a:spAutoFit/>
+          </a:bodyPr>
+          <a:lstStyle/>
+          <a:p>
+            <a:pPr algn="l"/>
+            <a:r>
+              <a:rPr sz="1100" b="1" i="0">
+                <a:solidFill>
+                  <a:srgbClr val="F59E0B"/>
+                </a:solidFill>
+              </a:rPr>
+              <a:t>-&gt;</a:t>
+            </a:r>
+          </a:p>
+        </p:txBody>
+      </p:sp>
+      <p:sp>
+        <p:nvSpPr>
+          <p:cNvPr id="56" name="TextBox 55"/>
+          <p:cNvSpPr txBox="1"/>
+          <p:nvPr/>
+        </p:nvSpPr>
+        <p:spPr>
+          <a:xfrm>
+            <a:off x="9098280" y="3511296"/>
+            <a:ext cx="2194560" cy="256032"/>
+          </a:xfrm>
+          <a:prstGeom prst="rect">
+            <a:avLst/>
+          </a:prstGeom>
+          <a:noFill/>
+        </p:spPr>
+        <p:txBody>
+          <a:bodyPr wrap="square">
+            <a:spAutoFit/>
+          </a:bodyPr>
+          <a:lstStyle/>
+          <a:p>
+            <a:pPr algn="l"/>
+            <a:r>
+              <a:rPr sz="900" b="1" i="0">
+                <a:solidFill>
+                  <a:srgbClr val="6366F1"/>
+                </a:solidFill>
+              </a:rPr>
+              <a:t>Customers.customer_id</a:t>
+            </a:r>
+          </a:p>
+        </p:txBody>
+      </p:sp>
+      <p:sp>
+        <p:nvSpPr>
+          <p:cNvPr id="57" name="TextBox 56"/>
+          <p:cNvSpPr txBox="1"/>
+          <p:nvPr/>
+        </p:nvSpPr>
+        <p:spPr>
+          <a:xfrm>
+            <a:off x="6446520" y="3785616"/>
+            <a:ext cx="5212080" cy="256032"/>
+          </a:xfrm>
+          <a:prstGeom prst="rect">
+            <a:avLst/>
+          </a:prstGeom>
+          <a:noFill/>
+        </p:spPr>
+        <p:txBody>
+          <a:bodyPr wrap="square">
+            <a:spAutoFit/>
+          </a:bodyPr>
+          <a:lstStyle/>
+          <a:p>
+            <a:pPr algn="l"/>
+            <a:r>
+              <a:rPr sz="800" b="0" i="1">
+                <a:solidFill>
+                  <a:srgbClr val="CBD5E1"/>
+                </a:solidFill>
+              </a:rPr>
+              <a:t>Credit profile per customer</a:t>
+            </a:r>
+          </a:p>
+        </p:txBody>
+      </p:sp>
+      <p:sp>
+        <p:nvSpPr>
+          <p:cNvPr id="58" name="Rectangle 57"/>
           <p:cNvSpPr/>
           <p:nvPr/>
         </p:nvSpPr>
         <p:spPr>
           <a:xfrm>
-            <a:off x="6309360" y="2350008"/>
-            <a:ext cx="36576" cy="804672"/>
-          </a:xfrm>
-          <a:prstGeom prst="rect">
-            <a:avLst/>
-          </a:prstGeom>
-          <a:solidFill>
-            <a:srgbClr val="6366F1"/>
+            <a:off x="6309360" y="4489704"/>
+            <a:ext cx="5486400" cy="804672"/>
+          </a:xfrm>
+          <a:prstGeom prst="rect">
+            <a:avLst/>
+          </a:prstGeom>
+          <a:solidFill>
+            <a:srgbClr val="1E293B"/>
           </a:solidFill>
           <a:ln>
             <a:noFill/>
@@ -10025,156 +10195,20 @@
       </p:sp>
       <p:sp>
         <p:nvSpPr>
-          <p:cNvPr id="54" name="TextBox 53"/>
-          <p:cNvSpPr txBox="1"/>
-          <p:nvPr/>
-        </p:nvSpPr>
-        <p:spPr>
-          <a:xfrm>
-            <a:off x="6446520" y="2395728"/>
-            <a:ext cx="2194560" cy="256032"/>
-          </a:xfrm>
-          <a:prstGeom prst="rect">
-            <a:avLst/>
-          </a:prstGeom>
-          <a:noFill/>
-        </p:spPr>
-        <p:txBody>
-          <a:bodyPr wrap="square">
-            <a:spAutoFit/>
-          </a:bodyPr>
-          <a:lstStyle/>
-          <a:p>
-            <a:pPr algn="l"/>
-            <a:r>
-              <a:rPr sz="900" b="1" i="0">
-                <a:solidFill>
-                  <a:srgbClr val="3B82F6"/>
-                </a:solidFill>
-              </a:rPr>
-              <a:t>Transactions.account_id</a:t>
-            </a:r>
-          </a:p>
-        </p:txBody>
-      </p:sp>
-      <p:sp>
-        <p:nvSpPr>
-          <p:cNvPr id="55" name="TextBox 54"/>
-          <p:cNvSpPr txBox="1"/>
-          <p:nvPr/>
-        </p:nvSpPr>
-        <p:spPr>
-          <a:xfrm>
-            <a:off x="8686800" y="2395728"/>
-            <a:ext cx="365760" cy="256032"/>
-          </a:xfrm>
-          <a:prstGeom prst="rect">
-            <a:avLst/>
-          </a:prstGeom>
-          <a:noFill/>
-        </p:spPr>
-        <p:txBody>
-          <a:bodyPr wrap="square">
-            <a:spAutoFit/>
-          </a:bodyPr>
-          <a:lstStyle/>
-          <a:p>
-            <a:pPr algn="l"/>
-            <a:r>
-              <a:rPr sz="1100" b="1" i="0">
-                <a:solidFill>
-                  <a:srgbClr val="F59E0B"/>
-                </a:solidFill>
-              </a:rPr>
-              <a:t>-&gt;</a:t>
-            </a:r>
-          </a:p>
-        </p:txBody>
-      </p:sp>
-      <p:sp>
-        <p:nvSpPr>
-          <p:cNvPr id="56" name="TextBox 55"/>
-          <p:cNvSpPr txBox="1"/>
-          <p:nvPr/>
-        </p:nvSpPr>
-        <p:spPr>
-          <a:xfrm>
-            <a:off x="9098280" y="2395728"/>
-            <a:ext cx="2194560" cy="256032"/>
-          </a:xfrm>
-          <a:prstGeom prst="rect">
-            <a:avLst/>
-          </a:prstGeom>
-          <a:noFill/>
-        </p:spPr>
-        <p:txBody>
-          <a:bodyPr wrap="square">
-            <a:spAutoFit/>
-          </a:bodyPr>
-          <a:lstStyle/>
-          <a:p>
-            <a:pPr algn="l"/>
-            <a:r>
-              <a:rPr sz="900" b="1" i="0">
-                <a:solidFill>
-                  <a:srgbClr val="6366F1"/>
-                </a:solidFill>
-              </a:rPr>
-              <a:t>Accounts.account_id</a:t>
-            </a:r>
-          </a:p>
-        </p:txBody>
-      </p:sp>
-      <p:sp>
-        <p:nvSpPr>
-          <p:cNvPr id="57" name="TextBox 56"/>
-          <p:cNvSpPr txBox="1"/>
-          <p:nvPr/>
-        </p:nvSpPr>
-        <p:spPr>
-          <a:xfrm>
-            <a:off x="6446520" y="2670048"/>
-            <a:ext cx="5212080" cy="256032"/>
-          </a:xfrm>
-          <a:prstGeom prst="rect">
-            <a:avLst/>
-          </a:prstGeom>
-          <a:noFill/>
-        </p:spPr>
-        <p:txBody>
-          <a:bodyPr wrap="square">
-            <a:spAutoFit/>
-          </a:bodyPr>
-          <a:lstStyle/>
-          <a:p>
-            <a:pPr algn="l"/>
-            <a:r>
-              <a:rPr sz="800" b="0" i="1">
-                <a:solidFill>
-                  <a:srgbClr val="CBD5E1"/>
-                </a:solidFill>
-              </a:rPr>
-              <a:t>One account, many transactions</a:t>
-            </a:r>
-          </a:p>
-        </p:txBody>
-      </p:sp>
-      <p:sp>
-        <p:nvSpPr>
-          <p:cNvPr id="58" name="Rectangle 57"/>
+          <p:cNvPr id="59" name="Rectangle 58"/>
           <p:cNvSpPr/>
           <p:nvPr/>
         </p:nvSpPr>
         <p:spPr>
           <a:xfrm>
-            <a:off x="6309360" y="3282696"/>
-            <a:ext cx="5486400" cy="804672"/>
-          </a:xfrm>
-          <a:prstGeom prst="rect">
-            <a:avLst/>
-          </a:prstGeom>
-          <a:solidFill>
-            <a:srgbClr val="1E293B"/>
+            <a:off x="6309360" y="4489704"/>
+            <a:ext cx="36576" cy="804672"/>
+          </a:xfrm>
+          <a:prstGeom prst="rect">
+            <a:avLst/>
+          </a:prstGeom>
+          <a:solidFill>
+            <a:srgbClr val="6366F1"/>
           </a:solidFill>
           <a:ln>
             <a:noFill/>
@@ -10204,56 +10238,13 @@
       </p:sp>
       <p:sp>
         <p:nvSpPr>
-          <p:cNvPr id="59" name="Rectangle 58"/>
-          <p:cNvSpPr/>
-          <p:nvPr/>
-        </p:nvSpPr>
-        <p:spPr>
-          <a:xfrm>
-            <a:off x="6309360" y="3282696"/>
-            <a:ext cx="36576" cy="804672"/>
-          </a:xfrm>
-          <a:prstGeom prst="rect">
-            <a:avLst/>
-          </a:prstGeom>
-          <a:solidFill>
-            <a:srgbClr val="6366F1"/>
-          </a:solidFill>
-          <a:ln>
-            <a:noFill/>
-          </a:ln>
-        </p:spPr>
-        <p:style>
-          <a:lnRef idx="1">
-            <a:schemeClr val="accent1"/>
-          </a:lnRef>
-          <a:fillRef idx="3">
-            <a:schemeClr val="accent1"/>
-          </a:fillRef>
-          <a:effectRef idx="2">
-            <a:schemeClr val="accent1"/>
-          </a:effectRef>
-          <a:fontRef idx="minor">
-            <a:schemeClr val="lt1"/>
-          </a:fontRef>
-        </p:style>
-        <p:txBody>
-          <a:bodyPr rtlCol="0" anchor="ctr"/>
-          <a:lstStyle/>
-          <a:p>
-            <a:pPr algn="ctr"/>
-          </a:p>
-        </p:txBody>
-      </p:sp>
-      <p:sp>
-        <p:nvSpPr>
           <p:cNvPr id="60" name="TextBox 59"/>
           <p:cNvSpPr txBox="1"/>
           <p:nvPr/>
         </p:nvSpPr>
         <p:spPr>
           <a:xfrm>
-            <a:off x="6446520" y="3328416"/>
+            <a:off x="6446520" y="4535424"/>
             <a:ext cx="2194560" cy="256032"/>
           </a:xfrm>
           <a:prstGeom prst="rect">
@@ -10274,7 +10265,7 @@
                   <a:srgbClr val="3B82F6"/>
                 </a:solidFill>
               </a:rPr>
-              <a:t>Loans.customer_id</a:t>
+              <a:t>Collateral.loan_id</a:t>
             </a:r>
           </a:p>
         </p:txBody>
@@ -10287,7 +10278,7 @@
         </p:nvSpPr>
         <p:spPr>
           <a:xfrm>
-            <a:off x="8686800" y="3328416"/>
+            <a:off x="8686800" y="4535424"/>
             <a:ext cx="365760" cy="256032"/>
           </a:xfrm>
           <a:prstGeom prst="rect">
@@ -10321,7 +10312,7 @@
         </p:nvSpPr>
         <p:spPr>
           <a:xfrm>
-            <a:off x="9098280" y="3328416"/>
+            <a:off x="9098280" y="4535424"/>
             <a:ext cx="2194560" cy="256032"/>
           </a:xfrm>
           <a:prstGeom prst="rect">
@@ -10342,7 +10333,7 @@
                   <a:srgbClr val="6366F1"/>
                 </a:solidFill>
               </a:rPr>
-              <a:t>Customers.customer_id</a:t>
+              <a:t>Loans.loan_id</a:t>
             </a:r>
           </a:p>
         </p:txBody>
@@ -10355,7 +10346,7 @@
         </p:nvSpPr>
         <p:spPr>
           <a:xfrm>
-            <a:off x="6446520" y="3602736"/>
+            <a:off x="6446520" y="4809744"/>
             <a:ext cx="5212080" cy="256032"/>
           </a:xfrm>
           <a:prstGeom prst="rect">
@@ -10376,451 +10367,7 @@
                   <a:srgbClr val="CBD5E1"/>
                 </a:solidFill>
               </a:rPr>
-              <a:t>One customer, many loans</a:t>
-            </a:r>
-          </a:p>
-        </p:txBody>
-      </p:sp>
-      <p:sp>
-        <p:nvSpPr>
-          <p:cNvPr id="64" name="Rectangle 63"/>
-          <p:cNvSpPr/>
-          <p:nvPr/>
-        </p:nvSpPr>
-        <p:spPr>
-          <a:xfrm>
-            <a:off x="6309360" y="4215384"/>
-            <a:ext cx="5486400" cy="804672"/>
-          </a:xfrm>
-          <a:prstGeom prst="rect">
-            <a:avLst/>
-          </a:prstGeom>
-          <a:solidFill>
-            <a:srgbClr val="1E293B"/>
-          </a:solidFill>
-          <a:ln>
-            <a:noFill/>
-          </a:ln>
-        </p:spPr>
-        <p:style>
-          <a:lnRef idx="1">
-            <a:schemeClr val="accent1"/>
-          </a:lnRef>
-          <a:fillRef idx="3">
-            <a:schemeClr val="accent1"/>
-          </a:fillRef>
-          <a:effectRef idx="2">
-            <a:schemeClr val="accent1"/>
-          </a:effectRef>
-          <a:fontRef idx="minor">
-            <a:schemeClr val="lt1"/>
-          </a:fontRef>
-        </p:style>
-        <p:txBody>
-          <a:bodyPr rtlCol="0" anchor="ctr"/>
-          <a:lstStyle/>
-          <a:p>
-            <a:pPr algn="ctr"/>
-          </a:p>
-        </p:txBody>
-      </p:sp>
-      <p:sp>
-        <p:nvSpPr>
-          <p:cNvPr id="65" name="Rectangle 64"/>
-          <p:cNvSpPr/>
-          <p:nvPr/>
-        </p:nvSpPr>
-        <p:spPr>
-          <a:xfrm>
-            <a:off x="6309360" y="4215384"/>
-            <a:ext cx="36576" cy="804672"/>
-          </a:xfrm>
-          <a:prstGeom prst="rect">
-            <a:avLst/>
-          </a:prstGeom>
-          <a:solidFill>
-            <a:srgbClr val="6366F1"/>
-          </a:solidFill>
-          <a:ln>
-            <a:noFill/>
-          </a:ln>
-        </p:spPr>
-        <p:style>
-          <a:lnRef idx="1">
-            <a:schemeClr val="accent1"/>
-          </a:lnRef>
-          <a:fillRef idx="3">
-            <a:schemeClr val="accent1"/>
-          </a:fillRef>
-          <a:effectRef idx="2">
-            <a:schemeClr val="accent1"/>
-          </a:effectRef>
-          <a:fontRef idx="minor">
-            <a:schemeClr val="lt1"/>
-          </a:fontRef>
-        </p:style>
-        <p:txBody>
-          <a:bodyPr rtlCol="0" anchor="ctr"/>
-          <a:lstStyle/>
-          <a:p>
-            <a:pPr algn="ctr"/>
-          </a:p>
-        </p:txBody>
-      </p:sp>
-      <p:sp>
-        <p:nvSpPr>
-          <p:cNvPr id="66" name="TextBox 65"/>
-          <p:cNvSpPr txBox="1"/>
-          <p:nvPr/>
-        </p:nvSpPr>
-        <p:spPr>
-          <a:xfrm>
-            <a:off x="6446520" y="4261104"/>
-            <a:ext cx="2194560" cy="256032"/>
-          </a:xfrm>
-          <a:prstGeom prst="rect">
-            <a:avLst/>
-          </a:prstGeom>
-          <a:noFill/>
-        </p:spPr>
-        <p:txBody>
-          <a:bodyPr wrap="square">
-            <a:spAutoFit/>
-          </a:bodyPr>
-          <a:lstStyle/>
-          <a:p>
-            <a:pPr algn="l"/>
-            <a:r>
-              <a:rPr sz="900" b="1" i="0">
-                <a:solidFill>
-                  <a:srgbClr val="3B82F6"/>
-                </a:solidFill>
-              </a:rPr>
-              <a:t>Loan_Payments.loan_id</a:t>
-            </a:r>
-          </a:p>
-        </p:txBody>
-      </p:sp>
-      <p:sp>
-        <p:nvSpPr>
-          <p:cNvPr id="67" name="TextBox 66"/>
-          <p:cNvSpPr txBox="1"/>
-          <p:nvPr/>
-        </p:nvSpPr>
-        <p:spPr>
-          <a:xfrm>
-            <a:off x="8686800" y="4261104"/>
-            <a:ext cx="365760" cy="256032"/>
-          </a:xfrm>
-          <a:prstGeom prst="rect">
-            <a:avLst/>
-          </a:prstGeom>
-          <a:noFill/>
-        </p:spPr>
-        <p:txBody>
-          <a:bodyPr wrap="square">
-            <a:spAutoFit/>
-          </a:bodyPr>
-          <a:lstStyle/>
-          <a:p>
-            <a:pPr algn="l"/>
-            <a:r>
-              <a:rPr sz="1100" b="1" i="0">
-                <a:solidFill>
-                  <a:srgbClr val="F59E0B"/>
-                </a:solidFill>
-              </a:rPr>
-              <a:t>-&gt;</a:t>
-            </a:r>
-          </a:p>
-        </p:txBody>
-      </p:sp>
-      <p:sp>
-        <p:nvSpPr>
-          <p:cNvPr id="68" name="TextBox 67"/>
-          <p:cNvSpPr txBox="1"/>
-          <p:nvPr/>
-        </p:nvSpPr>
-        <p:spPr>
-          <a:xfrm>
-            <a:off x="9098280" y="4261104"/>
-            <a:ext cx="2194560" cy="256032"/>
-          </a:xfrm>
-          <a:prstGeom prst="rect">
-            <a:avLst/>
-          </a:prstGeom>
-          <a:noFill/>
-        </p:spPr>
-        <p:txBody>
-          <a:bodyPr wrap="square">
-            <a:spAutoFit/>
-          </a:bodyPr>
-          <a:lstStyle/>
-          <a:p>
-            <a:pPr algn="l"/>
-            <a:r>
-              <a:rPr sz="900" b="1" i="0">
-                <a:solidFill>
-                  <a:srgbClr val="6366F1"/>
-                </a:solidFill>
-              </a:rPr>
-              <a:t>Loans.loan_id</a:t>
-            </a:r>
-          </a:p>
-        </p:txBody>
-      </p:sp>
-      <p:sp>
-        <p:nvSpPr>
-          <p:cNvPr id="69" name="TextBox 68"/>
-          <p:cNvSpPr txBox="1"/>
-          <p:nvPr/>
-        </p:nvSpPr>
-        <p:spPr>
-          <a:xfrm>
-            <a:off x="6446520" y="4535424"/>
-            <a:ext cx="5212080" cy="256032"/>
-          </a:xfrm>
-          <a:prstGeom prst="rect">
-            <a:avLst/>
-          </a:prstGeom>
-          <a:noFill/>
-        </p:spPr>
-        <p:txBody>
-          <a:bodyPr wrap="square">
-            <a:spAutoFit/>
-          </a:bodyPr>
-          <a:lstStyle/>
-          <a:p>
-            <a:pPr algn="l"/>
-            <a:r>
-              <a:rPr sz="800" b="0" i="1">
-                <a:solidFill>
-                  <a:srgbClr val="CBD5E1"/>
-                </a:solidFill>
-              </a:rPr>
-              <a:t>One loan, many payments</a:t>
-            </a:r>
-          </a:p>
-        </p:txBody>
-      </p:sp>
-      <p:sp>
-        <p:nvSpPr>
-          <p:cNvPr id="70" name="Rectangle 69"/>
-          <p:cNvSpPr/>
-          <p:nvPr/>
-        </p:nvSpPr>
-        <p:spPr>
-          <a:xfrm>
-            <a:off x="6309360" y="5148072"/>
-            <a:ext cx="5486400" cy="804672"/>
-          </a:xfrm>
-          <a:prstGeom prst="rect">
-            <a:avLst/>
-          </a:prstGeom>
-          <a:solidFill>
-            <a:srgbClr val="1E293B"/>
-          </a:solidFill>
-          <a:ln>
-            <a:noFill/>
-          </a:ln>
-        </p:spPr>
-        <p:style>
-          <a:lnRef idx="1">
-            <a:schemeClr val="accent1"/>
-          </a:lnRef>
-          <a:fillRef idx="3">
-            <a:schemeClr val="accent1"/>
-          </a:fillRef>
-          <a:effectRef idx="2">
-            <a:schemeClr val="accent1"/>
-          </a:effectRef>
-          <a:fontRef idx="minor">
-            <a:schemeClr val="lt1"/>
-          </a:fontRef>
-        </p:style>
-        <p:txBody>
-          <a:bodyPr rtlCol="0" anchor="ctr"/>
-          <a:lstStyle/>
-          <a:p>
-            <a:pPr algn="ctr"/>
-          </a:p>
-        </p:txBody>
-      </p:sp>
-      <p:sp>
-        <p:nvSpPr>
-          <p:cNvPr id="71" name="Rectangle 70"/>
-          <p:cNvSpPr/>
-          <p:nvPr/>
-        </p:nvSpPr>
-        <p:spPr>
-          <a:xfrm>
-            <a:off x="6309360" y="5148072"/>
-            <a:ext cx="36576" cy="804672"/>
-          </a:xfrm>
-          <a:prstGeom prst="rect">
-            <a:avLst/>
-          </a:prstGeom>
-          <a:solidFill>
-            <a:srgbClr val="6366F1"/>
-          </a:solidFill>
-          <a:ln>
-            <a:noFill/>
-          </a:ln>
-        </p:spPr>
-        <p:style>
-          <a:lnRef idx="1">
-            <a:schemeClr val="accent1"/>
-          </a:lnRef>
-          <a:fillRef idx="3">
-            <a:schemeClr val="accent1"/>
-          </a:fillRef>
-          <a:effectRef idx="2">
-            <a:schemeClr val="accent1"/>
-          </a:effectRef>
-          <a:fontRef idx="minor">
-            <a:schemeClr val="lt1"/>
-          </a:fontRef>
-        </p:style>
-        <p:txBody>
-          <a:bodyPr rtlCol="0" anchor="ctr"/>
-          <a:lstStyle/>
-          <a:p>
-            <a:pPr algn="ctr"/>
-          </a:p>
-        </p:txBody>
-      </p:sp>
-      <p:sp>
-        <p:nvSpPr>
-          <p:cNvPr id="72" name="TextBox 71"/>
-          <p:cNvSpPr txBox="1"/>
-          <p:nvPr/>
-        </p:nvSpPr>
-        <p:spPr>
-          <a:xfrm>
-            <a:off x="6446520" y="5193792"/>
-            <a:ext cx="2194560" cy="256032"/>
-          </a:xfrm>
-          <a:prstGeom prst="rect">
-            <a:avLst/>
-          </a:prstGeom>
-          <a:noFill/>
-        </p:spPr>
-        <p:txBody>
-          <a:bodyPr wrap="square">
-            <a:spAutoFit/>
-          </a:bodyPr>
-          <a:lstStyle/>
-          <a:p>
-            <a:pPr algn="l"/>
-            <a:r>
-              <a:rPr sz="900" b="1" i="0">
-                <a:solidFill>
-                  <a:srgbClr val="3B82F6"/>
-                </a:solidFill>
-              </a:rPr>
-              <a:t>Portfolio.customer_id</a:t>
-            </a:r>
-          </a:p>
-        </p:txBody>
-      </p:sp>
-      <p:sp>
-        <p:nvSpPr>
-          <p:cNvPr id="73" name="TextBox 72"/>
-          <p:cNvSpPr txBox="1"/>
-          <p:nvPr/>
-        </p:nvSpPr>
-        <p:spPr>
-          <a:xfrm>
-            <a:off x="8686800" y="5193792"/>
-            <a:ext cx="365760" cy="256032"/>
-          </a:xfrm>
-          <a:prstGeom prst="rect">
-            <a:avLst/>
-          </a:prstGeom>
-          <a:noFill/>
-        </p:spPr>
-        <p:txBody>
-          <a:bodyPr wrap="square">
-            <a:spAutoFit/>
-          </a:bodyPr>
-          <a:lstStyle/>
-          <a:p>
-            <a:pPr algn="l"/>
-            <a:r>
-              <a:rPr sz="1100" b="1" i="0">
-                <a:solidFill>
-                  <a:srgbClr val="F59E0B"/>
-                </a:solidFill>
-              </a:rPr>
-              <a:t>-&gt;</a:t>
-            </a:r>
-          </a:p>
-        </p:txBody>
-      </p:sp>
-      <p:sp>
-        <p:nvSpPr>
-          <p:cNvPr id="74" name="TextBox 73"/>
-          <p:cNvSpPr txBox="1"/>
-          <p:nvPr/>
-        </p:nvSpPr>
-        <p:spPr>
-          <a:xfrm>
-            <a:off x="9098280" y="5193792"/>
-            <a:ext cx="2194560" cy="256032"/>
-          </a:xfrm>
-          <a:prstGeom prst="rect">
-            <a:avLst/>
-          </a:prstGeom>
-          <a:noFill/>
-        </p:spPr>
-        <p:txBody>
-          <a:bodyPr wrap="square">
-            <a:spAutoFit/>
-          </a:bodyPr>
-          <a:lstStyle/>
-          <a:p>
-            <a:pPr algn="l"/>
-            <a:r>
-              <a:rPr sz="900" b="1" i="0">
-                <a:solidFill>
-                  <a:srgbClr val="6366F1"/>
-                </a:solidFill>
-              </a:rPr>
-              <a:t>Customers.customer_id</a:t>
-            </a:r>
-          </a:p>
-        </p:txBody>
-      </p:sp>
-      <p:sp>
-        <p:nvSpPr>
-          <p:cNvPr id="75" name="TextBox 74"/>
-          <p:cNvSpPr txBox="1"/>
-          <p:nvPr/>
-        </p:nvSpPr>
-        <p:spPr>
-          <a:xfrm>
-            <a:off x="6446520" y="5468112"/>
-            <a:ext cx="5212080" cy="256032"/>
-          </a:xfrm>
-          <a:prstGeom prst="rect">
-            <a:avLst/>
-          </a:prstGeom>
-          <a:noFill/>
-        </p:spPr>
-        <p:txBody>
-          <a:bodyPr wrap="square">
-            <a:spAutoFit/>
-          </a:bodyPr>
-          <a:lstStyle/>
-          <a:p>
-            <a:pPr algn="l"/>
-            <a:r>
-              <a:rPr sz="800" b="0" i="1">
-                <a:solidFill>
-                  <a:srgbClr val="CBD5E1"/>
-                </a:solidFill>
-              </a:rPr>
-              <a:t>Aggregated view per customer</a:t>
+              <a:t>Collateral pledged per loan</a:t>
             </a:r>
           </a:p>
         </p:txBody>
@@ -15383,7 +14930,7 @@
                   <a:srgbClr val="3B82F6"/>
                 </a:solidFill>
               </a:rPr>
-              <a:t>3</a:t>
+              <a:t>5</a:t>
             </a:r>
           </a:p>
         </p:txBody>
@@ -15417,7 +14964,7 @@
                   <a:srgbClr val="CBD5E1"/>
                 </a:solidFill>
               </a:rPr>
-              <a:t>Core Features</a:t>
+              <a:t>Product Features</a:t>
             </a:r>
           </a:p>
         </p:txBody>
@@ -15605,7 +15152,7 @@
                   <a:srgbClr val="3B82F6"/>
                 </a:solidFill>
               </a:rPr>
-              <a:t>6</a:t>
+              <a:t>5</a:t>
             </a:r>
           </a:p>
         </p:txBody>
@@ -16160,7 +15707,7 @@
                   <a:srgbClr val="3B82F6"/>
                 </a:solidFill>
               </a:rPr>
-              <a:t>100%</a:t>
+              <a:t>4</a:t>
             </a:r>
           </a:p>
         </p:txBody>
@@ -16194,7 +15741,7 @@
                   <a:srgbClr val="CBD5E1"/>
                 </a:solidFill>
               </a:rPr>
-              <a:t>Browser-Based</a:t>
+              <a:t>Industry Use Cases</a:t>
             </a:r>
           </a:p>
         </p:txBody>
@@ -21794,7 +21341,7 @@
                   <a:srgbClr val="64748B"/>
                 </a:solidFill>
               </a:rPr>
-              <a:t>FinanceData_MultiTab.xlsx  |  Loans tab</a:t>
+              <a:t>Banking_LoanPortfolio.xlsx  |  Loans tab</a:t>
             </a:r>
           </a:p>
         </p:txBody>
@@ -21871,7 +21418,7 @@
                   <a:srgbClr val="3B82F6"/>
                 </a:solidFill>
               </a:rPr>
-              <a:t>$2.1M</a:t>
+              <a:t>$743.9M</a:t>
             </a:r>
           </a:p>
         </p:txBody>
@@ -21905,7 +21452,7 @@
                   <a:srgbClr val="CBD5E1"/>
                 </a:solidFill>
               </a:rPr>
-              <a:t>Total Principal</a:t>
+              <a:t>Total Outstanding</a:t>
             </a:r>
           </a:p>
         </p:txBody>
@@ -21979,10 +21526,10 @@
             <a:r>
               <a:rPr sz="1400" b="1" i="0">
                 <a:solidFill>
-                  <a:srgbClr val="6366F1"/>
-                </a:solidFill>
-              </a:rPr>
-              <a:t>$11.7K</a:t>
+                  <a:srgbClr val="EF4444"/>
+                </a:solidFill>
+              </a:rPr>
+              <a:t>34%</a:t>
             </a:r>
           </a:p>
         </p:txBody>
@@ -22016,7 +21563,7 @@
                   <a:srgbClr val="CBD5E1"/>
                 </a:solidFill>
               </a:rPr>
-              <a:t>Avg EMI</a:t>
+              <a:t>Default+Watch Rate</a:t>
             </a:r>
           </a:p>
         </p:txBody>
@@ -22090,10 +21637,10 @@
             <a:r>
               <a:rPr sz="1400" b="1" i="0">
                 <a:solidFill>
-                  <a:srgbClr val="EF4444"/>
-                </a:solidFill>
-              </a:rPr>
-              <a:t>14%</a:t>
+                  <a:srgbClr val="10B981"/>
+                </a:solidFill>
+              </a:rPr>
+              <a:t>657</a:t>
             </a:r>
           </a:p>
         </p:txBody>
@@ -22127,7 +21674,7 @@
                   <a:srgbClr val="CBD5E1"/>
                 </a:solidFill>
               </a:rPr>
-              <a:t>Default Rate</a:t>
+              <a:t>Avg Credit Score</a:t>
             </a:r>
           </a:p>
         </p:txBody>
@@ -22201,10 +21748,10 @@
             <a:r>
               <a:rPr sz="1400" b="1" i="0">
                 <a:solidFill>
-                  <a:srgbClr val="10B981"/>
-                </a:solidFill>
-              </a:rPr>
-              <a:t>742</a:t>
+                  <a:srgbClr val="F59E0B"/>
+                </a:solidFill>
+              </a:rPr>
+              <a:t>80 days</a:t>
             </a:r>
           </a:p>
         </p:txBody>
@@ -22238,7 +21785,7 @@
                   <a:srgbClr val="CBD5E1"/>
                 </a:solidFill>
               </a:rPr>
-              <a:t>Avg Credit</a:t>
+              <a:t>Avg DPD</a:t>
             </a:r>
           </a:p>
         </p:txBody>
@@ -22392,8 +21939,7 @@
                   <a:srgbClr val="CBD5E1"/>
                 </a:solidFill>
               </a:rPr>
-              <a:t>"The Loans dataset shows 180 active loans totalling $2.1M. 14% are in Default or Watch status,
-concentrated in Personal and Revolving Credit types. Customers aged 35-50 carry the highest balances."</a:t>
+              <a:t>"Banking_LoanPortfolio.xlsx / Loans shows a Default+Watch Rate of 34.0% with $743.9M total outstanding. Average credit score is 657 and average DPD is 80 days. Outliers detected in outstanding_balance and EMI — these may warrant risk escalation."</a:t>
             </a:r>
           </a:p>
         </p:txBody>
@@ -23208,7 +22754,7 @@
                   <a:srgbClr val="CBD5E1"/>
                 </a:solidFill>
               </a:rPr>
-              <a:t>Auto-computes sum, avg, min, max for every numeric column</a:t>
+              <a:t>Smart KPI engine: rate KPIs from status columns, currency totals, score averages — color-coded red/green/blue</a:t>
             </a:r>
           </a:p>
         </p:txBody>
@@ -30387,184 +29933,48 @@
         <p:spPr>
           <a:xfrm>
             <a:off x="502920" y="2039112"/>
-            <a:ext cx="3200400" cy="685800"/>
-          </a:xfrm>
-          <a:prstGeom prst="rect">
-            <a:avLst/>
-          </a:prstGeom>
-          <a:noFill/>
-        </p:spPr>
-        <p:txBody>
-          <a:bodyPr wrap="square">
-            <a:spAutoFit/>
-          </a:bodyPr>
-          <a:lstStyle/>
-          <a:p>
-            <a:pPr algn="l"/>
-            <a:r>
-              <a:rPr sz="850" b="0" i="0">
+            <a:ext cx="3200400" cy="594360"/>
+          </a:xfrm>
+          <a:prstGeom prst="rect">
+            <a:avLst/>
+          </a:prstGeom>
+          <a:noFill/>
+        </p:spPr>
+        <p:txBody>
+          <a:bodyPr wrap="square">
+            <a:spAutoFit/>
+          </a:bodyPr>
+          <a:lstStyle/>
+          <a:p>
+            <a:pPr algn="l"/>
+            <a:r>
+              <a:rPr sz="800" b="0" i="0">
                 <a:solidFill>
                   <a:srgbClr val="CBD5E1"/>
                 </a:solidFill>
               </a:rPr>
-              <a:t>Upload loan portfolio data. Instantly identify default-risk customers (DPD &gt; 60),
-outstanding balance concentration, and collateral coverage gaps.</a:t>
-            </a:r>
-          </a:p>
-        </p:txBody>
-      </p:sp>
-      <p:sp>
-        <p:nvSpPr>
-          <p:cNvPr id="14" name="TextBox 13"/>
-          <p:cNvSpPr txBox="1"/>
-          <p:nvPr/>
-        </p:nvSpPr>
-        <p:spPr>
-          <a:xfrm>
-            <a:off x="3840480" y="1709928"/>
-            <a:ext cx="2011680" cy="384048"/>
-          </a:xfrm>
-          <a:prstGeom prst="rect">
-            <a:avLst/>
-          </a:prstGeom>
-          <a:noFill/>
-        </p:spPr>
-        <p:txBody>
-          <a:bodyPr wrap="square">
-            <a:spAutoFit/>
-          </a:bodyPr>
-          <a:lstStyle/>
-          <a:p>
-            <a:pPr algn="l"/>
-            <a:r>
-              <a:rPr sz="800" b="0" i="0">
-                <a:solidFill>
-                  <a:srgbClr val="3B82F6"/>
-                </a:solidFill>
-              </a:rPr>
-              <a:t>-&gt; Loan default prediction</a:t>
-            </a:r>
-          </a:p>
-        </p:txBody>
-      </p:sp>
-      <p:sp>
-        <p:nvSpPr>
-          <p:cNvPr id="15" name="TextBox 14"/>
-          <p:cNvSpPr txBox="1"/>
-          <p:nvPr/>
-        </p:nvSpPr>
-        <p:spPr>
-          <a:xfrm>
-            <a:off x="3840480" y="2139696"/>
-            <a:ext cx="2011680" cy="384048"/>
-          </a:xfrm>
-          <a:prstGeom prst="rect">
-            <a:avLst/>
-          </a:prstGeom>
-          <a:noFill/>
-        </p:spPr>
-        <p:txBody>
-          <a:bodyPr wrap="square">
-            <a:spAutoFit/>
-          </a:bodyPr>
-          <a:lstStyle/>
-          <a:p>
-            <a:pPr algn="l"/>
-            <a:r>
-              <a:rPr sz="800" b="0" i="0">
-                <a:solidFill>
-                  <a:srgbClr val="3B82F6"/>
-                </a:solidFill>
-              </a:rPr>
-              <a:t>-&gt; Portfolio concentration risk</a:t>
-            </a:r>
-          </a:p>
-        </p:txBody>
-      </p:sp>
-      <p:sp>
-        <p:nvSpPr>
-          <p:cNvPr id="16" name="TextBox 15"/>
-          <p:cNvSpPr txBox="1"/>
-          <p:nvPr/>
-        </p:nvSpPr>
-        <p:spPr>
-          <a:xfrm>
-            <a:off x="3840480" y="2569464"/>
-            <a:ext cx="2011680" cy="384048"/>
-          </a:xfrm>
-          <a:prstGeom prst="rect">
-            <a:avLst/>
-          </a:prstGeom>
-          <a:noFill/>
-        </p:spPr>
-        <p:txBody>
-          <a:bodyPr wrap="square">
-            <a:spAutoFit/>
-          </a:bodyPr>
-          <a:lstStyle/>
-          <a:p>
-            <a:pPr algn="l"/>
-            <a:r>
-              <a:rPr sz="800" b="0" i="0">
-                <a:solidFill>
-                  <a:srgbClr val="3B82F6"/>
-                </a:solidFill>
-              </a:rPr>
-              <a:t>-&gt; Credit score distribution</a:t>
-            </a:r>
-          </a:p>
-        </p:txBody>
-      </p:sp>
-      <p:sp>
-        <p:nvSpPr>
-          <p:cNvPr id="17" name="TextBox 16"/>
-          <p:cNvSpPr txBox="1"/>
-          <p:nvPr/>
-        </p:nvSpPr>
-        <p:spPr>
-          <a:xfrm>
-            <a:off x="3840480" y="2999232"/>
-            <a:ext cx="2011680" cy="384048"/>
-          </a:xfrm>
-          <a:prstGeom prst="rect">
-            <a:avLst/>
-          </a:prstGeom>
-          <a:noFill/>
-        </p:spPr>
-        <p:txBody>
-          <a:bodyPr wrap="square">
-            <a:spAutoFit/>
-          </a:bodyPr>
-          <a:lstStyle/>
-          <a:p>
-            <a:pPr algn="l"/>
-            <a:r>
-              <a:rPr sz="800" b="0" i="0">
-                <a:solidFill>
-                  <a:srgbClr val="3B82F6"/>
-                </a:solidFill>
-              </a:rPr>
-              <a:t>-&gt; Cross-tab: loan type vs status</a:t>
-            </a:r>
-          </a:p>
-        </p:txBody>
-      </p:sp>
-      <p:sp>
-        <p:nvSpPr>
-          <p:cNvPr id="18" name="Rectangle 17"/>
+              <a:t>Upload Banking_LoanPortfolio.xlsx (5 tabs, 1,820 rows). Instantly identify
+default-risk customers, outstanding balance concentration, and DPD trends.</a:t>
+            </a:r>
+          </a:p>
+        </p:txBody>
+      </p:sp>
+      <p:sp>
+        <p:nvSpPr>
+          <p:cNvPr id="14" name="Rectangle 13"/>
           <p:cNvSpPr/>
           <p:nvPr/>
         </p:nvSpPr>
         <p:spPr>
           <a:xfrm>
-            <a:off x="6217920" y="1143000"/>
-            <a:ext cx="5577840" cy="2514600"/>
-          </a:xfrm>
-          <a:prstGeom prst="rect">
-            <a:avLst/>
-          </a:prstGeom>
-          <a:solidFill>
-            <a:srgbClr val="1E293B"/>
+            <a:off x="502920" y="2715768"/>
+            <a:ext cx="1645920" cy="658368"/>
+          </a:xfrm>
+          <a:prstGeom prst="rect">
+            <a:avLst/>
+          </a:prstGeom>
+          <a:solidFill>
+            <a:srgbClr val="060B18"/>
           </a:solidFill>
           <a:ln>
             <a:noFill/>
@@ -30594,20 +30004,88 @@
       </p:sp>
       <p:sp>
         <p:nvSpPr>
-          <p:cNvPr id="19" name="Rectangle 18"/>
+          <p:cNvPr id="15" name="TextBox 14"/>
+          <p:cNvSpPr txBox="1"/>
+          <p:nvPr/>
+        </p:nvSpPr>
+        <p:spPr>
+          <a:xfrm>
+            <a:off x="576072" y="2752344"/>
+            <a:ext cx="1508760" cy="310896"/>
+          </a:xfrm>
+          <a:prstGeom prst="rect">
+            <a:avLst/>
+          </a:prstGeom>
+          <a:noFill/>
+        </p:spPr>
+        <p:txBody>
+          <a:bodyPr wrap="square">
+            <a:spAutoFit/>
+          </a:bodyPr>
+          <a:lstStyle/>
+          <a:p>
+            <a:pPr algn="l"/>
+            <a:r>
+              <a:rPr sz="1300" b="1" i="0">
+                <a:solidFill>
+                  <a:srgbClr val="EF4444"/>
+                </a:solidFill>
+              </a:rPr>
+              <a:t>34%</a:t>
+            </a:r>
+          </a:p>
+        </p:txBody>
+      </p:sp>
+      <p:sp>
+        <p:nvSpPr>
+          <p:cNvPr id="16" name="TextBox 15"/>
+          <p:cNvSpPr txBox="1"/>
+          <p:nvPr/>
+        </p:nvSpPr>
+        <p:spPr>
+          <a:xfrm>
+            <a:off x="576072" y="3044952"/>
+            <a:ext cx="1508760" cy="256032"/>
+          </a:xfrm>
+          <a:prstGeom prst="rect">
+            <a:avLst/>
+          </a:prstGeom>
+          <a:noFill/>
+        </p:spPr>
+        <p:txBody>
+          <a:bodyPr wrap="square">
+            <a:spAutoFit/>
+          </a:bodyPr>
+          <a:lstStyle/>
+          <a:p>
+            <a:pPr algn="l"/>
+            <a:r>
+              <a:rPr sz="700" b="0" i="0">
+                <a:solidFill>
+                  <a:srgbClr val="CBD5E1"/>
+                </a:solidFill>
+              </a:rPr>
+              <a:t>Default+Watch</a:t>
+            </a:r>
+          </a:p>
+        </p:txBody>
+      </p:sp>
+      <p:sp>
+        <p:nvSpPr>
+          <p:cNvPr id="17" name="Rectangle 16"/>
           <p:cNvSpPr/>
           <p:nvPr/>
         </p:nvSpPr>
         <p:spPr>
           <a:xfrm>
-            <a:off x="6217920" y="1143000"/>
-            <a:ext cx="5577840" cy="45720"/>
-          </a:xfrm>
-          <a:prstGeom prst="rect">
-            <a:avLst/>
-          </a:prstGeom>
-          <a:solidFill>
-            <a:srgbClr val="10B981"/>
+            <a:off x="2286000" y="2715768"/>
+            <a:ext cx="1645920" cy="658368"/>
+          </a:xfrm>
+          <a:prstGeom prst="rect">
+            <a:avLst/>
+          </a:prstGeom>
+          <a:solidFill>
+            <a:srgbClr val="060B18"/>
           </a:solidFill>
           <a:ln>
             <a:noFill/>
@@ -30637,14 +30115,82 @@
       </p:sp>
       <p:sp>
         <p:nvSpPr>
+          <p:cNvPr id="18" name="TextBox 17"/>
+          <p:cNvSpPr txBox="1"/>
+          <p:nvPr/>
+        </p:nvSpPr>
+        <p:spPr>
+          <a:xfrm>
+            <a:off x="2359152" y="2752344"/>
+            <a:ext cx="1508760" cy="310896"/>
+          </a:xfrm>
+          <a:prstGeom prst="rect">
+            <a:avLst/>
+          </a:prstGeom>
+          <a:noFill/>
+        </p:spPr>
+        <p:txBody>
+          <a:bodyPr wrap="square">
+            <a:spAutoFit/>
+          </a:bodyPr>
+          <a:lstStyle/>
+          <a:p>
+            <a:pPr algn="l"/>
+            <a:r>
+              <a:rPr sz="1300" b="1" i="0">
+                <a:solidFill>
+                  <a:srgbClr val="3B82F6"/>
+                </a:solidFill>
+              </a:rPr>
+              <a:t>$743.9M</a:t>
+            </a:r>
+          </a:p>
+        </p:txBody>
+      </p:sp>
+      <p:sp>
+        <p:nvSpPr>
+          <p:cNvPr id="19" name="TextBox 18"/>
+          <p:cNvSpPr txBox="1"/>
+          <p:nvPr/>
+        </p:nvSpPr>
+        <p:spPr>
+          <a:xfrm>
+            <a:off x="2359152" y="3044952"/>
+            <a:ext cx="1508760" cy="256032"/>
+          </a:xfrm>
+          <a:prstGeom prst="rect">
+            <a:avLst/>
+          </a:prstGeom>
+          <a:noFill/>
+        </p:spPr>
+        <p:txBody>
+          <a:bodyPr wrap="square">
+            <a:spAutoFit/>
+          </a:bodyPr>
+          <a:lstStyle/>
+          <a:p>
+            <a:pPr algn="l"/>
+            <a:r>
+              <a:rPr sz="700" b="0" i="0">
+                <a:solidFill>
+                  <a:srgbClr val="CBD5E1"/>
+                </a:solidFill>
+              </a:rPr>
+              <a:t>Outstanding</a:t>
+            </a:r>
+          </a:p>
+        </p:txBody>
+      </p:sp>
+      <p:sp>
+        <p:nvSpPr>
           <p:cNvPr id="20" name="Rectangle 19"/>
           <p:cNvSpPr/>
           <p:nvPr/>
         </p:nvSpPr>
         <p:spPr>
           <a:xfrm>
-            <a:off x="6309360" y="1252728"/>
-            <a:ext cx="2286000" cy="347472"/>
+            <a:off x="4069080" y="2715768"/>
+            <a:ext cx="1645920" cy="658368"/>
           </a:xfrm>
           <a:prstGeom prst="rect">
             <a:avLst/>
@@ -30686,28 +30232,28 @@
         </p:nvSpPr>
         <p:spPr>
           <a:xfrm>
-            <a:off x="6355080" y="1271016"/>
-            <a:ext cx="2194560" cy="310896"/>
-          </a:xfrm>
-          <a:prstGeom prst="rect">
-            <a:avLst/>
-          </a:prstGeom>
-          <a:noFill/>
-        </p:spPr>
-        <p:txBody>
-          <a:bodyPr wrap="square">
-            <a:spAutoFit/>
-          </a:bodyPr>
-          <a:lstStyle/>
-          <a:p>
-            <a:pPr algn="ctr"/>
-            <a:r>
-              <a:rPr sz="800" b="1" i="0">
+            <a:off x="4142232" y="2752344"/>
+            <a:ext cx="1508760" cy="310896"/>
+          </a:xfrm>
+          <a:prstGeom prst="rect">
+            <a:avLst/>
+          </a:prstGeom>
+          <a:noFill/>
+        </p:spPr>
+        <p:txBody>
+          <a:bodyPr wrap="square">
+            <a:spAutoFit/>
+          </a:bodyPr>
+          <a:lstStyle/>
+          <a:p>
+            <a:pPr algn="l"/>
+            <a:r>
+              <a:rPr sz="1300" b="1" i="0">
                 <a:solidFill>
                   <a:srgbClr val="10B981"/>
                 </a:solidFill>
               </a:rPr>
-              <a:t>Insurance</a:t>
+              <a:t>657</a:t>
             </a:r>
           </a:p>
         </p:txBody>
@@ -30720,28 +30266,28 @@
         </p:nvSpPr>
         <p:spPr>
           <a:xfrm>
-            <a:off x="6355080" y="1691640"/>
-            <a:ext cx="5303520" cy="320040"/>
-          </a:xfrm>
-          <a:prstGeom prst="rect">
-            <a:avLst/>
-          </a:prstGeom>
-          <a:noFill/>
-        </p:spPr>
-        <p:txBody>
-          <a:bodyPr wrap="square">
-            <a:spAutoFit/>
-          </a:bodyPr>
-          <a:lstStyle/>
-          <a:p>
-            <a:pPr algn="l"/>
-            <a:r>
-              <a:rPr sz="1300" b="1" i="0">
-                <a:solidFill>
-                  <a:srgbClr val="FFFFFF"/>
-                </a:solidFill>
-              </a:rPr>
-              <a:t>Claims Analytics</a:t>
+            <a:off x="4142232" y="3044952"/>
+            <a:ext cx="1508760" cy="256032"/>
+          </a:xfrm>
+          <a:prstGeom prst="rect">
+            <a:avLst/>
+          </a:prstGeom>
+          <a:noFill/>
+        </p:spPr>
+        <p:txBody>
+          <a:bodyPr wrap="square">
+            <a:spAutoFit/>
+          </a:bodyPr>
+          <a:lstStyle/>
+          <a:p>
+            <a:pPr algn="l"/>
+            <a:r>
+              <a:rPr sz="700" b="0" i="0">
+                <a:solidFill>
+                  <a:srgbClr val="CBD5E1"/>
+                </a:solidFill>
+              </a:rPr>
+              <a:t>Avg Credit</a:t>
             </a:r>
           </a:p>
         </p:txBody>
@@ -30754,29 +30300,28 @@
         </p:nvSpPr>
         <p:spPr>
           <a:xfrm>
-            <a:off x="6355080" y="2039112"/>
-            <a:ext cx="3200400" cy="685800"/>
-          </a:xfrm>
-          <a:prstGeom prst="rect">
-            <a:avLst/>
-          </a:prstGeom>
-          <a:noFill/>
-        </p:spPr>
-        <p:txBody>
-          <a:bodyPr wrap="square">
-            <a:spAutoFit/>
-          </a:bodyPr>
-          <a:lstStyle/>
-          <a:p>
-            <a:pPr algn="l"/>
-            <a:r>
-              <a:rPr sz="850" b="0" i="0">
-                <a:solidFill>
-                  <a:srgbClr val="CBD5E1"/>
-                </a:solidFill>
-              </a:rPr>
-              <a:t>Analyze claims history CSV. Spot high-frequency claimants, fraud indicators,
-and seasonal patterns without any SQL or BI tool setup.</a:t>
+            <a:off x="3840480" y="1709928"/>
+            <a:ext cx="2011680" cy="384048"/>
+          </a:xfrm>
+          <a:prstGeom prst="rect">
+            <a:avLst/>
+          </a:prstGeom>
+          <a:noFill/>
+        </p:spPr>
+        <p:txBody>
+          <a:bodyPr wrap="square">
+            <a:spAutoFit/>
+          </a:bodyPr>
+          <a:lstStyle/>
+          <a:p>
+            <a:pPr algn="l"/>
+            <a:r>
+              <a:rPr sz="750" b="0" i="0">
+                <a:solidFill>
+                  <a:srgbClr val="3B82F6"/>
+                </a:solidFill>
+              </a:rPr>
+              <a:t>-&gt; 34% Default+Watch Rate detected</a:t>
             </a:r>
           </a:p>
         </p:txBody>
@@ -30789,7 +30334,7 @@
         </p:nvSpPr>
         <p:spPr>
           <a:xfrm>
-            <a:off x="9692640" y="1709928"/>
+            <a:off x="3840480" y="2139696"/>
             <a:ext cx="2011680" cy="384048"/>
           </a:xfrm>
           <a:prstGeom prst="rect">
@@ -30805,12 +30350,12 @@
           <a:p>
             <a:pPr algn="l"/>
             <a:r>
-              <a:rPr sz="800" b="0" i="0">
-                <a:solidFill>
-                  <a:srgbClr val="10B981"/>
-                </a:solidFill>
-              </a:rPr>
-              <a:t>-&gt; High-value claims table</a:t>
+              <a:rPr sz="750" b="0" i="0">
+                <a:solidFill>
+                  <a:srgbClr val="3B82F6"/>
+                </a:solidFill>
+              </a:rPr>
+              <a:t>-&gt; Portfolio concentration risk</a:t>
             </a:r>
           </a:p>
         </p:txBody>
@@ -30823,7 +30368,7 @@
         </p:nvSpPr>
         <p:spPr>
           <a:xfrm>
-            <a:off x="9692640" y="2139696"/>
+            <a:off x="3840480" y="2569464"/>
             <a:ext cx="2011680" cy="384048"/>
           </a:xfrm>
           <a:prstGeom prst="rect">
@@ -30839,12 +30384,12 @@
           <a:p>
             <a:pPr algn="l"/>
             <a:r>
-              <a:rPr sz="800" b="0" i="0">
-                <a:solidFill>
-                  <a:srgbClr val="10B981"/>
-                </a:solidFill>
-              </a:rPr>
-              <a:t>-&gt; Fraud pattern detection</a:t>
+              <a:rPr sz="750" b="0" i="0">
+                <a:solidFill>
+                  <a:srgbClr val="3B82F6"/>
+                </a:solidFill>
+              </a:rPr>
+              <a:t>-&gt; Credit score distribution</a:t>
             </a:r>
           </a:p>
         </p:txBody>
@@ -30857,7 +30402,7 @@
         </p:nvSpPr>
         <p:spPr>
           <a:xfrm>
-            <a:off x="9692640" y="2569464"/>
+            <a:off x="3840480" y="2999232"/>
             <a:ext cx="2011680" cy="384048"/>
           </a:xfrm>
           <a:prstGeom prst="rect">
@@ -30873,59 +30418,25 @@
           <a:p>
             <a:pPr algn="l"/>
             <a:r>
-              <a:rPr sz="800" b="0" i="0">
-                <a:solidFill>
-                  <a:srgbClr val="10B981"/>
-                </a:solidFill>
-              </a:rPr>
-              <a:t>-&gt; Regional claim frequency</a:t>
-            </a:r>
-          </a:p>
-        </p:txBody>
-      </p:sp>
-      <p:sp>
-        <p:nvSpPr>
-          <p:cNvPr id="27" name="TextBox 26"/>
-          <p:cNvSpPr txBox="1"/>
-          <p:nvPr/>
-        </p:nvSpPr>
-        <p:spPr>
-          <a:xfrm>
-            <a:off x="9692640" y="2999232"/>
-            <a:ext cx="2011680" cy="384048"/>
-          </a:xfrm>
-          <a:prstGeom prst="rect">
-            <a:avLst/>
-          </a:prstGeom>
-          <a:noFill/>
-        </p:spPr>
-        <p:txBody>
-          <a:bodyPr wrap="square">
-            <a:spAutoFit/>
-          </a:bodyPr>
-          <a:lstStyle/>
-          <a:p>
-            <a:pPr algn="l"/>
-            <a:r>
-              <a:rPr sz="800" b="0" i="0">
-                <a:solidFill>
-                  <a:srgbClr val="10B981"/>
-                </a:solidFill>
-              </a:rPr>
-              <a:t>-&gt; Policy type breakdown</a:t>
-            </a:r>
-          </a:p>
-        </p:txBody>
-      </p:sp>
-      <p:sp>
-        <p:nvSpPr>
-          <p:cNvPr id="28" name="Rectangle 27"/>
+              <a:rPr sz="750" b="0" i="0">
+                <a:solidFill>
+                  <a:srgbClr val="3B82F6"/>
+                </a:solidFill>
+              </a:rPr>
+              <a:t>-&gt; Cross-tab: loan type vs status</a:t>
+            </a:r>
+          </a:p>
+        </p:txBody>
+      </p:sp>
+      <p:sp>
+        <p:nvSpPr>
+          <p:cNvPr id="27" name="Rectangle 26"/>
           <p:cNvSpPr/>
           <p:nvPr/>
         </p:nvSpPr>
         <p:spPr>
           <a:xfrm>
-            <a:off x="365760" y="3840480"/>
+            <a:off x="6217920" y="1143000"/>
             <a:ext cx="5577840" cy="2514600"/>
           </a:xfrm>
           <a:prstGeom prst="rect">
@@ -30962,20 +30473,20 @@
       </p:sp>
       <p:sp>
         <p:nvSpPr>
-          <p:cNvPr id="29" name="Rectangle 28"/>
+          <p:cNvPr id="28" name="Rectangle 27"/>
           <p:cNvSpPr/>
           <p:nvPr/>
         </p:nvSpPr>
         <p:spPr>
           <a:xfrm>
-            <a:off x="365760" y="3840480"/>
+            <a:off x="6217920" y="1143000"/>
             <a:ext cx="5577840" cy="45720"/>
           </a:xfrm>
           <a:prstGeom prst="rect">
             <a:avLst/>
           </a:prstGeom>
           <a:solidFill>
-            <a:srgbClr val="6366F1"/>
+            <a:srgbClr val="10B981"/>
           </a:solidFill>
           <a:ln>
             <a:noFill/>
@@ -31005,13 +30516,13 @@
       </p:sp>
       <p:sp>
         <p:nvSpPr>
-          <p:cNvPr id="30" name="Rectangle 29"/>
+          <p:cNvPr id="29" name="Rectangle 28"/>
           <p:cNvSpPr/>
           <p:nvPr/>
         </p:nvSpPr>
         <p:spPr>
           <a:xfrm>
-            <a:off x="457200" y="3950208"/>
+            <a:off x="6309360" y="1252728"/>
             <a:ext cx="2286000" cy="347472"/>
           </a:xfrm>
           <a:prstGeom prst="rect">
@@ -31048,34 +30559,68 @@
       </p:sp>
       <p:sp>
         <p:nvSpPr>
+          <p:cNvPr id="30" name="TextBox 29"/>
+          <p:cNvSpPr txBox="1"/>
+          <p:nvPr/>
+        </p:nvSpPr>
+        <p:spPr>
+          <a:xfrm>
+            <a:off x="6355080" y="1271016"/>
+            <a:ext cx="2194560" cy="310896"/>
+          </a:xfrm>
+          <a:prstGeom prst="rect">
+            <a:avLst/>
+          </a:prstGeom>
+          <a:noFill/>
+        </p:spPr>
+        <p:txBody>
+          <a:bodyPr wrap="square">
+            <a:spAutoFit/>
+          </a:bodyPr>
+          <a:lstStyle/>
+          <a:p>
+            <a:pPr algn="ctr"/>
+            <a:r>
+              <a:rPr sz="800" b="1" i="0">
+                <a:solidFill>
+                  <a:srgbClr val="10B981"/>
+                </a:solidFill>
+              </a:rPr>
+              <a:t>Insurance</a:t>
+            </a:r>
+          </a:p>
+        </p:txBody>
+      </p:sp>
+      <p:sp>
+        <p:nvSpPr>
           <p:cNvPr id="31" name="TextBox 30"/>
           <p:cNvSpPr txBox="1"/>
           <p:nvPr/>
         </p:nvSpPr>
         <p:spPr>
           <a:xfrm>
-            <a:off x="502920" y="3968496"/>
-            <a:ext cx="2194560" cy="310896"/>
-          </a:xfrm>
-          <a:prstGeom prst="rect">
-            <a:avLst/>
-          </a:prstGeom>
-          <a:noFill/>
-        </p:spPr>
-        <p:txBody>
-          <a:bodyPr wrap="square">
-            <a:spAutoFit/>
-          </a:bodyPr>
-          <a:lstStyle/>
-          <a:p>
-            <a:pPr algn="ctr"/>
-            <a:r>
-              <a:rPr sz="800" b="1" i="0">
-                <a:solidFill>
-                  <a:srgbClr val="6366F1"/>
-                </a:solidFill>
-              </a:rPr>
-              <a:t>Retail &amp; E-Commerce</a:t>
+            <a:off x="6355080" y="1691640"/>
+            <a:ext cx="5303520" cy="320040"/>
+          </a:xfrm>
+          <a:prstGeom prst="rect">
+            <a:avLst/>
+          </a:prstGeom>
+          <a:noFill/>
+        </p:spPr>
+        <p:txBody>
+          <a:bodyPr wrap="square">
+            <a:spAutoFit/>
+          </a:bodyPr>
+          <a:lstStyle/>
+          <a:p>
+            <a:pPr algn="l"/>
+            <a:r>
+              <a:rPr sz="1300" b="1" i="0">
+                <a:solidFill>
+                  <a:srgbClr val="FFFFFF"/>
+                </a:solidFill>
+              </a:rPr>
+              <a:t>Claims Analytics</a:t>
             </a:r>
           </a:p>
         </p:txBody>
@@ -31088,219 +30633,49 @@
         </p:nvSpPr>
         <p:spPr>
           <a:xfrm>
-            <a:off x="502920" y="4389120"/>
-            <a:ext cx="5303520" cy="320040"/>
-          </a:xfrm>
-          <a:prstGeom prst="rect">
-            <a:avLst/>
-          </a:prstGeom>
-          <a:noFill/>
-        </p:spPr>
-        <p:txBody>
-          <a:bodyPr wrap="square">
-            <a:spAutoFit/>
-          </a:bodyPr>
-          <a:lstStyle/>
-          <a:p>
-            <a:pPr algn="l"/>
-            <a:r>
-              <a:rPr sz="1300" b="1" i="0">
-                <a:solidFill>
-                  <a:srgbClr val="FFFFFF"/>
-                </a:solidFill>
-              </a:rPr>
-              <a:t>Sales Performance</a:t>
-            </a:r>
-          </a:p>
-        </p:txBody>
-      </p:sp>
-      <p:sp>
-        <p:nvSpPr>
-          <p:cNvPr id="33" name="TextBox 32"/>
-          <p:cNvSpPr txBox="1"/>
-          <p:nvPr/>
-        </p:nvSpPr>
-        <p:spPr>
-          <a:xfrm>
-            <a:off x="502920" y="4736592"/>
-            <a:ext cx="3200400" cy="685800"/>
-          </a:xfrm>
-          <a:prstGeom prst="rect">
-            <a:avLst/>
-          </a:prstGeom>
-          <a:noFill/>
-        </p:spPr>
-        <p:txBody>
-          <a:bodyPr wrap="square">
-            <a:spAutoFit/>
-          </a:bodyPr>
-          <a:lstStyle/>
-          <a:p>
-            <a:pPr algn="l"/>
-            <a:r>
-              <a:rPr sz="850" b="0" i="0">
+            <a:off x="6355080" y="2039112"/>
+            <a:ext cx="3200400" cy="594360"/>
+          </a:xfrm>
+          <a:prstGeom prst="rect">
+            <a:avLst/>
+          </a:prstGeom>
+          <a:noFill/>
+        </p:spPr>
+        <p:txBody>
+          <a:bodyPr wrap="square">
+            <a:spAutoFit/>
+          </a:bodyPr>
+          <a:lstStyle/>
+          <a:p>
+            <a:pPr algn="l"/>
+            <a:r>
+              <a:rPr sz="800" b="0" i="0">
                 <a:solidFill>
                   <a:srgbClr val="CBD5E1"/>
                 </a:solidFill>
               </a:rPr>
-              <a:t>Drop in monthly sales Excel. Get instant revenue KPIs, top/bottom product
-performers, regional breakdowns, and AI-written executive summary.</a:t>
-            </a:r>
-          </a:p>
-        </p:txBody>
-      </p:sp>
-      <p:sp>
-        <p:nvSpPr>
-          <p:cNvPr id="34" name="TextBox 33"/>
-          <p:cNvSpPr txBox="1"/>
-          <p:nvPr/>
-        </p:nvSpPr>
-        <p:spPr>
-          <a:xfrm>
-            <a:off x="3840480" y="4407408"/>
-            <a:ext cx="2011680" cy="384048"/>
-          </a:xfrm>
-          <a:prstGeom prst="rect">
-            <a:avLst/>
-          </a:prstGeom>
-          <a:noFill/>
-        </p:spPr>
-        <p:txBody>
-          <a:bodyPr wrap="square">
-            <a:spAutoFit/>
-          </a:bodyPr>
-          <a:lstStyle/>
-          <a:p>
-            <a:pPr algn="l"/>
-            <a:r>
-              <a:rPr sz="800" b="0" i="0">
-                <a:solidFill>
-                  <a:srgbClr val="6366F1"/>
-                </a:solidFill>
-              </a:rPr>
-              <a:t>-&gt; Top 10 products by revenue</a:t>
-            </a:r>
-          </a:p>
-        </p:txBody>
-      </p:sp>
-      <p:sp>
-        <p:nvSpPr>
-          <p:cNvPr id="35" name="TextBox 34"/>
-          <p:cNvSpPr txBox="1"/>
-          <p:nvPr/>
-        </p:nvSpPr>
-        <p:spPr>
-          <a:xfrm>
-            <a:off x="3840480" y="4837176"/>
-            <a:ext cx="2011680" cy="384048"/>
-          </a:xfrm>
-          <a:prstGeom prst="rect">
-            <a:avLst/>
-          </a:prstGeom>
-          <a:noFill/>
-        </p:spPr>
-        <p:txBody>
-          <a:bodyPr wrap="square">
-            <a:spAutoFit/>
-          </a:bodyPr>
-          <a:lstStyle/>
-          <a:p>
-            <a:pPr algn="l"/>
-            <a:r>
-              <a:rPr sz="800" b="0" i="0">
-                <a:solidFill>
-                  <a:srgbClr val="6366F1"/>
-                </a:solidFill>
-              </a:rPr>
-              <a:t>-&gt; Region vs category cross-tab</a:t>
-            </a:r>
-          </a:p>
-        </p:txBody>
-      </p:sp>
-      <p:sp>
-        <p:nvSpPr>
-          <p:cNvPr id="36" name="TextBox 35"/>
-          <p:cNvSpPr txBox="1"/>
-          <p:nvPr/>
-        </p:nvSpPr>
-        <p:spPr>
-          <a:xfrm>
-            <a:off x="3840480" y="5266944"/>
-            <a:ext cx="2011680" cy="384048"/>
-          </a:xfrm>
-          <a:prstGeom prst="rect">
-            <a:avLst/>
-          </a:prstGeom>
-          <a:noFill/>
-        </p:spPr>
-        <p:txBody>
-          <a:bodyPr wrap="square">
-            <a:spAutoFit/>
-          </a:bodyPr>
-          <a:lstStyle/>
-          <a:p>
-            <a:pPr algn="l"/>
-            <a:r>
-              <a:rPr sz="800" b="0" i="0">
-                <a:solidFill>
-                  <a:srgbClr val="6366F1"/>
-                </a:solidFill>
-              </a:rPr>
-              <a:t>-&gt; Return rate outliers</a:t>
-            </a:r>
-          </a:p>
-        </p:txBody>
-      </p:sp>
-      <p:sp>
-        <p:nvSpPr>
-          <p:cNvPr id="37" name="TextBox 36"/>
-          <p:cNvSpPr txBox="1"/>
-          <p:nvPr/>
-        </p:nvSpPr>
-        <p:spPr>
-          <a:xfrm>
-            <a:off x="3840480" y="5696712"/>
-            <a:ext cx="2011680" cy="384048"/>
-          </a:xfrm>
-          <a:prstGeom prst="rect">
-            <a:avLst/>
-          </a:prstGeom>
-          <a:noFill/>
-        </p:spPr>
-        <p:txBody>
-          <a:bodyPr wrap="square">
-            <a:spAutoFit/>
-          </a:bodyPr>
-          <a:lstStyle/>
-          <a:p>
-            <a:pPr algn="l"/>
-            <a:r>
-              <a:rPr sz="800" b="0" i="0">
-                <a:solidFill>
-                  <a:srgbClr val="6366F1"/>
-                </a:solidFill>
-              </a:rPr>
-              <a:t>-&gt; Month-over-month trend</a:t>
-            </a:r>
-          </a:p>
-        </p:txBody>
-      </p:sp>
-      <p:sp>
-        <p:nvSpPr>
-          <p:cNvPr id="38" name="Rectangle 37"/>
+              <a:t>Analyze Insurance_Claims.xlsx (4 tabs, 1,230 rows). Spot high-frequency
+claimants, fraud indicators, and seasonal patterns without any SQL.</a:t>
+            </a:r>
+          </a:p>
+        </p:txBody>
+      </p:sp>
+      <p:sp>
+        <p:nvSpPr>
+          <p:cNvPr id="33" name="Rectangle 32"/>
           <p:cNvSpPr/>
           <p:nvPr/>
         </p:nvSpPr>
         <p:spPr>
           <a:xfrm>
-            <a:off x="6217920" y="3840480"/>
-            <a:ext cx="5577840" cy="2514600"/>
-          </a:xfrm>
-          <a:prstGeom prst="rect">
-            <a:avLst/>
-          </a:prstGeom>
-          <a:solidFill>
-            <a:srgbClr val="1E293B"/>
+            <a:off x="6355080" y="2715768"/>
+            <a:ext cx="1645920" cy="658368"/>
+          </a:xfrm>
+          <a:prstGeom prst="rect">
+            <a:avLst/>
+          </a:prstGeom>
+          <a:solidFill>
+            <a:srgbClr val="060B18"/>
           </a:solidFill>
           <a:ln>
             <a:noFill/>
@@ -31330,20 +30705,88 @@
       </p:sp>
       <p:sp>
         <p:nvSpPr>
-          <p:cNvPr id="39" name="Rectangle 38"/>
+          <p:cNvPr id="34" name="TextBox 33"/>
+          <p:cNvSpPr txBox="1"/>
+          <p:nvPr/>
+        </p:nvSpPr>
+        <p:spPr>
+          <a:xfrm>
+            <a:off x="6428232" y="2752344"/>
+            <a:ext cx="1508760" cy="310896"/>
+          </a:xfrm>
+          <a:prstGeom prst="rect">
+            <a:avLst/>
+          </a:prstGeom>
+          <a:noFill/>
+        </p:spPr>
+        <p:txBody>
+          <a:bodyPr wrap="square">
+            <a:spAutoFit/>
+          </a:bodyPr>
+          <a:lstStyle/>
+          <a:p>
+            <a:pPr algn="l"/>
+            <a:r>
+              <a:rPr sz="1300" b="1" i="0">
+                <a:solidFill>
+                  <a:srgbClr val="EF4444"/>
+                </a:solidFill>
+              </a:rPr>
+              <a:t>40%</a:t>
+            </a:r>
+          </a:p>
+        </p:txBody>
+      </p:sp>
+      <p:sp>
+        <p:nvSpPr>
+          <p:cNvPr id="35" name="TextBox 34"/>
+          <p:cNvSpPr txBox="1"/>
+          <p:nvPr/>
+        </p:nvSpPr>
+        <p:spPr>
+          <a:xfrm>
+            <a:off x="6428232" y="3044952"/>
+            <a:ext cx="1508760" cy="256032"/>
+          </a:xfrm>
+          <a:prstGeom prst="rect">
+            <a:avLst/>
+          </a:prstGeom>
+          <a:noFill/>
+        </p:spPr>
+        <p:txBody>
+          <a:bodyPr wrap="square">
+            <a:spAutoFit/>
+          </a:bodyPr>
+          <a:lstStyle/>
+          <a:p>
+            <a:pPr algn="l"/>
+            <a:r>
+              <a:rPr sz="700" b="0" i="0">
+                <a:solidFill>
+                  <a:srgbClr val="CBD5E1"/>
+                </a:solidFill>
+              </a:rPr>
+              <a:t>Fraud Flagged</a:t>
+            </a:r>
+          </a:p>
+        </p:txBody>
+      </p:sp>
+      <p:sp>
+        <p:nvSpPr>
+          <p:cNvPr id="36" name="Rectangle 35"/>
           <p:cNvSpPr/>
           <p:nvPr/>
         </p:nvSpPr>
         <p:spPr>
           <a:xfrm>
-            <a:off x="6217920" y="3840480"/>
-            <a:ext cx="5577840" cy="45720"/>
-          </a:xfrm>
-          <a:prstGeom prst="rect">
-            <a:avLst/>
-          </a:prstGeom>
-          <a:solidFill>
-            <a:srgbClr val="F59E0B"/>
+            <a:off x="8138160" y="2715768"/>
+            <a:ext cx="1645920" cy="658368"/>
+          </a:xfrm>
+          <a:prstGeom prst="rect">
+            <a:avLst/>
+          </a:prstGeom>
+          <a:solidFill>
+            <a:srgbClr val="060B18"/>
           </a:solidFill>
           <a:ln>
             <a:noFill/>
@@ -31373,14 +30816,82 @@
       </p:sp>
       <p:sp>
         <p:nvSpPr>
-          <p:cNvPr id="40" name="Rectangle 39"/>
+          <p:cNvPr id="37" name="TextBox 36"/>
+          <p:cNvSpPr txBox="1"/>
+          <p:nvPr/>
+        </p:nvSpPr>
+        <p:spPr>
+          <a:xfrm>
+            <a:off x="8211312" y="2752344"/>
+            <a:ext cx="1508760" cy="310896"/>
+          </a:xfrm>
+          <a:prstGeom prst="rect">
+            <a:avLst/>
+          </a:prstGeom>
+          <a:noFill/>
+        </p:spPr>
+        <p:txBody>
+          <a:bodyPr wrap="square">
+            <a:spAutoFit/>
+          </a:bodyPr>
+          <a:lstStyle/>
+          <a:p>
+            <a:pPr algn="l"/>
+            <a:r>
+              <a:rPr sz="1300" b="1" i="0">
+                <a:solidFill>
+                  <a:srgbClr val="F59E0B"/>
+                </a:solidFill>
+              </a:rPr>
+              <a:t>180</a:t>
+            </a:r>
+          </a:p>
+        </p:txBody>
+      </p:sp>
+      <p:sp>
+        <p:nvSpPr>
+          <p:cNvPr id="38" name="TextBox 37"/>
+          <p:cNvSpPr txBox="1"/>
+          <p:nvPr/>
+        </p:nvSpPr>
+        <p:spPr>
+          <a:xfrm>
+            <a:off x="8211312" y="3044952"/>
+            <a:ext cx="1508760" cy="256032"/>
+          </a:xfrm>
+          <a:prstGeom prst="rect">
+            <a:avLst/>
+          </a:prstGeom>
+          <a:noFill/>
+        </p:spPr>
+        <p:txBody>
+          <a:bodyPr wrap="square">
+            <a:spAutoFit/>
+          </a:bodyPr>
+          <a:lstStyle/>
+          <a:p>
+            <a:pPr algn="l"/>
+            <a:r>
+              <a:rPr sz="700" b="0" i="0">
+                <a:solidFill>
+                  <a:srgbClr val="CBD5E1"/>
+                </a:solidFill>
+              </a:rPr>
+              <a:t>Indicators</a:t>
+            </a:r>
+          </a:p>
+        </p:txBody>
+      </p:sp>
+      <p:sp>
+        <p:nvSpPr>
+          <p:cNvPr id="39" name="Rectangle 38"/>
           <p:cNvSpPr/>
           <p:nvPr/>
         </p:nvSpPr>
         <p:spPr>
           <a:xfrm>
-            <a:off x="6309360" y="3950208"/>
-            <a:ext cx="2286000" cy="347472"/>
+            <a:off x="9921240" y="2715768"/>
+            <a:ext cx="1645920" cy="658368"/>
           </a:xfrm>
           <a:prstGeom prst="rect">
             <a:avLst/>
@@ -31416,7 +30927,1041 @@
       </p:sp>
       <p:sp>
         <p:nvSpPr>
+          <p:cNvPr id="40" name="TextBox 39"/>
+          <p:cNvSpPr txBox="1"/>
+          <p:nvPr/>
+        </p:nvSpPr>
+        <p:spPr>
+          <a:xfrm>
+            <a:off x="9994392" y="2752344"/>
+            <a:ext cx="1508760" cy="310896"/>
+          </a:xfrm>
+          <a:prstGeom prst="rect">
+            <a:avLst/>
+          </a:prstGeom>
+          <a:noFill/>
+        </p:spPr>
+        <p:txBody>
+          <a:bodyPr wrap="square">
+            <a:spAutoFit/>
+          </a:bodyPr>
+          <a:lstStyle/>
+          <a:p>
+            <a:pPr algn="l"/>
+            <a:r>
+              <a:rPr sz="1300" b="1" i="0">
+                <a:solidFill>
+                  <a:srgbClr val="10B981"/>
+                </a:solidFill>
+              </a:rPr>
+              <a:t>61 days</a:t>
+            </a:r>
+          </a:p>
+        </p:txBody>
+      </p:sp>
+      <p:sp>
+        <p:nvSpPr>
           <p:cNvPr id="41" name="TextBox 40"/>
+          <p:cNvSpPr txBox="1"/>
+          <p:nvPr/>
+        </p:nvSpPr>
+        <p:spPr>
+          <a:xfrm>
+            <a:off x="9994392" y="3044952"/>
+            <a:ext cx="1508760" cy="256032"/>
+          </a:xfrm>
+          <a:prstGeom prst="rect">
+            <a:avLst/>
+          </a:prstGeom>
+          <a:noFill/>
+        </p:spPr>
+        <p:txBody>
+          <a:bodyPr wrap="square">
+            <a:spAutoFit/>
+          </a:bodyPr>
+          <a:lstStyle/>
+          <a:p>
+            <a:pPr algn="l"/>
+            <a:r>
+              <a:rPr sz="700" b="0" i="0">
+                <a:solidFill>
+                  <a:srgbClr val="CBD5E1"/>
+                </a:solidFill>
+              </a:rPr>
+              <a:t>Avg Processing</a:t>
+            </a:r>
+          </a:p>
+        </p:txBody>
+      </p:sp>
+      <p:sp>
+        <p:nvSpPr>
+          <p:cNvPr id="42" name="TextBox 41"/>
+          <p:cNvSpPr txBox="1"/>
+          <p:nvPr/>
+        </p:nvSpPr>
+        <p:spPr>
+          <a:xfrm>
+            <a:off x="9692640" y="1709928"/>
+            <a:ext cx="2011680" cy="384048"/>
+          </a:xfrm>
+          <a:prstGeom prst="rect">
+            <a:avLst/>
+          </a:prstGeom>
+          <a:noFill/>
+        </p:spPr>
+        <p:txBody>
+          <a:bodyPr wrap="square">
+            <a:spAutoFit/>
+          </a:bodyPr>
+          <a:lstStyle/>
+          <a:p>
+            <a:pPr algn="l"/>
+            <a:r>
+              <a:rPr sz="750" b="0" i="0">
+                <a:solidFill>
+                  <a:srgbClr val="10B981"/>
+                </a:solidFill>
+              </a:rPr>
+              <a:t>-&gt; 40% claims flagged for fraud</a:t>
+            </a:r>
+          </a:p>
+        </p:txBody>
+      </p:sp>
+      <p:sp>
+        <p:nvSpPr>
+          <p:cNvPr id="43" name="TextBox 42"/>
+          <p:cNvSpPr txBox="1"/>
+          <p:nvPr/>
+        </p:nvSpPr>
+        <p:spPr>
+          <a:xfrm>
+            <a:off x="9692640" y="2139696"/>
+            <a:ext cx="2011680" cy="384048"/>
+          </a:xfrm>
+          <a:prstGeom prst="rect">
+            <a:avLst/>
+          </a:prstGeom>
+          <a:noFill/>
+        </p:spPr>
+        <p:txBody>
+          <a:bodyPr wrap="square">
+            <a:spAutoFit/>
+          </a:bodyPr>
+          <a:lstStyle/>
+          <a:p>
+            <a:pPr algn="l"/>
+            <a:r>
+              <a:rPr sz="750" b="0" i="0">
+                <a:solidFill>
+                  <a:srgbClr val="10B981"/>
+                </a:solidFill>
+              </a:rPr>
+              <a:t>-&gt; 180 fraud indicators found</a:t>
+            </a:r>
+          </a:p>
+        </p:txBody>
+      </p:sp>
+      <p:sp>
+        <p:nvSpPr>
+          <p:cNvPr id="44" name="TextBox 43"/>
+          <p:cNvSpPr txBox="1"/>
+          <p:nvPr/>
+        </p:nvSpPr>
+        <p:spPr>
+          <a:xfrm>
+            <a:off x="9692640" y="2569464"/>
+            <a:ext cx="2011680" cy="384048"/>
+          </a:xfrm>
+          <a:prstGeom prst="rect">
+            <a:avLst/>
+          </a:prstGeom>
+          <a:noFill/>
+        </p:spPr>
+        <p:txBody>
+          <a:bodyPr wrap="square">
+            <a:spAutoFit/>
+          </a:bodyPr>
+          <a:lstStyle/>
+          <a:p>
+            <a:pPr algn="l"/>
+            <a:r>
+              <a:rPr sz="750" b="0" i="0">
+                <a:solidFill>
+                  <a:srgbClr val="10B981"/>
+                </a:solidFill>
+              </a:rPr>
+              <a:t>-&gt; 17.3% rejection rate</a:t>
+            </a:r>
+          </a:p>
+        </p:txBody>
+      </p:sp>
+      <p:sp>
+        <p:nvSpPr>
+          <p:cNvPr id="45" name="TextBox 44"/>
+          <p:cNvSpPr txBox="1"/>
+          <p:nvPr/>
+        </p:nvSpPr>
+        <p:spPr>
+          <a:xfrm>
+            <a:off x="9692640" y="2999232"/>
+            <a:ext cx="2011680" cy="384048"/>
+          </a:xfrm>
+          <a:prstGeom prst="rect">
+            <a:avLst/>
+          </a:prstGeom>
+          <a:noFill/>
+        </p:spPr>
+        <p:txBody>
+          <a:bodyPr wrap="square">
+            <a:spAutoFit/>
+          </a:bodyPr>
+          <a:lstStyle/>
+          <a:p>
+            <a:pPr algn="l"/>
+            <a:r>
+              <a:rPr sz="750" b="0" i="0">
+                <a:solidFill>
+                  <a:srgbClr val="10B981"/>
+                </a:solidFill>
+              </a:rPr>
+              <a:t>-&gt; 61-day avg processing time</a:t>
+            </a:r>
+          </a:p>
+        </p:txBody>
+      </p:sp>
+      <p:sp>
+        <p:nvSpPr>
+          <p:cNvPr id="46" name="Rectangle 45"/>
+          <p:cNvSpPr/>
+          <p:nvPr/>
+        </p:nvSpPr>
+        <p:spPr>
+          <a:xfrm>
+            <a:off x="365760" y="3840480"/>
+            <a:ext cx="5577840" cy="2514600"/>
+          </a:xfrm>
+          <a:prstGeom prst="rect">
+            <a:avLst/>
+          </a:prstGeom>
+          <a:solidFill>
+            <a:srgbClr val="1E293B"/>
+          </a:solidFill>
+          <a:ln>
+            <a:noFill/>
+          </a:ln>
+        </p:spPr>
+        <p:style>
+          <a:lnRef idx="1">
+            <a:schemeClr val="accent1"/>
+          </a:lnRef>
+          <a:fillRef idx="3">
+            <a:schemeClr val="accent1"/>
+          </a:fillRef>
+          <a:effectRef idx="2">
+            <a:schemeClr val="accent1"/>
+          </a:effectRef>
+          <a:fontRef idx="minor">
+            <a:schemeClr val="lt1"/>
+          </a:fontRef>
+        </p:style>
+        <p:txBody>
+          <a:bodyPr rtlCol="0" anchor="ctr"/>
+          <a:lstStyle/>
+          <a:p>
+            <a:pPr algn="ctr"/>
+          </a:p>
+        </p:txBody>
+      </p:sp>
+      <p:sp>
+        <p:nvSpPr>
+          <p:cNvPr id="47" name="Rectangle 46"/>
+          <p:cNvSpPr/>
+          <p:nvPr/>
+        </p:nvSpPr>
+        <p:spPr>
+          <a:xfrm>
+            <a:off x="365760" y="3840480"/>
+            <a:ext cx="5577840" cy="45720"/>
+          </a:xfrm>
+          <a:prstGeom prst="rect">
+            <a:avLst/>
+          </a:prstGeom>
+          <a:solidFill>
+            <a:srgbClr val="6366F1"/>
+          </a:solidFill>
+          <a:ln>
+            <a:noFill/>
+          </a:ln>
+        </p:spPr>
+        <p:style>
+          <a:lnRef idx="1">
+            <a:schemeClr val="accent1"/>
+          </a:lnRef>
+          <a:fillRef idx="3">
+            <a:schemeClr val="accent1"/>
+          </a:fillRef>
+          <a:effectRef idx="2">
+            <a:schemeClr val="accent1"/>
+          </a:effectRef>
+          <a:fontRef idx="minor">
+            <a:schemeClr val="lt1"/>
+          </a:fontRef>
+        </p:style>
+        <p:txBody>
+          <a:bodyPr rtlCol="0" anchor="ctr"/>
+          <a:lstStyle/>
+          <a:p>
+            <a:pPr algn="ctr"/>
+          </a:p>
+        </p:txBody>
+      </p:sp>
+      <p:sp>
+        <p:nvSpPr>
+          <p:cNvPr id="48" name="Rectangle 47"/>
+          <p:cNvSpPr/>
+          <p:nvPr/>
+        </p:nvSpPr>
+        <p:spPr>
+          <a:xfrm>
+            <a:off x="457200" y="3950208"/>
+            <a:ext cx="2286000" cy="347472"/>
+          </a:xfrm>
+          <a:prstGeom prst="rect">
+            <a:avLst/>
+          </a:prstGeom>
+          <a:solidFill>
+            <a:srgbClr val="060B18"/>
+          </a:solidFill>
+          <a:ln>
+            <a:noFill/>
+          </a:ln>
+        </p:spPr>
+        <p:style>
+          <a:lnRef idx="1">
+            <a:schemeClr val="accent1"/>
+          </a:lnRef>
+          <a:fillRef idx="3">
+            <a:schemeClr val="accent1"/>
+          </a:fillRef>
+          <a:effectRef idx="2">
+            <a:schemeClr val="accent1"/>
+          </a:effectRef>
+          <a:fontRef idx="minor">
+            <a:schemeClr val="lt1"/>
+          </a:fontRef>
+        </p:style>
+        <p:txBody>
+          <a:bodyPr rtlCol="0" anchor="ctr"/>
+          <a:lstStyle/>
+          <a:p>
+            <a:pPr algn="ctr"/>
+          </a:p>
+        </p:txBody>
+      </p:sp>
+      <p:sp>
+        <p:nvSpPr>
+          <p:cNvPr id="49" name="TextBox 48"/>
+          <p:cNvSpPr txBox="1"/>
+          <p:nvPr/>
+        </p:nvSpPr>
+        <p:spPr>
+          <a:xfrm>
+            <a:off x="502920" y="3968496"/>
+            <a:ext cx="2194560" cy="310896"/>
+          </a:xfrm>
+          <a:prstGeom prst="rect">
+            <a:avLst/>
+          </a:prstGeom>
+          <a:noFill/>
+        </p:spPr>
+        <p:txBody>
+          <a:bodyPr wrap="square">
+            <a:spAutoFit/>
+          </a:bodyPr>
+          <a:lstStyle/>
+          <a:p>
+            <a:pPr algn="ctr"/>
+            <a:r>
+              <a:rPr sz="800" b="1" i="0">
+                <a:solidFill>
+                  <a:srgbClr val="6366F1"/>
+                </a:solidFill>
+              </a:rPr>
+              <a:t>Retail &amp; E-Commerce</a:t>
+            </a:r>
+          </a:p>
+        </p:txBody>
+      </p:sp>
+      <p:sp>
+        <p:nvSpPr>
+          <p:cNvPr id="50" name="TextBox 49"/>
+          <p:cNvSpPr txBox="1"/>
+          <p:nvPr/>
+        </p:nvSpPr>
+        <p:spPr>
+          <a:xfrm>
+            <a:off x="502920" y="4389120"/>
+            <a:ext cx="5303520" cy="320040"/>
+          </a:xfrm>
+          <a:prstGeom prst="rect">
+            <a:avLst/>
+          </a:prstGeom>
+          <a:noFill/>
+        </p:spPr>
+        <p:txBody>
+          <a:bodyPr wrap="square">
+            <a:spAutoFit/>
+          </a:bodyPr>
+          <a:lstStyle/>
+          <a:p>
+            <a:pPr algn="l"/>
+            <a:r>
+              <a:rPr sz="1300" b="1" i="0">
+                <a:solidFill>
+                  <a:srgbClr val="FFFFFF"/>
+                </a:solidFill>
+              </a:rPr>
+              <a:t>Sales Performance</a:t>
+            </a:r>
+          </a:p>
+        </p:txBody>
+      </p:sp>
+      <p:sp>
+        <p:nvSpPr>
+          <p:cNvPr id="51" name="TextBox 50"/>
+          <p:cNvSpPr txBox="1"/>
+          <p:nvPr/>
+        </p:nvSpPr>
+        <p:spPr>
+          <a:xfrm>
+            <a:off x="502920" y="4736592"/>
+            <a:ext cx="3200400" cy="594360"/>
+          </a:xfrm>
+          <a:prstGeom prst="rect">
+            <a:avLst/>
+          </a:prstGeom>
+          <a:noFill/>
+        </p:spPr>
+        <p:txBody>
+          <a:bodyPr wrap="square">
+            <a:spAutoFit/>
+          </a:bodyPr>
+          <a:lstStyle/>
+          <a:p>
+            <a:pPr algn="l"/>
+            <a:r>
+              <a:rPr sz="800" b="0" i="0">
+                <a:solidFill>
+                  <a:srgbClr val="CBD5E1"/>
+                </a:solidFill>
+              </a:rPr>
+              <a:t>Drop in Retail_Sales.xlsx (5 tabs, 3,062 rows). Get revenue KPIs,
+top/bottom performers, regional breakdowns, and AI-written summaries.</a:t>
+            </a:r>
+          </a:p>
+        </p:txBody>
+      </p:sp>
+      <p:sp>
+        <p:nvSpPr>
+          <p:cNvPr id="52" name="Rectangle 51"/>
+          <p:cNvSpPr/>
+          <p:nvPr/>
+        </p:nvSpPr>
+        <p:spPr>
+          <a:xfrm>
+            <a:off x="502920" y="5413248"/>
+            <a:ext cx="1645920" cy="658368"/>
+          </a:xfrm>
+          <a:prstGeom prst="rect">
+            <a:avLst/>
+          </a:prstGeom>
+          <a:solidFill>
+            <a:srgbClr val="060B18"/>
+          </a:solidFill>
+          <a:ln>
+            <a:noFill/>
+          </a:ln>
+        </p:spPr>
+        <p:style>
+          <a:lnRef idx="1">
+            <a:schemeClr val="accent1"/>
+          </a:lnRef>
+          <a:fillRef idx="3">
+            <a:schemeClr val="accent1"/>
+          </a:fillRef>
+          <a:effectRef idx="2">
+            <a:schemeClr val="accent1"/>
+          </a:effectRef>
+          <a:fontRef idx="minor">
+            <a:schemeClr val="lt1"/>
+          </a:fontRef>
+        </p:style>
+        <p:txBody>
+          <a:bodyPr rtlCol="0" anchor="ctr"/>
+          <a:lstStyle/>
+          <a:p>
+            <a:pPr algn="ctr"/>
+          </a:p>
+        </p:txBody>
+      </p:sp>
+      <p:sp>
+        <p:nvSpPr>
+          <p:cNvPr id="53" name="TextBox 52"/>
+          <p:cNvSpPr txBox="1"/>
+          <p:nvPr/>
+        </p:nvSpPr>
+        <p:spPr>
+          <a:xfrm>
+            <a:off x="576072" y="5449824"/>
+            <a:ext cx="1508760" cy="310896"/>
+          </a:xfrm>
+          <a:prstGeom prst="rect">
+            <a:avLst/>
+          </a:prstGeom>
+          <a:noFill/>
+        </p:spPr>
+        <p:txBody>
+          <a:bodyPr wrap="square">
+            <a:spAutoFit/>
+          </a:bodyPr>
+          <a:lstStyle/>
+          <a:p>
+            <a:pPr algn="l"/>
+            <a:r>
+              <a:rPr sz="1300" b="1" i="0">
+                <a:solidFill>
+                  <a:srgbClr val="EF4444"/>
+                </a:solidFill>
+              </a:rPr>
+              <a:t>21.4%</a:t>
+            </a:r>
+          </a:p>
+        </p:txBody>
+      </p:sp>
+      <p:sp>
+        <p:nvSpPr>
+          <p:cNvPr id="54" name="TextBox 53"/>
+          <p:cNvSpPr txBox="1"/>
+          <p:nvPr/>
+        </p:nvSpPr>
+        <p:spPr>
+          <a:xfrm>
+            <a:off x="576072" y="5742432"/>
+            <a:ext cx="1508760" cy="256032"/>
+          </a:xfrm>
+          <a:prstGeom prst="rect">
+            <a:avLst/>
+          </a:prstGeom>
+          <a:noFill/>
+        </p:spPr>
+        <p:txBody>
+          <a:bodyPr wrap="square">
+            <a:spAutoFit/>
+          </a:bodyPr>
+          <a:lstStyle/>
+          <a:p>
+            <a:pPr algn="l"/>
+            <a:r>
+              <a:rPr sz="700" b="0" i="0">
+                <a:solidFill>
+                  <a:srgbClr val="CBD5E1"/>
+                </a:solidFill>
+              </a:rPr>
+              <a:t>Return Rate</a:t>
+            </a:r>
+          </a:p>
+        </p:txBody>
+      </p:sp>
+      <p:sp>
+        <p:nvSpPr>
+          <p:cNvPr id="55" name="Rectangle 54"/>
+          <p:cNvSpPr/>
+          <p:nvPr/>
+        </p:nvSpPr>
+        <p:spPr>
+          <a:xfrm>
+            <a:off x="2286000" y="5413248"/>
+            <a:ext cx="1645920" cy="658368"/>
+          </a:xfrm>
+          <a:prstGeom prst="rect">
+            <a:avLst/>
+          </a:prstGeom>
+          <a:solidFill>
+            <a:srgbClr val="060B18"/>
+          </a:solidFill>
+          <a:ln>
+            <a:noFill/>
+          </a:ln>
+        </p:spPr>
+        <p:style>
+          <a:lnRef idx="1">
+            <a:schemeClr val="accent1"/>
+          </a:lnRef>
+          <a:fillRef idx="3">
+            <a:schemeClr val="accent1"/>
+          </a:fillRef>
+          <a:effectRef idx="2">
+            <a:schemeClr val="accent1"/>
+          </a:effectRef>
+          <a:fontRef idx="minor">
+            <a:schemeClr val="lt1"/>
+          </a:fontRef>
+        </p:style>
+        <p:txBody>
+          <a:bodyPr rtlCol="0" anchor="ctr"/>
+          <a:lstStyle/>
+          <a:p>
+            <a:pPr algn="ctr"/>
+          </a:p>
+        </p:txBody>
+      </p:sp>
+      <p:sp>
+        <p:nvSpPr>
+          <p:cNvPr id="56" name="TextBox 55"/>
+          <p:cNvSpPr txBox="1"/>
+          <p:nvPr/>
+        </p:nvSpPr>
+        <p:spPr>
+          <a:xfrm>
+            <a:off x="2359152" y="5449824"/>
+            <a:ext cx="1508760" cy="310896"/>
+          </a:xfrm>
+          <a:prstGeom prst="rect">
+            <a:avLst/>
+          </a:prstGeom>
+          <a:noFill/>
+        </p:spPr>
+        <p:txBody>
+          <a:bodyPr wrap="square">
+            <a:spAutoFit/>
+          </a:bodyPr>
+          <a:lstStyle/>
+          <a:p>
+            <a:pPr algn="l"/>
+            <a:r>
+              <a:rPr sz="1300" b="1" i="0">
+                <a:solidFill>
+                  <a:srgbClr val="3B82F6"/>
+                </a:solidFill>
+              </a:rPr>
+              <a:t>$401.1M</a:t>
+            </a:r>
+          </a:p>
+        </p:txBody>
+      </p:sp>
+      <p:sp>
+        <p:nvSpPr>
+          <p:cNvPr id="57" name="TextBox 56"/>
+          <p:cNvSpPr txBox="1"/>
+          <p:nvPr/>
+        </p:nvSpPr>
+        <p:spPr>
+          <a:xfrm>
+            <a:off x="2359152" y="5742432"/>
+            <a:ext cx="1508760" cy="256032"/>
+          </a:xfrm>
+          <a:prstGeom prst="rect">
+            <a:avLst/>
+          </a:prstGeom>
+          <a:noFill/>
+        </p:spPr>
+        <p:txBody>
+          <a:bodyPr wrap="square">
+            <a:spAutoFit/>
+          </a:bodyPr>
+          <a:lstStyle/>
+          <a:p>
+            <a:pPr algn="l"/>
+            <a:r>
+              <a:rPr sz="700" b="0" i="0">
+                <a:solidFill>
+                  <a:srgbClr val="CBD5E1"/>
+                </a:solidFill>
+              </a:rPr>
+              <a:t>Revenue</a:t>
+            </a:r>
+          </a:p>
+        </p:txBody>
+      </p:sp>
+      <p:sp>
+        <p:nvSpPr>
+          <p:cNvPr id="58" name="Rectangle 57"/>
+          <p:cNvSpPr/>
+          <p:nvPr/>
+        </p:nvSpPr>
+        <p:spPr>
+          <a:xfrm>
+            <a:off x="4069080" y="5413248"/>
+            <a:ext cx="1645920" cy="658368"/>
+          </a:xfrm>
+          <a:prstGeom prst="rect">
+            <a:avLst/>
+          </a:prstGeom>
+          <a:solidFill>
+            <a:srgbClr val="060B18"/>
+          </a:solidFill>
+          <a:ln>
+            <a:noFill/>
+          </a:ln>
+        </p:spPr>
+        <p:style>
+          <a:lnRef idx="1">
+            <a:schemeClr val="accent1"/>
+          </a:lnRef>
+          <a:fillRef idx="3">
+            <a:schemeClr val="accent1"/>
+          </a:fillRef>
+          <a:effectRef idx="2">
+            <a:schemeClr val="accent1"/>
+          </a:effectRef>
+          <a:fontRef idx="minor">
+            <a:schemeClr val="lt1"/>
+          </a:fontRef>
+        </p:style>
+        <p:txBody>
+          <a:bodyPr rtlCol="0" anchor="ctr"/>
+          <a:lstStyle/>
+          <a:p>
+            <a:pPr algn="ctr"/>
+          </a:p>
+        </p:txBody>
+      </p:sp>
+      <p:sp>
+        <p:nvSpPr>
+          <p:cNvPr id="59" name="TextBox 58"/>
+          <p:cNvSpPr txBox="1"/>
+          <p:nvPr/>
+        </p:nvSpPr>
+        <p:spPr>
+          <a:xfrm>
+            <a:off x="4142232" y="5449824"/>
+            <a:ext cx="1508760" cy="310896"/>
+          </a:xfrm>
+          <a:prstGeom prst="rect">
+            <a:avLst/>
+          </a:prstGeom>
+          <a:noFill/>
+        </p:spPr>
+        <p:txBody>
+          <a:bodyPr wrap="square">
+            <a:spAutoFit/>
+          </a:bodyPr>
+          <a:lstStyle/>
+          <a:p>
+            <a:pPr algn="l"/>
+            <a:r>
+              <a:rPr sz="1300" b="1" i="0">
+                <a:solidFill>
+                  <a:srgbClr val="F59E0B"/>
+                </a:solidFill>
+              </a:rPr>
+              <a:t>16.4%</a:t>
+            </a:r>
+          </a:p>
+        </p:txBody>
+      </p:sp>
+      <p:sp>
+        <p:nvSpPr>
+          <p:cNvPr id="60" name="TextBox 59"/>
+          <p:cNvSpPr txBox="1"/>
+          <p:nvPr/>
+        </p:nvSpPr>
+        <p:spPr>
+          <a:xfrm>
+            <a:off x="4142232" y="5742432"/>
+            <a:ext cx="1508760" cy="256032"/>
+          </a:xfrm>
+          <a:prstGeom prst="rect">
+            <a:avLst/>
+          </a:prstGeom>
+          <a:noFill/>
+        </p:spPr>
+        <p:txBody>
+          <a:bodyPr wrap="square">
+            <a:spAutoFit/>
+          </a:bodyPr>
+          <a:lstStyle/>
+          <a:p>
+            <a:pPr algn="l"/>
+            <a:r>
+              <a:rPr sz="700" b="0" i="0">
+                <a:solidFill>
+                  <a:srgbClr val="CBD5E1"/>
+                </a:solidFill>
+              </a:rPr>
+              <a:t>Cancelled</a:t>
+            </a:r>
+          </a:p>
+        </p:txBody>
+      </p:sp>
+      <p:sp>
+        <p:nvSpPr>
+          <p:cNvPr id="61" name="TextBox 60"/>
+          <p:cNvSpPr txBox="1"/>
+          <p:nvPr/>
+        </p:nvSpPr>
+        <p:spPr>
+          <a:xfrm>
+            <a:off x="3840480" y="4407408"/>
+            <a:ext cx="2011680" cy="384048"/>
+          </a:xfrm>
+          <a:prstGeom prst="rect">
+            <a:avLst/>
+          </a:prstGeom>
+          <a:noFill/>
+        </p:spPr>
+        <p:txBody>
+          <a:bodyPr wrap="square">
+            <a:spAutoFit/>
+          </a:bodyPr>
+          <a:lstStyle/>
+          <a:p>
+            <a:pPr algn="l"/>
+            <a:r>
+              <a:rPr sz="750" b="0" i="0">
+                <a:solidFill>
+                  <a:srgbClr val="6366F1"/>
+                </a:solidFill>
+              </a:rPr>
+              <a:t>-&gt; 21.4% return rate detected</a:t>
+            </a:r>
+          </a:p>
+        </p:txBody>
+      </p:sp>
+      <p:sp>
+        <p:nvSpPr>
+          <p:cNvPr id="62" name="TextBox 61"/>
+          <p:cNvSpPr txBox="1"/>
+          <p:nvPr/>
+        </p:nvSpPr>
+        <p:spPr>
+          <a:xfrm>
+            <a:off x="3840480" y="4837176"/>
+            <a:ext cx="2011680" cy="384048"/>
+          </a:xfrm>
+          <a:prstGeom prst="rect">
+            <a:avLst/>
+          </a:prstGeom>
+          <a:noFill/>
+        </p:spPr>
+        <p:txBody>
+          <a:bodyPr wrap="square">
+            <a:spAutoFit/>
+          </a:bodyPr>
+          <a:lstStyle/>
+          <a:p>
+            <a:pPr algn="l"/>
+            <a:r>
+              <a:rPr sz="750" b="0" i="0">
+                <a:solidFill>
+                  <a:srgbClr val="6366F1"/>
+                </a:solidFill>
+              </a:rPr>
+              <a:t>-&gt; Top 3 categories nearly equal share</a:t>
+            </a:r>
+          </a:p>
+        </p:txBody>
+      </p:sp>
+      <p:sp>
+        <p:nvSpPr>
+          <p:cNvPr id="63" name="TextBox 62"/>
+          <p:cNvSpPr txBox="1"/>
+          <p:nvPr/>
+        </p:nvSpPr>
+        <p:spPr>
+          <a:xfrm>
+            <a:off x="3840480" y="5266944"/>
+            <a:ext cx="2011680" cy="384048"/>
+          </a:xfrm>
+          <a:prstGeom prst="rect">
+            <a:avLst/>
+          </a:prstGeom>
+          <a:noFill/>
+        </p:spPr>
+        <p:txBody>
+          <a:bodyPr wrap="square">
+            <a:spAutoFit/>
+          </a:bodyPr>
+          <a:lstStyle/>
+          <a:p>
+            <a:pPr algn="l"/>
+            <a:r>
+              <a:rPr sz="750" b="0" i="0">
+                <a:solidFill>
+                  <a:srgbClr val="6366F1"/>
+                </a:solidFill>
+              </a:rPr>
+              <a:t>-&gt; $401.1M total line revenue</a:t>
+            </a:r>
+          </a:p>
+        </p:txBody>
+      </p:sp>
+      <p:sp>
+        <p:nvSpPr>
+          <p:cNvPr id="64" name="TextBox 63"/>
+          <p:cNvSpPr txBox="1"/>
+          <p:nvPr/>
+        </p:nvSpPr>
+        <p:spPr>
+          <a:xfrm>
+            <a:off x="3840480" y="5696712"/>
+            <a:ext cx="2011680" cy="384048"/>
+          </a:xfrm>
+          <a:prstGeom prst="rect">
+            <a:avLst/>
+          </a:prstGeom>
+          <a:noFill/>
+        </p:spPr>
+        <p:txBody>
+          <a:bodyPr wrap="square">
+            <a:spAutoFit/>
+          </a:bodyPr>
+          <a:lstStyle/>
+          <a:p>
+            <a:pPr algn="l"/>
+            <a:r>
+              <a:rPr sz="750" b="0" i="0">
+                <a:solidFill>
+                  <a:srgbClr val="6366F1"/>
+                </a:solidFill>
+              </a:rPr>
+              <a:t>-&gt; 16.4% cancelled order rate</a:t>
+            </a:r>
+          </a:p>
+        </p:txBody>
+      </p:sp>
+      <p:sp>
+        <p:nvSpPr>
+          <p:cNvPr id="65" name="Rectangle 64"/>
+          <p:cNvSpPr/>
+          <p:nvPr/>
+        </p:nvSpPr>
+        <p:spPr>
+          <a:xfrm>
+            <a:off x="6217920" y="3840480"/>
+            <a:ext cx="5577840" cy="2514600"/>
+          </a:xfrm>
+          <a:prstGeom prst="rect">
+            <a:avLst/>
+          </a:prstGeom>
+          <a:solidFill>
+            <a:srgbClr val="1E293B"/>
+          </a:solidFill>
+          <a:ln>
+            <a:noFill/>
+          </a:ln>
+        </p:spPr>
+        <p:style>
+          <a:lnRef idx="1">
+            <a:schemeClr val="accent1"/>
+          </a:lnRef>
+          <a:fillRef idx="3">
+            <a:schemeClr val="accent1"/>
+          </a:fillRef>
+          <a:effectRef idx="2">
+            <a:schemeClr val="accent1"/>
+          </a:effectRef>
+          <a:fontRef idx="minor">
+            <a:schemeClr val="lt1"/>
+          </a:fontRef>
+        </p:style>
+        <p:txBody>
+          <a:bodyPr rtlCol="0" anchor="ctr"/>
+          <a:lstStyle/>
+          <a:p>
+            <a:pPr algn="ctr"/>
+          </a:p>
+        </p:txBody>
+      </p:sp>
+      <p:sp>
+        <p:nvSpPr>
+          <p:cNvPr id="66" name="Rectangle 65"/>
+          <p:cNvSpPr/>
+          <p:nvPr/>
+        </p:nvSpPr>
+        <p:spPr>
+          <a:xfrm>
+            <a:off x="6217920" y="3840480"/>
+            <a:ext cx="5577840" cy="45720"/>
+          </a:xfrm>
+          <a:prstGeom prst="rect">
+            <a:avLst/>
+          </a:prstGeom>
+          <a:solidFill>
+            <a:srgbClr val="F59E0B"/>
+          </a:solidFill>
+          <a:ln>
+            <a:noFill/>
+          </a:ln>
+        </p:spPr>
+        <p:style>
+          <a:lnRef idx="1">
+            <a:schemeClr val="accent1"/>
+          </a:lnRef>
+          <a:fillRef idx="3">
+            <a:schemeClr val="accent1"/>
+          </a:fillRef>
+          <a:effectRef idx="2">
+            <a:schemeClr val="accent1"/>
+          </a:effectRef>
+          <a:fontRef idx="minor">
+            <a:schemeClr val="lt1"/>
+          </a:fontRef>
+        </p:style>
+        <p:txBody>
+          <a:bodyPr rtlCol="0" anchor="ctr"/>
+          <a:lstStyle/>
+          <a:p>
+            <a:pPr algn="ctr"/>
+          </a:p>
+        </p:txBody>
+      </p:sp>
+      <p:sp>
+        <p:nvSpPr>
+          <p:cNvPr id="67" name="Rectangle 66"/>
+          <p:cNvSpPr/>
+          <p:nvPr/>
+        </p:nvSpPr>
+        <p:spPr>
+          <a:xfrm>
+            <a:off x="6309360" y="3950208"/>
+            <a:ext cx="2286000" cy="347472"/>
+          </a:xfrm>
+          <a:prstGeom prst="rect">
+            <a:avLst/>
+          </a:prstGeom>
+          <a:solidFill>
+            <a:srgbClr val="060B18"/>
+          </a:solidFill>
+          <a:ln>
+            <a:noFill/>
+          </a:ln>
+        </p:spPr>
+        <p:style>
+          <a:lnRef idx="1">
+            <a:schemeClr val="accent1"/>
+          </a:lnRef>
+          <a:fillRef idx="3">
+            <a:schemeClr val="accent1"/>
+          </a:fillRef>
+          <a:effectRef idx="2">
+            <a:schemeClr val="accent1"/>
+          </a:effectRef>
+          <a:fontRef idx="minor">
+            <a:schemeClr val="lt1"/>
+          </a:fontRef>
+        </p:style>
+        <p:txBody>
+          <a:bodyPr rtlCol="0" anchor="ctr"/>
+          <a:lstStyle/>
+          <a:p>
+            <a:pPr algn="ctr"/>
+          </a:p>
+        </p:txBody>
+      </p:sp>
+      <p:sp>
+        <p:nvSpPr>
+          <p:cNvPr id="68" name="TextBox 67"/>
           <p:cNvSpPr txBox="1"/>
           <p:nvPr/>
         </p:nvSpPr>
@@ -31450,7 +31995,7 @@
       </p:sp>
       <p:sp>
         <p:nvSpPr>
-          <p:cNvPr id="42" name="TextBox 41"/>
+          <p:cNvPr id="69" name="TextBox 68"/>
           <p:cNvSpPr txBox="1"/>
           <p:nvPr/>
         </p:nvSpPr>
@@ -31484,42 +32029,375 @@
       </p:sp>
       <p:sp>
         <p:nvSpPr>
-          <p:cNvPr id="43" name="TextBox 42"/>
+          <p:cNvPr id="70" name="TextBox 69"/>
           <p:cNvSpPr txBox="1"/>
           <p:nvPr/>
         </p:nvSpPr>
         <p:spPr>
           <a:xfrm>
             <a:off x="6355080" y="4736592"/>
-            <a:ext cx="3200400" cy="685800"/>
-          </a:xfrm>
-          <a:prstGeom prst="rect">
-            <a:avLst/>
-          </a:prstGeom>
-          <a:noFill/>
-        </p:spPr>
-        <p:txBody>
-          <a:bodyPr wrap="square">
-            <a:spAutoFit/>
-          </a:bodyPr>
-          <a:lstStyle/>
-          <a:p>
-            <a:pPr algn="l"/>
-            <a:r>
-              <a:rPr sz="850" b="0" i="0">
+            <a:ext cx="3200400" cy="594360"/>
+          </a:xfrm>
+          <a:prstGeom prst="rect">
+            <a:avLst/>
+          </a:prstGeom>
+          <a:noFill/>
+        </p:spPr>
+        <p:txBody>
+          <a:bodyPr wrap="square">
+            <a:spAutoFit/>
+          </a:bodyPr>
+          <a:lstStyle/>
+          <a:p>
+            <a:pPr algn="l"/>
+            <a:r>
+              <a:rPr sz="800" b="0" i="0">
                 <a:solidFill>
                   <a:srgbClr val="CBD5E1"/>
                 </a:solidFill>
               </a:rPr>
-              <a:t>Upload headcount data. Identify attrition risks, compensation outliers,
-department overstaffing, and diversity metrics in minutes.</a:t>
-            </a:r>
-          </a:p>
-        </p:txBody>
-      </p:sp>
-      <p:sp>
-        <p:nvSpPr>
-          <p:cNvPr id="44" name="TextBox 43"/>
+              <a:t>Upload HR_Workforce.xlsx (5 tabs, 3,411 rows). Identify attrition risks,
+compensation outliers, and diversity metrics in minutes.</a:t>
+            </a:r>
+          </a:p>
+        </p:txBody>
+      </p:sp>
+      <p:sp>
+        <p:nvSpPr>
+          <p:cNvPr id="71" name="Rectangle 70"/>
+          <p:cNvSpPr/>
+          <p:nvPr/>
+        </p:nvSpPr>
+        <p:spPr>
+          <a:xfrm>
+            <a:off x="6355080" y="5413248"/>
+            <a:ext cx="1645920" cy="658368"/>
+          </a:xfrm>
+          <a:prstGeom prst="rect">
+            <a:avLst/>
+          </a:prstGeom>
+          <a:solidFill>
+            <a:srgbClr val="060B18"/>
+          </a:solidFill>
+          <a:ln>
+            <a:noFill/>
+          </a:ln>
+        </p:spPr>
+        <p:style>
+          <a:lnRef idx="1">
+            <a:schemeClr val="accent1"/>
+          </a:lnRef>
+          <a:fillRef idx="3">
+            <a:schemeClr val="accent1"/>
+          </a:fillRef>
+          <a:effectRef idx="2">
+            <a:schemeClr val="accent1"/>
+          </a:effectRef>
+          <a:fontRef idx="minor">
+            <a:schemeClr val="lt1"/>
+          </a:fontRef>
+        </p:style>
+        <p:txBody>
+          <a:bodyPr rtlCol="0" anchor="ctr"/>
+          <a:lstStyle/>
+          <a:p>
+            <a:pPr algn="ctr"/>
+          </a:p>
+        </p:txBody>
+      </p:sp>
+      <p:sp>
+        <p:nvSpPr>
+          <p:cNvPr id="72" name="TextBox 71"/>
+          <p:cNvSpPr txBox="1"/>
+          <p:nvPr/>
+        </p:nvSpPr>
+        <p:spPr>
+          <a:xfrm>
+            <a:off x="6428232" y="5449824"/>
+            <a:ext cx="1508760" cy="310896"/>
+          </a:xfrm>
+          <a:prstGeom prst="rect">
+            <a:avLst/>
+          </a:prstGeom>
+          <a:noFill/>
+        </p:spPr>
+        <p:txBody>
+          <a:bodyPr wrap="square">
+            <a:spAutoFit/>
+          </a:bodyPr>
+          <a:lstStyle/>
+          <a:p>
+            <a:pPr algn="l"/>
+            <a:r>
+              <a:rPr sz="1300" b="1" i="0">
+                <a:solidFill>
+                  <a:srgbClr val="10B981"/>
+                </a:solidFill>
+              </a:rPr>
+              <a:t>66.8%</a:t>
+            </a:r>
+          </a:p>
+        </p:txBody>
+      </p:sp>
+      <p:sp>
+        <p:nvSpPr>
+          <p:cNvPr id="73" name="TextBox 72"/>
+          <p:cNvSpPr txBox="1"/>
+          <p:nvPr/>
+        </p:nvSpPr>
+        <p:spPr>
+          <a:xfrm>
+            <a:off x="6428232" y="5742432"/>
+            <a:ext cx="1508760" cy="256032"/>
+          </a:xfrm>
+          <a:prstGeom prst="rect">
+            <a:avLst/>
+          </a:prstGeom>
+          <a:noFill/>
+        </p:spPr>
+        <p:txBody>
+          <a:bodyPr wrap="square">
+            <a:spAutoFit/>
+          </a:bodyPr>
+          <a:lstStyle/>
+          <a:p>
+            <a:pPr algn="l"/>
+            <a:r>
+              <a:rPr sz="700" b="0" i="0">
+                <a:solidFill>
+                  <a:srgbClr val="CBD5E1"/>
+                </a:solidFill>
+              </a:rPr>
+              <a:t>Active Rate</a:t>
+            </a:r>
+          </a:p>
+        </p:txBody>
+      </p:sp>
+      <p:sp>
+        <p:nvSpPr>
+          <p:cNvPr id="74" name="Rectangle 73"/>
+          <p:cNvSpPr/>
+          <p:nvPr/>
+        </p:nvSpPr>
+        <p:spPr>
+          <a:xfrm>
+            <a:off x="8138160" y="5413248"/>
+            <a:ext cx="1645920" cy="658368"/>
+          </a:xfrm>
+          <a:prstGeom prst="rect">
+            <a:avLst/>
+          </a:prstGeom>
+          <a:solidFill>
+            <a:srgbClr val="060B18"/>
+          </a:solidFill>
+          <a:ln>
+            <a:noFill/>
+          </a:ln>
+        </p:spPr>
+        <p:style>
+          <a:lnRef idx="1">
+            <a:schemeClr val="accent1"/>
+          </a:lnRef>
+          <a:fillRef idx="3">
+            <a:schemeClr val="accent1"/>
+          </a:fillRef>
+          <a:effectRef idx="2">
+            <a:schemeClr val="accent1"/>
+          </a:effectRef>
+          <a:fontRef idx="minor">
+            <a:schemeClr val="lt1"/>
+          </a:fontRef>
+        </p:style>
+        <p:txBody>
+          <a:bodyPr rtlCol="0" anchor="ctr"/>
+          <a:lstStyle/>
+          <a:p>
+            <a:pPr algn="ctr"/>
+          </a:p>
+        </p:txBody>
+      </p:sp>
+      <p:sp>
+        <p:nvSpPr>
+          <p:cNvPr id="75" name="TextBox 74"/>
+          <p:cNvSpPr txBox="1"/>
+          <p:nvPr/>
+        </p:nvSpPr>
+        <p:spPr>
+          <a:xfrm>
+            <a:off x="8211312" y="5449824"/>
+            <a:ext cx="1508760" cy="310896"/>
+          </a:xfrm>
+          <a:prstGeom prst="rect">
+            <a:avLst/>
+          </a:prstGeom>
+          <a:noFill/>
+        </p:spPr>
+        <p:txBody>
+          <a:bodyPr wrap="square">
+            <a:spAutoFit/>
+          </a:bodyPr>
+          <a:lstStyle/>
+          <a:p>
+            <a:pPr algn="l"/>
+            <a:r>
+              <a:rPr sz="1300" b="1" i="0">
+                <a:solidFill>
+                  <a:srgbClr val="3B82F6"/>
+                </a:solidFill>
+              </a:rPr>
+              <a:t>$548.3M</a:t>
+            </a:r>
+          </a:p>
+        </p:txBody>
+      </p:sp>
+      <p:sp>
+        <p:nvSpPr>
+          <p:cNvPr id="76" name="TextBox 75"/>
+          <p:cNvSpPr txBox="1"/>
+          <p:nvPr/>
+        </p:nvSpPr>
+        <p:spPr>
+          <a:xfrm>
+            <a:off x="8211312" y="5742432"/>
+            <a:ext cx="1508760" cy="256032"/>
+          </a:xfrm>
+          <a:prstGeom prst="rect">
+            <a:avLst/>
+          </a:prstGeom>
+          <a:noFill/>
+        </p:spPr>
+        <p:txBody>
+          <a:bodyPr wrap="square">
+            <a:spAutoFit/>
+          </a:bodyPr>
+          <a:lstStyle/>
+          <a:p>
+            <a:pPr algn="l"/>
+            <a:r>
+              <a:rPr sz="700" b="0" i="0">
+                <a:solidFill>
+                  <a:srgbClr val="CBD5E1"/>
+                </a:solidFill>
+              </a:rPr>
+              <a:t>Payroll</a:t>
+            </a:r>
+          </a:p>
+        </p:txBody>
+      </p:sp>
+      <p:sp>
+        <p:nvSpPr>
+          <p:cNvPr id="77" name="Rectangle 76"/>
+          <p:cNvSpPr/>
+          <p:nvPr/>
+        </p:nvSpPr>
+        <p:spPr>
+          <a:xfrm>
+            <a:off x="9921240" y="5413248"/>
+            <a:ext cx="1645920" cy="658368"/>
+          </a:xfrm>
+          <a:prstGeom prst="rect">
+            <a:avLst/>
+          </a:prstGeom>
+          <a:solidFill>
+            <a:srgbClr val="060B18"/>
+          </a:solidFill>
+          <a:ln>
+            <a:noFill/>
+          </a:ln>
+        </p:spPr>
+        <p:style>
+          <a:lnRef idx="1">
+            <a:schemeClr val="accent1"/>
+          </a:lnRef>
+          <a:fillRef idx="3">
+            <a:schemeClr val="accent1"/>
+          </a:fillRef>
+          <a:effectRef idx="2">
+            <a:schemeClr val="accent1"/>
+          </a:effectRef>
+          <a:fontRef idx="minor">
+            <a:schemeClr val="lt1"/>
+          </a:fontRef>
+        </p:style>
+        <p:txBody>
+          <a:bodyPr rtlCol="0" anchor="ctr"/>
+          <a:lstStyle/>
+          <a:p>
+            <a:pPr algn="ctr"/>
+          </a:p>
+        </p:txBody>
+      </p:sp>
+      <p:sp>
+        <p:nvSpPr>
+          <p:cNvPr id="78" name="TextBox 77"/>
+          <p:cNvSpPr txBox="1"/>
+          <p:nvPr/>
+        </p:nvSpPr>
+        <p:spPr>
+          <a:xfrm>
+            <a:off x="9994392" y="5449824"/>
+            <a:ext cx="1508760" cy="310896"/>
+          </a:xfrm>
+          <a:prstGeom prst="rect">
+            <a:avLst/>
+          </a:prstGeom>
+          <a:noFill/>
+        </p:spPr>
+        <p:txBody>
+          <a:bodyPr wrap="square">
+            <a:spAutoFit/>
+          </a:bodyPr>
+          <a:lstStyle/>
+          <a:p>
+            <a:pPr algn="l"/>
+            <a:r>
+              <a:rPr sz="1300" b="1" i="0">
+                <a:solidFill>
+                  <a:srgbClr val="F59E0B"/>
+                </a:solidFill>
+              </a:rPr>
+              <a:t>1.09x</a:t>
+            </a:r>
+          </a:p>
+        </p:txBody>
+      </p:sp>
+      <p:sp>
+        <p:nvSpPr>
+          <p:cNvPr id="79" name="TextBox 78"/>
+          <p:cNvSpPr txBox="1"/>
+          <p:nvPr/>
+        </p:nvSpPr>
+        <p:spPr>
+          <a:xfrm>
+            <a:off x="9994392" y="5742432"/>
+            <a:ext cx="1508760" cy="256032"/>
+          </a:xfrm>
+          <a:prstGeom prst="rect">
+            <a:avLst/>
+          </a:prstGeom>
+          <a:noFill/>
+        </p:spPr>
+        <p:txBody>
+          <a:bodyPr wrap="square">
+            <a:spAutoFit/>
+          </a:bodyPr>
+          <a:lstStyle/>
+          <a:p>
+            <a:pPr algn="l"/>
+            <a:r>
+              <a:rPr sz="700" b="0" i="0">
+                <a:solidFill>
+                  <a:srgbClr val="CBD5E1"/>
+                </a:solidFill>
+              </a:rPr>
+              <a:t>Pay Gap</a:t>
+            </a:r>
+          </a:p>
+        </p:txBody>
+      </p:sp>
+      <p:sp>
+        <p:nvSpPr>
+          <p:cNvPr id="80" name="TextBox 79"/>
           <p:cNvSpPr txBox="1"/>
           <p:nvPr/>
         </p:nvSpPr>
@@ -31541,19 +32419,19 @@
           <a:p>
             <a:pPr algn="l"/>
             <a:r>
-              <a:rPr sz="800" b="0" i="0">
+              <a:rPr sz="750" b="0" i="0">
                 <a:solidFill>
                   <a:srgbClr val="F59E0B"/>
                 </a:solidFill>
               </a:rPr>
-              <a:t>-&gt; Attrition risk table</a:t>
-            </a:r>
-          </a:p>
-        </p:txBody>
-      </p:sp>
-      <p:sp>
-        <p:nvSpPr>
-          <p:cNvPr id="45" name="TextBox 44"/>
+              <a:t>-&gt; 66.8% active employee rate</a:t>
+            </a:r>
+          </a:p>
+        </p:txBody>
+      </p:sp>
+      <p:sp>
+        <p:nvSpPr>
+          <p:cNvPr id="81" name="TextBox 80"/>
           <p:cNvSpPr txBox="1"/>
           <p:nvPr/>
         </p:nvSpPr>
@@ -31575,19 +32453,19 @@
           <a:p>
             <a:pPr algn="l"/>
             <a:r>
-              <a:rPr sz="800" b="0" i="0">
+              <a:rPr sz="750" b="0" i="0">
                 <a:solidFill>
                   <a:srgbClr val="F59E0B"/>
                 </a:solidFill>
               </a:rPr>
-              <a:t>-&gt; Salary distribution by grade</a:t>
-            </a:r>
-          </a:p>
-        </p:txBody>
-      </p:sp>
-      <p:sp>
-        <p:nvSpPr>
-          <p:cNvPr id="46" name="TextBox 45"/>
+              <a:t>-&gt; 5 departments at attrition risk</a:t>
+            </a:r>
+          </a:p>
+        </p:txBody>
+      </p:sp>
+      <p:sp>
+        <p:nvSpPr>
+          <p:cNvPr id="82" name="TextBox 81"/>
           <p:cNvSpPr txBox="1"/>
           <p:nvPr/>
         </p:nvSpPr>
@@ -31609,19 +32487,19 @@
           <a:p>
             <a:pPr algn="l"/>
             <a:r>
-              <a:rPr sz="800" b="0" i="0">
+              <a:rPr sz="750" b="0" i="0">
                 <a:solidFill>
                   <a:srgbClr val="F59E0B"/>
                 </a:solidFill>
               </a:rPr>
-              <a:t>-&gt; Tenure vs performance</a:t>
-            </a:r>
-          </a:p>
-        </p:txBody>
-      </p:sp>
-      <p:sp>
-        <p:nvSpPr>
-          <p:cNvPr id="47" name="TextBox 46"/>
+              <a:t>-&gt; 1.09x gender pay gap detected</a:t>
+            </a:r>
+          </a:p>
+        </p:txBody>
+      </p:sp>
+      <p:sp>
+        <p:nvSpPr>
+          <p:cNvPr id="83" name="TextBox 82"/>
           <p:cNvSpPr txBox="1"/>
           <p:nvPr/>
         </p:nvSpPr>
@@ -31643,12 +32521,12 @@
           <a:p>
             <a:pPr algn="l"/>
             <a:r>
-              <a:rPr sz="800" b="0" i="0">
+              <a:rPr sz="750" b="0" i="0">
                 <a:solidFill>
                   <a:srgbClr val="F59E0B"/>
                 </a:solidFill>
               </a:rPr>
-              <a:t>-&gt; Department headcount</a:t>
+              <a:t>-&gt; $548.3M total payroll</a:t>
             </a:r>
           </a:p>
         </p:txBody>

</xml_diff>

<commit_message>
updated PPT with features
</commit_message>
<xml_diff>
--- a/test_data/PulseAI_Presentation.pptx
+++ b/test_data/PulseAI_Presentation.pptx
@@ -5,21 +5,21 @@
     <p:sldMasterId id="2147483648" r:id="rId1"/>
   </p:sldMasterIdLst>
   <p:sldIdLst>
-    <p:sldId id="256" r:id="rId7"/>
-    <p:sldId id="257" r:id="rId8"/>
-    <p:sldId id="258" r:id="rId9"/>
-    <p:sldId id="259" r:id="rId10"/>
-    <p:sldId id="260" r:id="rId11"/>
-    <p:sldId id="261" r:id="rId12"/>
-    <p:sldId id="262" r:id="rId13"/>
-    <p:sldId id="263" r:id="rId14"/>
-    <p:sldId id="264" r:id="rId15"/>
-    <p:sldId id="265" r:id="rId16"/>
-    <p:sldId id="266" r:id="rId17"/>
-    <p:sldId id="267" r:id="rId18"/>
-    <p:sldId id="268" r:id="rId19"/>
+    <p:sldId id="256" r:id="rId2"/>
+    <p:sldId id="257" r:id="rId3"/>
+    <p:sldId id="258" r:id="rId4"/>
+    <p:sldId id="259" r:id="rId5"/>
+    <p:sldId id="260" r:id="rId6"/>
+    <p:sldId id="261" r:id="rId7"/>
+    <p:sldId id="262" r:id="rId8"/>
+    <p:sldId id="263" r:id="rId9"/>
+    <p:sldId id="264" r:id="rId10"/>
+    <p:sldId id="265" r:id="rId11"/>
+    <p:sldId id="266" r:id="rId12"/>
+    <p:sldId id="267" r:id="rId13"/>
+    <p:sldId id="268" r:id="rId14"/>
   </p:sldIdLst>
-  <p:sldSz cx="12188952" cy="6858000" type="screen4x3"/>
+  <p:sldSz cx="12188825" cy="6858000"/>
   <p:notesSz cx="6858000" cy="9144000"/>
   <p:defaultTextStyle>
     <a:defPPr>
@@ -116,6 +116,22 @@
       </a:defRPr>
     </a:lvl9pPr>
   </p:defaultTextStyle>
+  <p:extLst>
+    <p:ext uri="{EFAFB233-063F-42B5-8137-9DF3F51BA10A}">
+      <p15:sldGuideLst xmlns:p15="http://schemas.microsoft.com/office/powerpoint/2012/main">
+        <p15:guide id="1" orient="horz" pos="2160">
+          <p15:clr>
+            <a:srgbClr val="A4A3A4"/>
+          </p15:clr>
+        </p15:guide>
+        <p15:guide id="2" pos="2880">
+          <p15:clr>
+            <a:srgbClr val="A4A3A4"/>
+          </p15:clr>
+        </p15:guide>
+      </p15:sldGuideLst>
+    </p:ext>
+  </p:extLst>
 </p:presentation>
 </file>
 
@@ -157,10 +173,9 @@
           <a:lstStyle/>
           <a:p>
             <a:r>
-              <a:rPr lang="en-US" smtClean="0"/>
+              <a:rPr lang="en-US"/>
               <a:t>Click to edit Master title style</a:t>
             </a:r>
-            <a:endParaRPr lang="en-US"/>
           </a:p>
         </p:txBody>
       </p:sp>
@@ -276,10 +291,9 @@
           </a:lstStyle>
           <a:p>
             <a:r>
-              <a:rPr lang="en-US" smtClean="0"/>
+              <a:rPr lang="en-US"/>
               <a:t>Click to edit Master subtitle style</a:t>
             </a:r>
-            <a:endParaRPr lang="en-US"/>
           </a:p>
         </p:txBody>
       </p:sp>
@@ -300,7 +314,7 @@
           <a:p>
             <a:fld id="{5BCAD085-E8A6-8845-BD4E-CB4CCA059FC4}" type="datetimeFigureOut">
               <a:rPr lang="en-US" smtClean="0"/>
-              <a:t>1/27/13</a:t>
+              <a:t>7/9/2026</a:t>
             </a:fld>
             <a:endParaRPr lang="en-US"/>
           </a:p>
@@ -394,10 +408,9 @@
           <a:lstStyle/>
           <a:p>
             <a:r>
-              <a:rPr lang="en-US" smtClean="0"/>
+              <a:rPr lang="en-US"/>
               <a:t>Click to edit Master title style</a:t>
             </a:r>
-            <a:endParaRPr lang="en-US"/>
           </a:p>
         </p:txBody>
       </p:sp>
@@ -418,38 +431,37 @@
           <a:p>
             <a:pPr lvl="0"/>
             <a:r>
-              <a:rPr lang="en-US" smtClean="0"/>
+              <a:rPr lang="en-US"/>
               <a:t>Click to edit Master text styles</a:t>
             </a:r>
           </a:p>
           <a:p>
             <a:pPr lvl="1"/>
             <a:r>
-              <a:rPr lang="en-US" smtClean="0"/>
+              <a:rPr lang="en-US"/>
               <a:t>Second level</a:t>
             </a:r>
           </a:p>
           <a:p>
             <a:pPr lvl="2"/>
             <a:r>
-              <a:rPr lang="en-US" smtClean="0"/>
+              <a:rPr lang="en-US"/>
               <a:t>Third level</a:t>
             </a:r>
           </a:p>
           <a:p>
             <a:pPr lvl="3"/>
             <a:r>
-              <a:rPr lang="en-US" smtClean="0"/>
+              <a:rPr lang="en-US"/>
               <a:t>Fourth level</a:t>
             </a:r>
           </a:p>
           <a:p>
             <a:pPr lvl="4"/>
             <a:r>
-              <a:rPr lang="en-US" smtClean="0"/>
+              <a:rPr lang="en-US"/>
               <a:t>Fifth level</a:t>
             </a:r>
-            <a:endParaRPr lang="en-US"/>
           </a:p>
         </p:txBody>
       </p:sp>
@@ -470,7 +482,7 @@
           <a:p>
             <a:fld id="{5BCAD085-E8A6-8845-BD4E-CB4CCA059FC4}" type="datetimeFigureOut">
               <a:rPr lang="en-US" smtClean="0"/>
-              <a:t>1/27/13</a:t>
+              <a:t>7/9/2026</a:t>
             </a:fld>
             <a:endParaRPr lang="en-US"/>
           </a:p>
@@ -569,10 +581,9 @@
           <a:lstStyle/>
           <a:p>
             <a:r>
-              <a:rPr lang="en-US" smtClean="0"/>
+              <a:rPr lang="en-US"/>
               <a:t>Click to edit Master title style</a:t>
             </a:r>
-            <a:endParaRPr lang="en-US"/>
           </a:p>
         </p:txBody>
       </p:sp>
@@ -598,38 +609,37 @@
           <a:p>
             <a:pPr lvl="0"/>
             <a:r>
-              <a:rPr lang="en-US" smtClean="0"/>
+              <a:rPr lang="en-US"/>
               <a:t>Click to edit Master text styles</a:t>
             </a:r>
           </a:p>
           <a:p>
             <a:pPr lvl="1"/>
             <a:r>
-              <a:rPr lang="en-US" smtClean="0"/>
+              <a:rPr lang="en-US"/>
               <a:t>Second level</a:t>
             </a:r>
           </a:p>
           <a:p>
             <a:pPr lvl="2"/>
             <a:r>
-              <a:rPr lang="en-US" smtClean="0"/>
+              <a:rPr lang="en-US"/>
               <a:t>Third level</a:t>
             </a:r>
           </a:p>
           <a:p>
             <a:pPr lvl="3"/>
             <a:r>
-              <a:rPr lang="en-US" smtClean="0"/>
+              <a:rPr lang="en-US"/>
               <a:t>Fourth level</a:t>
             </a:r>
           </a:p>
           <a:p>
             <a:pPr lvl="4"/>
             <a:r>
-              <a:rPr lang="en-US" smtClean="0"/>
+              <a:rPr lang="en-US"/>
               <a:t>Fifth level</a:t>
             </a:r>
-            <a:endParaRPr lang="en-US"/>
           </a:p>
         </p:txBody>
       </p:sp>
@@ -650,7 +660,7 @@
           <a:p>
             <a:fld id="{5BCAD085-E8A6-8845-BD4E-CB4CCA059FC4}" type="datetimeFigureOut">
               <a:rPr lang="en-US" smtClean="0"/>
-              <a:t>1/27/13</a:t>
+              <a:t>7/9/2026</a:t>
             </a:fld>
             <a:endParaRPr lang="en-US"/>
           </a:p>
@@ -744,10 +754,9 @@
           <a:lstStyle/>
           <a:p>
             <a:r>
-              <a:rPr lang="en-US" smtClean="0"/>
+              <a:rPr lang="en-US"/>
               <a:t>Click to edit Master title style</a:t>
             </a:r>
-            <a:endParaRPr lang="en-US"/>
           </a:p>
         </p:txBody>
       </p:sp>
@@ -768,38 +777,37 @@
           <a:p>
             <a:pPr lvl="0"/>
             <a:r>
-              <a:rPr lang="en-US" smtClean="0"/>
+              <a:rPr lang="en-US"/>
               <a:t>Click to edit Master text styles</a:t>
             </a:r>
           </a:p>
           <a:p>
             <a:pPr lvl="1"/>
             <a:r>
-              <a:rPr lang="en-US" smtClean="0"/>
+              <a:rPr lang="en-US"/>
               <a:t>Second level</a:t>
             </a:r>
           </a:p>
           <a:p>
             <a:pPr lvl="2"/>
             <a:r>
-              <a:rPr lang="en-US" smtClean="0"/>
+              <a:rPr lang="en-US"/>
               <a:t>Third level</a:t>
             </a:r>
           </a:p>
           <a:p>
             <a:pPr lvl="3"/>
             <a:r>
-              <a:rPr lang="en-US" smtClean="0"/>
+              <a:rPr lang="en-US"/>
               <a:t>Fourth level</a:t>
             </a:r>
           </a:p>
           <a:p>
             <a:pPr lvl="4"/>
             <a:r>
-              <a:rPr lang="en-US" smtClean="0"/>
+              <a:rPr lang="en-US"/>
               <a:t>Fifth level</a:t>
             </a:r>
-            <a:endParaRPr lang="en-US"/>
           </a:p>
         </p:txBody>
       </p:sp>
@@ -820,7 +828,7 @@
           <a:p>
             <a:fld id="{5BCAD085-E8A6-8845-BD4E-CB4CCA059FC4}" type="datetimeFigureOut">
               <a:rPr lang="en-US" smtClean="0"/>
-              <a:t>1/27/13</a:t>
+              <a:t>7/9/2026</a:t>
             </a:fld>
             <a:endParaRPr lang="en-US"/>
           </a:p>
@@ -923,10 +931,9 @@
           </a:lstStyle>
           <a:p>
             <a:r>
-              <a:rPr lang="en-US" smtClean="0"/>
+              <a:rPr lang="en-US"/>
               <a:t>Click to edit Master title style</a:t>
             </a:r>
-            <a:endParaRPr lang="en-US"/>
           </a:p>
         </p:txBody>
       </p:sp>
@@ -1043,7 +1050,7 @@
           <a:p>
             <a:pPr lvl="0"/>
             <a:r>
-              <a:rPr lang="en-US" smtClean="0"/>
+              <a:rPr lang="en-US"/>
               <a:t>Click to edit Master text styles</a:t>
             </a:r>
           </a:p>
@@ -1066,7 +1073,7 @@
           <a:p>
             <a:fld id="{5BCAD085-E8A6-8845-BD4E-CB4CCA059FC4}" type="datetimeFigureOut">
               <a:rPr lang="en-US" smtClean="0"/>
-              <a:t>1/27/13</a:t>
+              <a:t>7/9/2026</a:t>
             </a:fld>
             <a:endParaRPr lang="en-US"/>
           </a:p>
@@ -1160,10 +1167,9 @@
           <a:lstStyle/>
           <a:p>
             <a:r>
-              <a:rPr lang="en-US" smtClean="0"/>
+              <a:rPr lang="en-US"/>
               <a:t>Click to edit Master title style</a:t>
             </a:r>
-            <a:endParaRPr lang="en-US"/>
           </a:p>
         </p:txBody>
       </p:sp>
@@ -1217,38 +1223,37 @@
           <a:p>
             <a:pPr lvl="0"/>
             <a:r>
-              <a:rPr lang="en-US" smtClean="0"/>
+              <a:rPr lang="en-US"/>
               <a:t>Click to edit Master text styles</a:t>
             </a:r>
           </a:p>
           <a:p>
             <a:pPr lvl="1"/>
             <a:r>
-              <a:rPr lang="en-US" smtClean="0"/>
+              <a:rPr lang="en-US"/>
               <a:t>Second level</a:t>
             </a:r>
           </a:p>
           <a:p>
             <a:pPr lvl="2"/>
             <a:r>
-              <a:rPr lang="en-US" smtClean="0"/>
+              <a:rPr lang="en-US"/>
               <a:t>Third level</a:t>
             </a:r>
           </a:p>
           <a:p>
             <a:pPr lvl="3"/>
             <a:r>
-              <a:rPr lang="en-US" smtClean="0"/>
+              <a:rPr lang="en-US"/>
               <a:t>Fourth level</a:t>
             </a:r>
           </a:p>
           <a:p>
             <a:pPr lvl="4"/>
             <a:r>
-              <a:rPr lang="en-US" smtClean="0"/>
+              <a:rPr lang="en-US"/>
               <a:t>Fifth level</a:t>
             </a:r>
-            <a:endParaRPr lang="en-US"/>
           </a:p>
         </p:txBody>
       </p:sp>
@@ -1302,38 +1307,37 @@
           <a:p>
             <a:pPr lvl="0"/>
             <a:r>
-              <a:rPr lang="en-US" smtClean="0"/>
+              <a:rPr lang="en-US"/>
               <a:t>Click to edit Master text styles</a:t>
             </a:r>
           </a:p>
           <a:p>
             <a:pPr lvl="1"/>
             <a:r>
-              <a:rPr lang="en-US" smtClean="0"/>
+              <a:rPr lang="en-US"/>
               <a:t>Second level</a:t>
             </a:r>
           </a:p>
           <a:p>
             <a:pPr lvl="2"/>
             <a:r>
-              <a:rPr lang="en-US" smtClean="0"/>
+              <a:rPr lang="en-US"/>
               <a:t>Third level</a:t>
             </a:r>
           </a:p>
           <a:p>
             <a:pPr lvl="3"/>
             <a:r>
-              <a:rPr lang="en-US" smtClean="0"/>
+              <a:rPr lang="en-US"/>
               <a:t>Fourth level</a:t>
             </a:r>
           </a:p>
           <a:p>
             <a:pPr lvl="4"/>
             <a:r>
-              <a:rPr lang="en-US" smtClean="0"/>
+              <a:rPr lang="en-US"/>
               <a:t>Fifth level</a:t>
             </a:r>
-            <a:endParaRPr lang="en-US"/>
           </a:p>
         </p:txBody>
       </p:sp>
@@ -1354,7 +1358,7 @@
           <a:p>
             <a:fld id="{5BCAD085-E8A6-8845-BD4E-CB4CCA059FC4}" type="datetimeFigureOut">
               <a:rPr lang="en-US" smtClean="0"/>
-              <a:t>1/27/13</a:t>
+              <a:t>7/9/2026</a:t>
             </a:fld>
             <a:endParaRPr lang="en-US"/>
           </a:p>
@@ -1452,10 +1456,9 @@
           </a:lstStyle>
           <a:p>
             <a:r>
-              <a:rPr lang="en-US" smtClean="0"/>
+              <a:rPr lang="en-US"/>
               <a:t>Click to edit Master title style</a:t>
             </a:r>
-            <a:endParaRPr lang="en-US"/>
           </a:p>
         </p:txBody>
       </p:sp>
@@ -1518,7 +1521,7 @@
           <a:p>
             <a:pPr lvl="0"/>
             <a:r>
-              <a:rPr lang="en-US" smtClean="0"/>
+              <a:rPr lang="en-US"/>
               <a:t>Click to edit Master text styles</a:t>
             </a:r>
           </a:p>
@@ -1574,38 +1577,37 @@
           <a:p>
             <a:pPr lvl="0"/>
             <a:r>
-              <a:rPr lang="en-US" smtClean="0"/>
+              <a:rPr lang="en-US"/>
               <a:t>Click to edit Master text styles</a:t>
             </a:r>
           </a:p>
           <a:p>
             <a:pPr lvl="1"/>
             <a:r>
-              <a:rPr lang="en-US" smtClean="0"/>
+              <a:rPr lang="en-US"/>
               <a:t>Second level</a:t>
             </a:r>
           </a:p>
           <a:p>
             <a:pPr lvl="2"/>
             <a:r>
-              <a:rPr lang="en-US" smtClean="0"/>
+              <a:rPr lang="en-US"/>
               <a:t>Third level</a:t>
             </a:r>
           </a:p>
           <a:p>
             <a:pPr lvl="3"/>
             <a:r>
-              <a:rPr lang="en-US" smtClean="0"/>
+              <a:rPr lang="en-US"/>
               <a:t>Fourth level</a:t>
             </a:r>
           </a:p>
           <a:p>
             <a:pPr lvl="4"/>
             <a:r>
-              <a:rPr lang="en-US" smtClean="0"/>
+              <a:rPr lang="en-US"/>
               <a:t>Fifth level</a:t>
             </a:r>
-            <a:endParaRPr lang="en-US"/>
           </a:p>
         </p:txBody>
       </p:sp>
@@ -1668,7 +1670,7 @@
           <a:p>
             <a:pPr lvl="0"/>
             <a:r>
-              <a:rPr lang="en-US" smtClean="0"/>
+              <a:rPr lang="en-US"/>
               <a:t>Click to edit Master text styles</a:t>
             </a:r>
           </a:p>
@@ -1724,38 +1726,37 @@
           <a:p>
             <a:pPr lvl="0"/>
             <a:r>
-              <a:rPr lang="en-US" smtClean="0"/>
+              <a:rPr lang="en-US"/>
               <a:t>Click to edit Master text styles</a:t>
             </a:r>
           </a:p>
           <a:p>
             <a:pPr lvl="1"/>
             <a:r>
-              <a:rPr lang="en-US" smtClean="0"/>
+              <a:rPr lang="en-US"/>
               <a:t>Second level</a:t>
             </a:r>
           </a:p>
           <a:p>
             <a:pPr lvl="2"/>
             <a:r>
-              <a:rPr lang="en-US" smtClean="0"/>
+              <a:rPr lang="en-US"/>
               <a:t>Third level</a:t>
             </a:r>
           </a:p>
           <a:p>
             <a:pPr lvl="3"/>
             <a:r>
-              <a:rPr lang="en-US" smtClean="0"/>
+              <a:rPr lang="en-US"/>
               <a:t>Fourth level</a:t>
             </a:r>
           </a:p>
           <a:p>
             <a:pPr lvl="4"/>
             <a:r>
-              <a:rPr lang="en-US" smtClean="0"/>
+              <a:rPr lang="en-US"/>
               <a:t>Fifth level</a:t>
             </a:r>
-            <a:endParaRPr lang="en-US"/>
           </a:p>
         </p:txBody>
       </p:sp>
@@ -1776,7 +1777,7 @@
           <a:p>
             <a:fld id="{5BCAD085-E8A6-8845-BD4E-CB4CCA059FC4}" type="datetimeFigureOut">
               <a:rPr lang="en-US" smtClean="0"/>
-              <a:t>1/27/13</a:t>
+              <a:t>7/9/2026</a:t>
             </a:fld>
             <a:endParaRPr lang="en-US"/>
           </a:p>
@@ -1870,10 +1871,9 @@
           <a:lstStyle/>
           <a:p>
             <a:r>
-              <a:rPr lang="en-US" smtClean="0"/>
+              <a:rPr lang="en-US"/>
               <a:t>Click to edit Master title style</a:t>
             </a:r>
-            <a:endParaRPr lang="en-US"/>
           </a:p>
         </p:txBody>
       </p:sp>
@@ -1894,7 +1894,7 @@
           <a:p>
             <a:fld id="{5BCAD085-E8A6-8845-BD4E-CB4CCA059FC4}" type="datetimeFigureOut">
               <a:rPr lang="en-US" smtClean="0"/>
-              <a:t>1/27/13</a:t>
+              <a:t>7/9/2026</a:t>
             </a:fld>
             <a:endParaRPr lang="en-US"/>
           </a:p>
@@ -1989,7 +1989,7 @@
           <a:p>
             <a:fld id="{5BCAD085-E8A6-8845-BD4E-CB4CCA059FC4}" type="datetimeFigureOut">
               <a:rPr lang="en-US" smtClean="0"/>
-              <a:t>1/27/13</a:t>
+              <a:t>7/9/2026</a:t>
             </a:fld>
             <a:endParaRPr lang="en-US"/>
           </a:p>
@@ -2092,10 +2092,9 @@
           </a:lstStyle>
           <a:p>
             <a:r>
-              <a:rPr lang="en-US" smtClean="0"/>
+              <a:rPr lang="en-US"/>
               <a:t>Click to edit Master title style</a:t>
             </a:r>
-            <a:endParaRPr lang="en-US"/>
           </a:p>
         </p:txBody>
       </p:sp>
@@ -2149,38 +2148,37 @@
           <a:p>
             <a:pPr lvl="0"/>
             <a:r>
-              <a:rPr lang="en-US" smtClean="0"/>
+              <a:rPr lang="en-US"/>
               <a:t>Click to edit Master text styles</a:t>
             </a:r>
           </a:p>
           <a:p>
             <a:pPr lvl="1"/>
             <a:r>
-              <a:rPr lang="en-US" smtClean="0"/>
+              <a:rPr lang="en-US"/>
               <a:t>Second level</a:t>
             </a:r>
           </a:p>
           <a:p>
             <a:pPr lvl="2"/>
             <a:r>
-              <a:rPr lang="en-US" smtClean="0"/>
+              <a:rPr lang="en-US"/>
               <a:t>Third level</a:t>
             </a:r>
           </a:p>
           <a:p>
             <a:pPr lvl="3"/>
             <a:r>
-              <a:rPr lang="en-US" smtClean="0"/>
+              <a:rPr lang="en-US"/>
               <a:t>Fourth level</a:t>
             </a:r>
           </a:p>
           <a:p>
             <a:pPr lvl="4"/>
             <a:r>
-              <a:rPr lang="en-US" smtClean="0"/>
+              <a:rPr lang="en-US"/>
               <a:t>Fifth level</a:t>
             </a:r>
-            <a:endParaRPr lang="en-US"/>
           </a:p>
         </p:txBody>
       </p:sp>
@@ -2243,7 +2241,7 @@
           <a:p>
             <a:pPr lvl="0"/>
             <a:r>
-              <a:rPr lang="en-US" smtClean="0"/>
+              <a:rPr lang="en-US"/>
               <a:t>Click to edit Master text styles</a:t>
             </a:r>
           </a:p>
@@ -2266,7 +2264,7 @@
           <a:p>
             <a:fld id="{5BCAD085-E8A6-8845-BD4E-CB4CCA059FC4}" type="datetimeFigureOut">
               <a:rPr lang="en-US" smtClean="0"/>
-              <a:t>1/27/13</a:t>
+              <a:t>7/9/2026</a:t>
             </a:fld>
             <a:endParaRPr lang="en-US"/>
           </a:p>
@@ -2369,10 +2367,9 @@
           </a:lstStyle>
           <a:p>
             <a:r>
-              <a:rPr lang="en-US" smtClean="0"/>
+              <a:rPr lang="en-US"/>
               <a:t>Click to edit Master title style</a:t>
             </a:r>
-            <a:endParaRPr lang="en-US"/>
           </a:p>
         </p:txBody>
       </p:sp>
@@ -2496,7 +2493,7 @@
           <a:p>
             <a:pPr lvl="0"/>
             <a:r>
-              <a:rPr lang="en-US" smtClean="0"/>
+              <a:rPr lang="en-US"/>
               <a:t>Click to edit Master text styles</a:t>
             </a:r>
           </a:p>
@@ -2519,7 +2516,7 @@
           <a:p>
             <a:fld id="{5BCAD085-E8A6-8845-BD4E-CB4CCA059FC4}" type="datetimeFigureOut">
               <a:rPr lang="en-US" smtClean="0"/>
-              <a:t>1/27/13</a:t>
+              <a:t>7/9/2026</a:t>
             </a:fld>
             <a:endParaRPr lang="en-US"/>
           </a:p>
@@ -2628,10 +2625,9 @@
           <a:lstStyle/>
           <a:p>
             <a:r>
-              <a:rPr lang="en-US" smtClean="0"/>
+              <a:rPr lang="en-US"/>
               <a:t>Click to edit Master title style</a:t>
             </a:r>
-            <a:endParaRPr lang="en-US"/>
           </a:p>
         </p:txBody>
       </p:sp>
@@ -2662,38 +2658,37 @@
           <a:p>
             <a:pPr lvl="0"/>
             <a:r>
-              <a:rPr lang="en-US" smtClean="0"/>
+              <a:rPr lang="en-US"/>
               <a:t>Click to edit Master text styles</a:t>
             </a:r>
           </a:p>
           <a:p>
             <a:pPr lvl="1"/>
             <a:r>
-              <a:rPr lang="en-US" smtClean="0"/>
+              <a:rPr lang="en-US"/>
               <a:t>Second level</a:t>
             </a:r>
           </a:p>
           <a:p>
             <a:pPr lvl="2"/>
             <a:r>
-              <a:rPr lang="en-US" smtClean="0"/>
+              <a:rPr lang="en-US"/>
               <a:t>Third level</a:t>
             </a:r>
           </a:p>
           <a:p>
             <a:pPr lvl="3"/>
             <a:r>
-              <a:rPr lang="en-US" smtClean="0"/>
+              <a:rPr lang="en-US"/>
               <a:t>Fourth level</a:t>
             </a:r>
           </a:p>
           <a:p>
             <a:pPr lvl="4"/>
             <a:r>
-              <a:rPr lang="en-US" smtClean="0"/>
+              <a:rPr lang="en-US"/>
               <a:t>Fifth level</a:t>
             </a:r>
-            <a:endParaRPr lang="en-US"/>
           </a:p>
         </p:txBody>
       </p:sp>
@@ -2732,7 +2727,7 @@
           <a:p>
             <a:fld id="{5BCAD085-E8A6-8845-BD4E-CB4CCA059FC4}" type="datetimeFigureOut">
               <a:rPr lang="en-US" smtClean="0"/>
-              <a:t>1/27/13</a:t>
+              <a:t>7/9/2026</a:t>
             </a:fld>
             <a:endParaRPr lang="en-US"/>
           </a:p>
@@ -3091,7 +3086,7 @@
 </file>
 
 <file path=ppt/slides/slide1.xml><?xml version="1.0" encoding="utf-8"?>
-<p:sld xmlns:a="http://schemas.openxmlformats.org/drawingml/2006/main" xmlns:p="http://schemas.openxmlformats.org/presentationml/2006/main" xmlns:r="http://schemas.openxmlformats.org/officeDocument/2006/relationships">
+<p:sld xmlns:a="http://schemas.openxmlformats.org/drawingml/2006/main" xmlns:r="http://schemas.openxmlformats.org/officeDocument/2006/relationships" xmlns:p="http://schemas.openxmlformats.org/presentationml/2006/main">
   <p:cSld>
     <p:bg>
       <p:bgPr>
@@ -3107,7 +3102,14 @@
         <p:cNvGrpSpPr/>
         <p:nvPr/>
       </p:nvGrpSpPr>
-      <p:grpSpPr/>
+      <p:grpSpPr>
+        <a:xfrm>
+          <a:off x="0" y="0"/>
+          <a:ext cx="0" cy="0"/>
+          <a:chOff x="0" y="0"/>
+          <a:chExt cx="0" cy="0"/>
+        </a:xfrm>
+      </p:grpSpPr>
       <p:sp>
         <p:nvSpPr>
           <p:cNvPr id="2" name="Rectangle 1"/>
@@ -3148,6 +3150,7 @@
           <a:lstStyle/>
           <a:p>
             <a:pPr algn="ctr"/>
+            <a:endParaRPr/>
           </a:p>
         </p:txBody>
       </p:sp>
@@ -3191,6 +3194,7 @@
           <a:lstStyle/>
           <a:p>
             <a:pPr algn="ctr"/>
+            <a:endParaRPr/>
           </a:p>
         </p:txBody>
       </p:sp>
@@ -3234,6 +3238,7 @@
           <a:lstStyle/>
           <a:p>
             <a:pPr algn="ctr"/>
+            <a:endParaRPr/>
           </a:p>
         </p:txBody>
       </p:sp>
@@ -3450,6 +3455,7 @@
           <a:lstStyle/>
           <a:p>
             <a:pPr algn="ctr"/>
+            <a:endParaRPr/>
           </a:p>
         </p:txBody>
       </p:sp>
@@ -3493,6 +3499,7 @@
           <a:lstStyle/>
           <a:p>
             <a:pPr algn="ctr"/>
+            <a:endParaRPr/>
           </a:p>
         </p:txBody>
       </p:sp>
@@ -3604,6 +3611,7 @@
           <a:lstStyle/>
           <a:p>
             <a:pPr algn="ctr"/>
+            <a:endParaRPr/>
           </a:p>
         </p:txBody>
       </p:sp>
@@ -3647,6 +3655,7 @@
           <a:lstStyle/>
           <a:p>
             <a:pPr algn="ctr"/>
+            <a:endParaRPr/>
           </a:p>
         </p:txBody>
       </p:sp>
@@ -3758,6 +3767,7 @@
           <a:lstStyle/>
           <a:p>
             <a:pPr algn="ctr"/>
+            <a:endParaRPr/>
           </a:p>
         </p:txBody>
       </p:sp>
@@ -3801,6 +3811,7 @@
           <a:lstStyle/>
           <a:p>
             <a:pPr algn="ctr"/>
+            <a:endParaRPr/>
           </a:p>
         </p:txBody>
       </p:sp>
@@ -3912,6 +3923,7 @@
           <a:lstStyle/>
           <a:p>
             <a:pPr algn="ctr"/>
+            <a:endParaRPr/>
           </a:p>
         </p:txBody>
       </p:sp>
@@ -3955,6 +3967,7 @@
           <a:lstStyle/>
           <a:p>
             <a:pPr algn="ctr"/>
+            <a:endParaRPr/>
           </a:p>
         </p:txBody>
       </p:sp>
@@ -4032,6 +4045,7 @@
           <a:lstStyle/>
           <a:p>
             <a:pPr algn="ctr"/>
+            <a:endParaRPr/>
           </a:p>
         </p:txBody>
       </p:sp>
@@ -4075,6 +4089,7 @@
           <a:lstStyle/>
           <a:p>
             <a:pPr algn="ctr"/>
+            <a:endParaRPr/>
           </a:p>
         </p:txBody>
       </p:sp>
@@ -4186,6 +4201,7 @@
           <a:lstStyle/>
           <a:p>
             <a:pPr algn="ctr"/>
+            <a:endParaRPr/>
           </a:p>
         </p:txBody>
       </p:sp>
@@ -4229,6 +4245,7 @@
           <a:lstStyle/>
           <a:p>
             <a:pPr algn="ctr"/>
+            <a:endParaRPr/>
           </a:p>
         </p:txBody>
       </p:sp>
@@ -4340,6 +4357,7 @@
           <a:lstStyle/>
           <a:p>
             <a:pPr algn="ctr"/>
+            <a:endParaRPr/>
           </a:p>
         </p:txBody>
       </p:sp>
@@ -4383,6 +4401,7 @@
           <a:lstStyle/>
           <a:p>
             <a:pPr algn="ctr"/>
+            <a:endParaRPr/>
           </a:p>
         </p:txBody>
       </p:sp>
@@ -4494,6 +4513,7 @@
           <a:lstStyle/>
           <a:p>
             <a:pPr algn="ctr"/>
+            <a:endParaRPr/>
           </a:p>
         </p:txBody>
       </p:sp>
@@ -4571,6 +4591,7 @@
           <a:lstStyle/>
           <a:p>
             <a:pPr algn="ctr"/>
+            <a:endParaRPr/>
           </a:p>
         </p:txBody>
       </p:sp>
@@ -4614,6 +4635,7 @@
           <a:lstStyle/>
           <a:p>
             <a:pPr algn="ctr"/>
+            <a:endParaRPr/>
           </a:p>
         </p:txBody>
       </p:sp>
@@ -4657,6 +4679,7 @@
           <a:lstStyle/>
           <a:p>
             <a:pPr algn="ctr"/>
+            <a:endParaRPr/>
           </a:p>
         </p:txBody>
       </p:sp>
@@ -4700,6 +4723,7 @@
           <a:lstStyle/>
           <a:p>
             <a:pPr algn="ctr"/>
+            <a:endParaRPr/>
           </a:p>
         </p:txBody>
       </p:sp>
@@ -4743,6 +4767,7 @@
           <a:lstStyle/>
           <a:p>
             <a:pPr algn="ctr"/>
+            <a:endParaRPr/>
           </a:p>
         </p:txBody>
       </p:sp>
@@ -4786,6 +4811,7 @@
           <a:lstStyle/>
           <a:p>
             <a:pPr algn="ctr"/>
+            <a:endParaRPr/>
           </a:p>
         </p:txBody>
       </p:sp>
@@ -4829,6 +4855,7 @@
           <a:lstStyle/>
           <a:p>
             <a:pPr algn="ctr"/>
+            <a:endParaRPr/>
           </a:p>
         </p:txBody>
       </p:sp>
@@ -4872,6 +4899,7 @@
           <a:lstStyle/>
           <a:p>
             <a:pPr algn="ctr"/>
+            <a:endParaRPr/>
           </a:p>
         </p:txBody>
       </p:sp>
@@ -4915,6 +4943,7 @@
           <a:lstStyle/>
           <a:p>
             <a:pPr algn="ctr"/>
+            <a:endParaRPr/>
           </a:p>
         </p:txBody>
       </p:sp>
@@ -4958,6 +4987,7 @@
           <a:lstStyle/>
           <a:p>
             <a:pPr algn="ctr"/>
+            <a:endParaRPr/>
           </a:p>
         </p:txBody>
       </p:sp>
@@ -5001,6 +5031,7 @@
           <a:lstStyle/>
           <a:p>
             <a:pPr algn="ctr"/>
+            <a:endParaRPr/>
           </a:p>
         </p:txBody>
       </p:sp>
@@ -5044,6 +5075,7 @@
           <a:lstStyle/>
           <a:p>
             <a:pPr algn="ctr"/>
+            <a:endParaRPr/>
           </a:p>
         </p:txBody>
       </p:sp>
@@ -5087,6 +5119,7 @@
           <a:lstStyle/>
           <a:p>
             <a:pPr algn="ctr"/>
+            <a:endParaRPr/>
           </a:p>
         </p:txBody>
       </p:sp>
@@ -5164,6 +5197,7 @@
           <a:lstStyle/>
           <a:p>
             <a:pPr algn="ctr"/>
+            <a:endParaRPr/>
           </a:p>
         </p:txBody>
       </p:sp>
@@ -5241,6 +5275,7 @@
           <a:lstStyle/>
           <a:p>
             <a:pPr algn="ctr"/>
+            <a:endParaRPr/>
           </a:p>
         </p:txBody>
       </p:sp>
@@ -5318,6 +5353,7 @@
           <a:lstStyle/>
           <a:p>
             <a:pPr algn="ctr"/>
+            <a:endParaRPr/>
           </a:p>
         </p:txBody>
       </p:sp>
@@ -5398,7 +5434,7 @@
 </file>
 
 <file path=ppt/slides/slide10.xml><?xml version="1.0" encoding="utf-8"?>
-<p:sld xmlns:a="http://schemas.openxmlformats.org/drawingml/2006/main" xmlns:p="http://schemas.openxmlformats.org/presentationml/2006/main" xmlns:r="http://schemas.openxmlformats.org/officeDocument/2006/relationships">
+<p:sld xmlns:a="http://schemas.openxmlformats.org/drawingml/2006/main" xmlns:r="http://schemas.openxmlformats.org/officeDocument/2006/relationships" xmlns:p="http://schemas.openxmlformats.org/presentationml/2006/main">
   <p:cSld>
     <p:bg>
       <p:bgPr>
@@ -5414,7 +5450,14 @@
         <p:cNvGrpSpPr/>
         <p:nvPr/>
       </p:nvGrpSpPr>
-      <p:grpSpPr/>
+      <p:grpSpPr>
+        <a:xfrm>
+          <a:off x="0" y="0"/>
+          <a:ext cx="0" cy="0"/>
+          <a:chOff x="0" y="0"/>
+          <a:chExt cx="0" cy="0"/>
+        </a:xfrm>
+      </p:grpSpPr>
       <p:sp>
         <p:nvSpPr>
           <p:cNvPr id="2" name="Rectangle 1"/>
@@ -5455,6 +5498,7 @@
           <a:lstStyle/>
           <a:p>
             <a:pPr algn="ctr"/>
+            <a:endParaRPr/>
           </a:p>
         </p:txBody>
       </p:sp>
@@ -5498,6 +5542,7 @@
           <a:lstStyle/>
           <a:p>
             <a:pPr algn="ctr"/>
+            <a:endParaRPr/>
           </a:p>
         </p:txBody>
       </p:sp>
@@ -5609,6 +5654,7 @@
           <a:lstStyle/>
           <a:p>
             <a:pPr algn="ctr"/>
+            <a:endParaRPr/>
           </a:p>
         </p:txBody>
       </p:sp>
@@ -5686,6 +5732,7 @@
           <a:lstStyle/>
           <a:p>
             <a:pPr algn="ctr"/>
+            <a:endParaRPr/>
           </a:p>
         </p:txBody>
       </p:sp>
@@ -5729,6 +5776,7 @@
           <a:lstStyle/>
           <a:p>
             <a:pPr algn="ctr"/>
+            <a:endParaRPr/>
           </a:p>
         </p:txBody>
       </p:sp>
@@ -5806,6 +5854,7 @@
           <a:lstStyle/>
           <a:p>
             <a:pPr algn="ctr"/>
+            <a:endParaRPr/>
           </a:p>
         </p:txBody>
       </p:sp>
@@ -5917,6 +5966,7 @@
           <a:lstStyle/>
           <a:p>
             <a:pPr algn="ctr"/>
+            <a:endParaRPr/>
           </a:p>
         </p:txBody>
       </p:sp>
@@ -6028,6 +6078,7 @@
           <a:lstStyle/>
           <a:p>
             <a:pPr algn="ctr"/>
+            <a:endParaRPr/>
           </a:p>
         </p:txBody>
       </p:sp>
@@ -6139,6 +6190,7 @@
           <a:lstStyle/>
           <a:p>
             <a:pPr algn="ctr"/>
+            <a:endParaRPr/>
           </a:p>
         </p:txBody>
       </p:sp>
@@ -6250,6 +6302,7 @@
           <a:lstStyle/>
           <a:p>
             <a:pPr algn="ctr"/>
+            <a:endParaRPr/>
           </a:p>
         </p:txBody>
       </p:sp>
@@ -6361,6 +6414,7 @@
           <a:lstStyle/>
           <a:p>
             <a:pPr algn="ctr"/>
+            <a:endParaRPr/>
           </a:p>
         </p:txBody>
       </p:sp>
@@ -6472,6 +6526,7 @@
           <a:lstStyle/>
           <a:p>
             <a:pPr algn="ctr"/>
+            <a:endParaRPr/>
           </a:p>
         </p:txBody>
       </p:sp>
@@ -6515,6 +6570,7 @@
           <a:lstStyle/>
           <a:p>
             <a:pPr algn="ctr"/>
+            <a:endParaRPr/>
           </a:p>
         </p:txBody>
       </p:sp>
@@ -6592,6 +6648,7 @@
           <a:lstStyle/>
           <a:p>
             <a:pPr algn="ctr"/>
+            <a:endParaRPr/>
           </a:p>
         </p:txBody>
       </p:sp>
@@ -6703,6 +6760,7 @@
           <a:lstStyle/>
           <a:p>
             <a:pPr algn="ctr"/>
+            <a:endParaRPr/>
           </a:p>
         </p:txBody>
       </p:sp>
@@ -6814,6 +6872,7 @@
           <a:lstStyle/>
           <a:p>
             <a:pPr algn="ctr"/>
+            <a:endParaRPr/>
           </a:p>
         </p:txBody>
       </p:sp>
@@ -6925,6 +6984,7 @@
           <a:lstStyle/>
           <a:p>
             <a:pPr algn="ctr"/>
+            <a:endParaRPr/>
           </a:p>
         </p:txBody>
       </p:sp>
@@ -7036,6 +7096,7 @@
           <a:lstStyle/>
           <a:p>
             <a:pPr algn="ctr"/>
+            <a:endParaRPr/>
           </a:p>
         </p:txBody>
       </p:sp>
@@ -7147,6 +7208,7 @@
           <a:lstStyle/>
           <a:p>
             <a:pPr algn="ctr"/>
+            <a:endParaRPr/>
           </a:p>
         </p:txBody>
       </p:sp>
@@ -7258,6 +7320,7 @@
           <a:lstStyle/>
           <a:p>
             <a:pPr algn="ctr"/>
+            <a:endParaRPr/>
           </a:p>
         </p:txBody>
       </p:sp>
@@ -7301,6 +7364,7 @@
           <a:lstStyle/>
           <a:p>
             <a:pPr algn="ctr"/>
+            <a:endParaRPr/>
           </a:p>
         </p:txBody>
       </p:sp>
@@ -7378,6 +7442,7 @@
           <a:lstStyle/>
           <a:p>
             <a:pPr algn="ctr"/>
+            <a:endParaRPr/>
           </a:p>
         </p:txBody>
       </p:sp>
@@ -7489,6 +7554,7 @@
           <a:lstStyle/>
           <a:p>
             <a:pPr algn="ctr"/>
+            <a:endParaRPr/>
           </a:p>
         </p:txBody>
       </p:sp>
@@ -7600,6 +7666,7 @@
           <a:lstStyle/>
           <a:p>
             <a:pPr algn="ctr"/>
+            <a:endParaRPr/>
           </a:p>
         </p:txBody>
       </p:sp>
@@ -7711,6 +7778,7 @@
           <a:lstStyle/>
           <a:p>
             <a:pPr algn="ctr"/>
+            <a:endParaRPr/>
           </a:p>
         </p:txBody>
       </p:sp>
@@ -7822,6 +7890,7 @@
           <a:lstStyle/>
           <a:p>
             <a:pPr algn="ctr"/>
+            <a:endParaRPr/>
           </a:p>
         </p:txBody>
       </p:sp>
@@ -7933,6 +8002,7 @@
           <a:lstStyle/>
           <a:p>
             <a:pPr algn="ctr"/>
+            <a:endParaRPr/>
           </a:p>
         </p:txBody>
       </p:sp>
@@ -8013,7 +8083,7 @@
 </file>
 
 <file path=ppt/slides/slide11.xml><?xml version="1.0" encoding="utf-8"?>
-<p:sld xmlns:a="http://schemas.openxmlformats.org/drawingml/2006/main" xmlns:p="http://schemas.openxmlformats.org/presentationml/2006/main" xmlns:r="http://schemas.openxmlformats.org/officeDocument/2006/relationships">
+<p:sld xmlns:a="http://schemas.openxmlformats.org/drawingml/2006/main" xmlns:r="http://schemas.openxmlformats.org/officeDocument/2006/relationships" xmlns:p="http://schemas.openxmlformats.org/presentationml/2006/main">
   <p:cSld>
     <p:bg>
       <p:bgPr>
@@ -8029,7 +8099,14 @@
         <p:cNvGrpSpPr/>
         <p:nvPr/>
       </p:nvGrpSpPr>
-      <p:grpSpPr/>
+      <p:grpSpPr>
+        <a:xfrm>
+          <a:off x="0" y="0"/>
+          <a:ext cx="0" cy="0"/>
+          <a:chOff x="0" y="0"/>
+          <a:chExt cx="0" cy="0"/>
+        </a:xfrm>
+      </p:grpSpPr>
       <p:sp>
         <p:nvSpPr>
           <p:cNvPr id="2" name="Rectangle 1"/>
@@ -8070,6 +8147,7 @@
           <a:lstStyle/>
           <a:p>
             <a:pPr algn="ctr"/>
+            <a:endParaRPr/>
           </a:p>
         </p:txBody>
       </p:sp>
@@ -8113,6 +8191,7 @@
           <a:lstStyle/>
           <a:p>
             <a:pPr algn="ctr"/>
+            <a:endParaRPr/>
           </a:p>
         </p:txBody>
       </p:sp>
@@ -8224,6 +8303,7 @@
           <a:lstStyle/>
           <a:p>
             <a:pPr algn="ctr"/>
+            <a:endParaRPr/>
           </a:p>
         </p:txBody>
       </p:sp>
@@ -8335,6 +8415,7 @@
           <a:lstStyle/>
           <a:p>
             <a:pPr algn="ctr"/>
+            <a:endParaRPr/>
           </a:p>
         </p:txBody>
       </p:sp>
@@ -8378,6 +8459,7 @@
           <a:lstStyle/>
           <a:p>
             <a:pPr algn="ctr"/>
+            <a:endParaRPr/>
           </a:p>
         </p:txBody>
       </p:sp>
@@ -8421,6 +8503,7 @@
           <a:lstStyle/>
           <a:p>
             <a:pPr algn="ctr"/>
+            <a:endParaRPr/>
           </a:p>
         </p:txBody>
       </p:sp>
@@ -8566,6 +8649,7 @@
           <a:lstStyle/>
           <a:p>
             <a:pPr algn="ctr"/>
+            <a:endParaRPr/>
           </a:p>
         </p:txBody>
       </p:sp>
@@ -8609,6 +8693,7 @@
           <a:lstStyle/>
           <a:p>
             <a:pPr algn="ctr"/>
+            <a:endParaRPr/>
           </a:p>
         </p:txBody>
       </p:sp>
@@ -8652,6 +8737,7 @@
           <a:lstStyle/>
           <a:p>
             <a:pPr algn="ctr"/>
+            <a:endParaRPr/>
           </a:p>
         </p:txBody>
       </p:sp>
@@ -8797,6 +8883,7 @@
           <a:lstStyle/>
           <a:p>
             <a:pPr algn="ctr"/>
+            <a:endParaRPr/>
           </a:p>
         </p:txBody>
       </p:sp>
@@ -8840,6 +8927,7 @@
           <a:lstStyle/>
           <a:p>
             <a:pPr algn="ctr"/>
+            <a:endParaRPr/>
           </a:p>
         </p:txBody>
       </p:sp>
@@ -8883,6 +8971,7 @@
           <a:lstStyle/>
           <a:p>
             <a:pPr algn="ctr"/>
+            <a:endParaRPr/>
           </a:p>
         </p:txBody>
       </p:sp>
@@ -9028,6 +9117,7 @@
           <a:lstStyle/>
           <a:p>
             <a:pPr algn="ctr"/>
+            <a:endParaRPr/>
           </a:p>
         </p:txBody>
       </p:sp>
@@ -9071,6 +9161,7 @@
           <a:lstStyle/>
           <a:p>
             <a:pPr algn="ctr"/>
+            <a:endParaRPr/>
           </a:p>
         </p:txBody>
       </p:sp>
@@ -9114,6 +9205,7 @@
           <a:lstStyle/>
           <a:p>
             <a:pPr algn="ctr"/>
+            <a:endParaRPr/>
           </a:p>
         </p:txBody>
       </p:sp>
@@ -9259,6 +9351,7 @@
           <a:lstStyle/>
           <a:p>
             <a:pPr algn="ctr"/>
+            <a:endParaRPr/>
           </a:p>
         </p:txBody>
       </p:sp>
@@ -9302,6 +9395,7 @@
           <a:lstStyle/>
           <a:p>
             <a:pPr algn="ctr"/>
+            <a:endParaRPr/>
           </a:p>
         </p:txBody>
       </p:sp>
@@ -9345,6 +9439,7 @@
           <a:lstStyle/>
           <a:p>
             <a:pPr algn="ctr"/>
+            <a:endParaRPr/>
           </a:p>
         </p:txBody>
       </p:sp>
@@ -9524,6 +9619,7 @@
           <a:lstStyle/>
           <a:p>
             <a:pPr algn="ctr"/>
+            <a:endParaRPr/>
           </a:p>
         </p:txBody>
       </p:sp>
@@ -9567,6 +9663,7 @@
           <a:lstStyle/>
           <a:p>
             <a:pPr algn="ctr"/>
+            <a:endParaRPr/>
           </a:p>
         </p:txBody>
       </p:sp>
@@ -9746,6 +9843,7 @@
           <a:lstStyle/>
           <a:p>
             <a:pPr algn="ctr"/>
+            <a:endParaRPr/>
           </a:p>
         </p:txBody>
       </p:sp>
@@ -9789,6 +9887,7 @@
           <a:lstStyle/>
           <a:p>
             <a:pPr algn="ctr"/>
+            <a:endParaRPr/>
           </a:p>
         </p:txBody>
       </p:sp>
@@ -9968,6 +10067,7 @@
           <a:lstStyle/>
           <a:p>
             <a:pPr algn="ctr"/>
+            <a:endParaRPr/>
           </a:p>
         </p:txBody>
       </p:sp>
@@ -10011,6 +10111,7 @@
           <a:lstStyle/>
           <a:p>
             <a:pPr algn="ctr"/>
+            <a:endParaRPr/>
           </a:p>
         </p:txBody>
       </p:sp>
@@ -10190,6 +10291,7 @@
           <a:lstStyle/>
           <a:p>
             <a:pPr algn="ctr"/>
+            <a:endParaRPr/>
           </a:p>
         </p:txBody>
       </p:sp>
@@ -10233,6 +10335,7 @@
           <a:lstStyle/>
           <a:p>
             <a:pPr algn="ctr"/>
+            <a:endParaRPr/>
           </a:p>
         </p:txBody>
       </p:sp>
@@ -10381,7 +10484,7 @@
 </file>
 
 <file path=ppt/slides/slide12.xml><?xml version="1.0" encoding="utf-8"?>
-<p:sld xmlns:a="http://schemas.openxmlformats.org/drawingml/2006/main" xmlns:p="http://schemas.openxmlformats.org/presentationml/2006/main" xmlns:r="http://schemas.openxmlformats.org/officeDocument/2006/relationships">
+<p:sld xmlns:a="http://schemas.openxmlformats.org/drawingml/2006/main" xmlns:r="http://schemas.openxmlformats.org/officeDocument/2006/relationships" xmlns:p="http://schemas.openxmlformats.org/presentationml/2006/main">
   <p:cSld>
     <p:bg>
       <p:bgPr>
@@ -10397,7 +10500,14 @@
         <p:cNvGrpSpPr/>
         <p:nvPr/>
       </p:nvGrpSpPr>
-      <p:grpSpPr/>
+      <p:grpSpPr>
+        <a:xfrm>
+          <a:off x="0" y="0"/>
+          <a:ext cx="0" cy="0"/>
+          <a:chOff x="0" y="0"/>
+          <a:chExt cx="0" cy="0"/>
+        </a:xfrm>
+      </p:grpSpPr>
       <p:sp>
         <p:nvSpPr>
           <p:cNvPr id="2" name="Rectangle 1"/>
@@ -10438,6 +10548,7 @@
           <a:lstStyle/>
           <a:p>
             <a:pPr algn="ctr"/>
+            <a:endParaRPr/>
           </a:p>
         </p:txBody>
       </p:sp>
@@ -10481,6 +10592,7 @@
           <a:lstStyle/>
           <a:p>
             <a:pPr algn="ctr"/>
+            <a:endParaRPr/>
           </a:p>
         </p:txBody>
       </p:sp>
@@ -10592,6 +10704,7 @@
           <a:lstStyle/>
           <a:p>
             <a:pPr algn="ctr"/>
+            <a:endParaRPr/>
           </a:p>
         </p:txBody>
       </p:sp>
@@ -10669,6 +10782,7 @@
           <a:lstStyle/>
           <a:p>
             <a:pPr algn="ctr"/>
+            <a:endParaRPr/>
           </a:p>
         </p:txBody>
       </p:sp>
@@ -10712,6 +10826,7 @@
           <a:lstStyle/>
           <a:p>
             <a:pPr algn="ctr"/>
+            <a:endParaRPr/>
           </a:p>
         </p:txBody>
       </p:sp>
@@ -10789,6 +10904,7 @@
           <a:lstStyle/>
           <a:p>
             <a:pPr algn="ctr"/>
+            <a:endParaRPr/>
           </a:p>
         </p:txBody>
       </p:sp>
@@ -10832,6 +10948,7 @@
           <a:lstStyle/>
           <a:p>
             <a:pPr algn="ctr"/>
+            <a:endParaRPr/>
           </a:p>
         </p:txBody>
       </p:sp>
@@ -10943,6 +11060,7 @@
           <a:lstStyle/>
           <a:p>
             <a:pPr algn="ctr"/>
+            <a:endParaRPr/>
           </a:p>
         </p:txBody>
       </p:sp>
@@ -10986,6 +11104,7 @@
           <a:lstStyle/>
           <a:p>
             <a:pPr algn="ctr"/>
+            <a:endParaRPr/>
           </a:p>
         </p:txBody>
       </p:sp>
@@ -11097,6 +11216,7 @@
           <a:lstStyle/>
           <a:p>
             <a:pPr algn="ctr"/>
+            <a:endParaRPr/>
           </a:p>
         </p:txBody>
       </p:sp>
@@ -11140,6 +11260,7 @@
           <a:lstStyle/>
           <a:p>
             <a:pPr algn="ctr"/>
+            <a:endParaRPr/>
           </a:p>
         </p:txBody>
       </p:sp>
@@ -11251,6 +11372,7 @@
           <a:lstStyle/>
           <a:p>
             <a:pPr algn="ctr"/>
+            <a:endParaRPr/>
           </a:p>
         </p:txBody>
       </p:sp>
@@ -11294,6 +11416,7 @@
           <a:lstStyle/>
           <a:p>
             <a:pPr algn="ctr"/>
+            <a:endParaRPr/>
           </a:p>
         </p:txBody>
       </p:sp>
@@ -11405,6 +11528,7 @@
           <a:lstStyle/>
           <a:p>
             <a:pPr algn="ctr"/>
+            <a:endParaRPr/>
           </a:p>
         </p:txBody>
       </p:sp>
@@ -11448,6 +11572,7 @@
           <a:lstStyle/>
           <a:p>
             <a:pPr algn="ctr"/>
+            <a:endParaRPr/>
           </a:p>
         </p:txBody>
       </p:sp>
@@ -11559,6 +11684,7 @@
           <a:lstStyle/>
           <a:p>
             <a:pPr algn="ctr"/>
+            <a:endParaRPr/>
           </a:p>
         </p:txBody>
       </p:sp>
@@ -11602,6 +11728,7 @@
           <a:lstStyle/>
           <a:p>
             <a:pPr algn="ctr"/>
+            <a:endParaRPr/>
           </a:p>
         </p:txBody>
       </p:sp>
@@ -11713,6 +11840,7 @@
           <a:lstStyle/>
           <a:p>
             <a:pPr algn="ctr"/>
+            <a:endParaRPr/>
           </a:p>
         </p:txBody>
       </p:sp>
@@ -11756,6 +11884,7 @@
           <a:lstStyle/>
           <a:p>
             <a:pPr algn="ctr"/>
+            <a:endParaRPr/>
           </a:p>
         </p:txBody>
       </p:sp>
@@ -11833,6 +11962,7 @@
           <a:lstStyle/>
           <a:p>
             <a:pPr algn="ctr"/>
+            <a:endParaRPr/>
           </a:p>
         </p:txBody>
       </p:sp>
@@ -11876,6 +12006,7 @@
           <a:lstStyle/>
           <a:p>
             <a:pPr algn="ctr"/>
+            <a:endParaRPr/>
           </a:p>
         </p:txBody>
       </p:sp>
@@ -11987,6 +12118,7 @@
           <a:lstStyle/>
           <a:p>
             <a:pPr algn="ctr"/>
+            <a:endParaRPr/>
           </a:p>
         </p:txBody>
       </p:sp>
@@ -12030,6 +12162,7 @@
           <a:lstStyle/>
           <a:p>
             <a:pPr algn="ctr"/>
+            <a:endParaRPr/>
           </a:p>
         </p:txBody>
       </p:sp>
@@ -12141,6 +12274,7 @@
           <a:lstStyle/>
           <a:p>
             <a:pPr algn="ctr"/>
+            <a:endParaRPr/>
           </a:p>
         </p:txBody>
       </p:sp>
@@ -12184,6 +12318,7 @@
           <a:lstStyle/>
           <a:p>
             <a:pPr algn="ctr"/>
+            <a:endParaRPr/>
           </a:p>
         </p:txBody>
       </p:sp>
@@ -12295,6 +12430,7 @@
           <a:lstStyle/>
           <a:p>
             <a:pPr algn="ctr"/>
+            <a:endParaRPr/>
           </a:p>
         </p:txBody>
       </p:sp>
@@ -12338,6 +12474,7 @@
           <a:lstStyle/>
           <a:p>
             <a:pPr algn="ctr"/>
+            <a:endParaRPr/>
           </a:p>
         </p:txBody>
       </p:sp>
@@ -12449,6 +12586,7 @@
           <a:lstStyle/>
           <a:p>
             <a:pPr algn="ctr"/>
+            <a:endParaRPr/>
           </a:p>
         </p:txBody>
       </p:sp>
@@ -12492,6 +12630,7 @@
           <a:lstStyle/>
           <a:p>
             <a:pPr algn="ctr"/>
+            <a:endParaRPr/>
           </a:p>
         </p:txBody>
       </p:sp>
@@ -12603,6 +12742,7 @@
           <a:lstStyle/>
           <a:p>
             <a:pPr algn="ctr"/>
+            <a:endParaRPr/>
           </a:p>
         </p:txBody>
       </p:sp>
@@ -12646,6 +12786,7 @@
           <a:lstStyle/>
           <a:p>
             <a:pPr algn="ctr"/>
+            <a:endParaRPr/>
           </a:p>
         </p:txBody>
       </p:sp>
@@ -12757,6 +12898,7 @@
           <a:lstStyle/>
           <a:p>
             <a:pPr algn="ctr"/>
+            <a:endParaRPr/>
           </a:p>
         </p:txBody>
       </p:sp>
@@ -12800,6 +12942,7 @@
           <a:lstStyle/>
           <a:p>
             <a:pPr algn="ctr"/>
+            <a:endParaRPr/>
           </a:p>
         </p:txBody>
       </p:sp>
@@ -12877,6 +13020,7 @@
           <a:lstStyle/>
           <a:p>
             <a:pPr algn="ctr"/>
+            <a:endParaRPr/>
           </a:p>
         </p:txBody>
       </p:sp>
@@ -12920,6 +13064,7 @@
           <a:lstStyle/>
           <a:p>
             <a:pPr algn="ctr"/>
+            <a:endParaRPr/>
           </a:p>
         </p:txBody>
       </p:sp>
@@ -13031,6 +13176,7 @@
           <a:lstStyle/>
           <a:p>
             <a:pPr algn="ctr"/>
+            <a:endParaRPr/>
           </a:p>
         </p:txBody>
       </p:sp>
@@ -13074,6 +13220,7 @@
           <a:lstStyle/>
           <a:p>
             <a:pPr algn="ctr"/>
+            <a:endParaRPr/>
           </a:p>
         </p:txBody>
       </p:sp>
@@ -13185,6 +13332,7 @@
           <a:lstStyle/>
           <a:p>
             <a:pPr algn="ctr"/>
+            <a:endParaRPr/>
           </a:p>
         </p:txBody>
       </p:sp>
@@ -13228,6 +13376,7 @@
           <a:lstStyle/>
           <a:p>
             <a:pPr algn="ctr"/>
+            <a:endParaRPr/>
           </a:p>
         </p:txBody>
       </p:sp>
@@ -13339,6 +13488,7 @@
           <a:lstStyle/>
           <a:p>
             <a:pPr algn="ctr"/>
+            <a:endParaRPr/>
           </a:p>
         </p:txBody>
       </p:sp>
@@ -13382,6 +13532,7 @@
           <a:lstStyle/>
           <a:p>
             <a:pPr algn="ctr"/>
+            <a:endParaRPr/>
           </a:p>
         </p:txBody>
       </p:sp>
@@ -13493,6 +13644,7 @@
           <a:lstStyle/>
           <a:p>
             <a:pPr algn="ctr"/>
+            <a:endParaRPr/>
           </a:p>
         </p:txBody>
       </p:sp>
@@ -13536,6 +13688,7 @@
           <a:lstStyle/>
           <a:p>
             <a:pPr algn="ctr"/>
+            <a:endParaRPr/>
           </a:p>
         </p:txBody>
       </p:sp>
@@ -13647,6 +13800,7 @@
           <a:lstStyle/>
           <a:p>
             <a:pPr algn="ctr"/>
+            <a:endParaRPr/>
           </a:p>
         </p:txBody>
       </p:sp>
@@ -13690,6 +13844,7 @@
           <a:lstStyle/>
           <a:p>
             <a:pPr algn="ctr"/>
+            <a:endParaRPr/>
           </a:p>
         </p:txBody>
       </p:sp>
@@ -13770,7 +13925,7 @@
 </file>
 
 <file path=ppt/slides/slide13.xml><?xml version="1.0" encoding="utf-8"?>
-<p:sld xmlns:a="http://schemas.openxmlformats.org/drawingml/2006/main" xmlns:p="http://schemas.openxmlformats.org/presentationml/2006/main" xmlns:r="http://schemas.openxmlformats.org/officeDocument/2006/relationships">
+<p:sld xmlns:a="http://schemas.openxmlformats.org/drawingml/2006/main" xmlns:r="http://schemas.openxmlformats.org/officeDocument/2006/relationships" xmlns:p="http://schemas.openxmlformats.org/presentationml/2006/main">
   <p:cSld>
     <p:bg>
       <p:bgPr>
@@ -13786,7 +13941,14 @@
         <p:cNvGrpSpPr/>
         <p:nvPr/>
       </p:nvGrpSpPr>
-      <p:grpSpPr/>
+      <p:grpSpPr>
+        <a:xfrm>
+          <a:off x="0" y="0"/>
+          <a:ext cx="0" cy="0"/>
+          <a:chOff x="0" y="0"/>
+          <a:chExt cx="0" cy="0"/>
+        </a:xfrm>
+      </p:grpSpPr>
       <p:sp>
         <p:nvSpPr>
           <p:cNvPr id="2" name="Rectangle 1"/>
@@ -13827,6 +13989,7 @@
           <a:lstStyle/>
           <a:p>
             <a:pPr algn="ctr"/>
+            <a:endParaRPr/>
           </a:p>
         </p:txBody>
       </p:sp>
@@ -13870,6 +14033,7 @@
           <a:lstStyle/>
           <a:p>
             <a:pPr algn="ctr"/>
+            <a:endParaRPr/>
           </a:p>
         </p:txBody>
       </p:sp>
@@ -14017,6 +14181,7 @@
           <a:lstStyle/>
           <a:p>
             <a:pPr algn="ctr"/>
+            <a:endParaRPr/>
           </a:p>
         </p:txBody>
       </p:sp>
@@ -14094,6 +14259,7 @@
           <a:lstStyle/>
           <a:p>
             <a:pPr algn="ctr"/>
+            <a:endParaRPr/>
           </a:p>
         </p:txBody>
       </p:sp>
@@ -14171,6 +14337,7 @@
           <a:lstStyle/>
           <a:p>
             <a:pPr algn="ctr"/>
+            <a:endParaRPr/>
           </a:p>
         </p:txBody>
       </p:sp>
@@ -14248,6 +14415,7 @@
           <a:lstStyle/>
           <a:p>
             <a:pPr algn="ctr"/>
+            <a:endParaRPr/>
           </a:p>
         </p:txBody>
       </p:sp>
@@ -14325,6 +14493,7 @@
           <a:lstStyle/>
           <a:p>
             <a:pPr algn="ctr"/>
+            <a:endParaRPr/>
           </a:p>
         </p:txBody>
       </p:sp>
@@ -14402,6 +14571,7 @@
           <a:lstStyle/>
           <a:p>
             <a:pPr algn="ctr"/>
+            <a:endParaRPr/>
           </a:p>
         </p:txBody>
       </p:sp>
@@ -14479,6 +14649,7 @@
           <a:lstStyle/>
           <a:p>
             <a:pPr algn="ctr"/>
+            <a:endParaRPr/>
           </a:p>
         </p:txBody>
       </p:sp>
@@ -14556,6 +14727,7 @@
           <a:lstStyle/>
           <a:p>
             <a:pPr algn="ctr"/>
+            <a:endParaRPr/>
           </a:p>
         </p:txBody>
       </p:sp>
@@ -14633,6 +14805,7 @@
           <a:lstStyle/>
           <a:p>
             <a:pPr algn="ctr"/>
+            <a:endParaRPr/>
           </a:p>
         </p:txBody>
       </p:sp>
@@ -14778,6 +14951,7 @@
           <a:lstStyle/>
           <a:p>
             <a:pPr algn="ctr"/>
+            <a:endParaRPr/>
           </a:p>
         </p:txBody>
       </p:sp>
@@ -14821,6 +14995,7 @@
           <a:lstStyle/>
           <a:p>
             <a:pPr algn="ctr"/>
+            <a:endParaRPr/>
           </a:p>
         </p:txBody>
       </p:sp>
@@ -14898,6 +15073,7 @@
           <a:lstStyle/>
           <a:p>
             <a:pPr algn="ctr"/>
+            <a:endParaRPr/>
           </a:p>
         </p:txBody>
       </p:sp>
@@ -15009,6 +15185,7 @@
           <a:lstStyle/>
           <a:p>
             <a:pPr algn="ctr"/>
+            <a:endParaRPr/>
           </a:p>
         </p:txBody>
       </p:sp>
@@ -15120,6 +15297,7 @@
           <a:lstStyle/>
           <a:p>
             <a:pPr algn="ctr"/>
+            <a:endParaRPr/>
           </a:p>
         </p:txBody>
       </p:sp>
@@ -15231,6 +15409,7 @@
           <a:lstStyle/>
           <a:p>
             <a:pPr algn="ctr"/>
+            <a:endParaRPr/>
           </a:p>
         </p:txBody>
       </p:sp>
@@ -15342,6 +15521,7 @@
           <a:lstStyle/>
           <a:p>
             <a:pPr algn="ctr"/>
+            <a:endParaRPr/>
           </a:p>
         </p:txBody>
       </p:sp>
@@ -15453,6 +15633,7 @@
           <a:lstStyle/>
           <a:p>
             <a:pPr algn="ctr"/>
+            <a:endParaRPr/>
           </a:p>
         </p:txBody>
       </p:sp>
@@ -15564,6 +15745,7 @@
           <a:lstStyle/>
           <a:p>
             <a:pPr algn="ctr"/>
+            <a:endParaRPr/>
           </a:p>
         </p:txBody>
       </p:sp>
@@ -15675,6 +15857,7 @@
           <a:lstStyle/>
           <a:p>
             <a:pPr algn="ctr"/>
+            <a:endParaRPr/>
           </a:p>
         </p:txBody>
       </p:sp>
@@ -15755,7 +15938,7 @@
 </file>
 
 <file path=ppt/slides/slide2.xml><?xml version="1.0" encoding="utf-8"?>
-<p:sld xmlns:a="http://schemas.openxmlformats.org/drawingml/2006/main" xmlns:p="http://schemas.openxmlformats.org/presentationml/2006/main" xmlns:r="http://schemas.openxmlformats.org/officeDocument/2006/relationships">
+<p:sld xmlns:a="http://schemas.openxmlformats.org/drawingml/2006/main" xmlns:r="http://schemas.openxmlformats.org/officeDocument/2006/relationships" xmlns:p="http://schemas.openxmlformats.org/presentationml/2006/main">
   <p:cSld>
     <p:bg>
       <p:bgPr>
@@ -15771,7 +15954,14 @@
         <p:cNvGrpSpPr/>
         <p:nvPr/>
       </p:nvGrpSpPr>
-      <p:grpSpPr/>
+      <p:grpSpPr>
+        <a:xfrm>
+          <a:off x="0" y="0"/>
+          <a:ext cx="0" cy="0"/>
+          <a:chOff x="0" y="0"/>
+          <a:chExt cx="0" cy="0"/>
+        </a:xfrm>
+      </p:grpSpPr>
       <p:sp>
         <p:nvSpPr>
           <p:cNvPr id="2" name="Rectangle 1"/>
@@ -15812,6 +16002,7 @@
           <a:lstStyle/>
           <a:p>
             <a:pPr algn="ctr"/>
+            <a:endParaRPr/>
           </a:p>
         </p:txBody>
       </p:sp>
@@ -15855,6 +16046,7 @@
           <a:lstStyle/>
           <a:p>
             <a:pPr algn="ctr"/>
+            <a:endParaRPr/>
           </a:p>
         </p:txBody>
       </p:sp>
@@ -15966,6 +16158,7 @@
           <a:lstStyle/>
           <a:p>
             <a:pPr algn="ctr"/>
+            <a:endParaRPr/>
           </a:p>
         </p:txBody>
       </p:sp>
@@ -16043,6 +16236,7 @@
           <a:lstStyle/>
           <a:p>
             <a:pPr algn="ctr"/>
+            <a:endParaRPr/>
           </a:p>
         </p:txBody>
       </p:sp>
@@ -16086,6 +16280,7 @@
           <a:lstStyle/>
           <a:p>
             <a:pPr algn="ctr"/>
+            <a:endParaRPr/>
           </a:p>
         </p:txBody>
       </p:sp>
@@ -16231,6 +16426,7 @@
           <a:lstStyle/>
           <a:p>
             <a:pPr algn="ctr"/>
+            <a:endParaRPr/>
           </a:p>
         </p:txBody>
       </p:sp>
@@ -16274,6 +16470,7 @@
           <a:lstStyle/>
           <a:p>
             <a:pPr algn="ctr"/>
+            <a:endParaRPr/>
           </a:p>
         </p:txBody>
       </p:sp>
@@ -16419,6 +16616,7 @@
           <a:lstStyle/>
           <a:p>
             <a:pPr algn="ctr"/>
+            <a:endParaRPr/>
           </a:p>
         </p:txBody>
       </p:sp>
@@ -16462,6 +16660,7 @@
           <a:lstStyle/>
           <a:p>
             <a:pPr algn="ctr"/>
+            <a:endParaRPr/>
           </a:p>
         </p:txBody>
       </p:sp>
@@ -16607,6 +16806,7 @@
           <a:lstStyle/>
           <a:p>
             <a:pPr algn="ctr"/>
+            <a:endParaRPr/>
           </a:p>
         </p:txBody>
       </p:sp>
@@ -16650,6 +16850,7 @@
           <a:lstStyle/>
           <a:p>
             <a:pPr algn="ctr"/>
+            <a:endParaRPr/>
           </a:p>
         </p:txBody>
       </p:sp>
@@ -16795,6 +16996,7 @@
           <a:lstStyle/>
           <a:p>
             <a:pPr algn="ctr"/>
+            <a:endParaRPr/>
           </a:p>
         </p:txBody>
       </p:sp>
@@ -16838,6 +17040,7 @@
           <a:lstStyle/>
           <a:p>
             <a:pPr algn="ctr"/>
+            <a:endParaRPr/>
           </a:p>
         </p:txBody>
       </p:sp>
@@ -16983,6 +17186,7 @@
           <a:lstStyle/>
           <a:p>
             <a:pPr algn="ctr"/>
+            <a:endParaRPr/>
           </a:p>
         </p:txBody>
       </p:sp>
@@ -17029,7 +17233,7 @@
 </file>
 
 <file path=ppt/slides/slide3.xml><?xml version="1.0" encoding="utf-8"?>
-<p:sld xmlns:a="http://schemas.openxmlformats.org/drawingml/2006/main" xmlns:p="http://schemas.openxmlformats.org/presentationml/2006/main" xmlns:r="http://schemas.openxmlformats.org/officeDocument/2006/relationships">
+<p:sld xmlns:a="http://schemas.openxmlformats.org/drawingml/2006/main" xmlns:r="http://schemas.openxmlformats.org/officeDocument/2006/relationships" xmlns:p="http://schemas.openxmlformats.org/presentationml/2006/main">
   <p:cSld>
     <p:bg>
       <p:bgPr>
@@ -17045,7 +17249,14 @@
         <p:cNvGrpSpPr/>
         <p:nvPr/>
       </p:nvGrpSpPr>
-      <p:grpSpPr/>
+      <p:grpSpPr>
+        <a:xfrm>
+          <a:off x="0" y="0"/>
+          <a:ext cx="0" cy="0"/>
+          <a:chOff x="0" y="0"/>
+          <a:chExt cx="0" cy="0"/>
+        </a:xfrm>
+      </p:grpSpPr>
       <p:sp>
         <p:nvSpPr>
           <p:cNvPr id="2" name="Rectangle 1"/>
@@ -17086,6 +17297,7 @@
           <a:lstStyle/>
           <a:p>
             <a:pPr algn="ctr"/>
+            <a:endParaRPr/>
           </a:p>
         </p:txBody>
       </p:sp>
@@ -17129,6 +17341,7 @@
           <a:lstStyle/>
           <a:p>
             <a:pPr algn="ctr"/>
+            <a:endParaRPr/>
           </a:p>
         </p:txBody>
       </p:sp>
@@ -17240,6 +17453,7 @@
           <a:lstStyle/>
           <a:p>
             <a:pPr algn="ctr"/>
+            <a:endParaRPr/>
           </a:p>
         </p:txBody>
       </p:sp>
@@ -17317,6 +17531,7 @@
           <a:lstStyle/>
           <a:p>
             <a:pPr algn="ctr"/>
+            <a:endParaRPr/>
           </a:p>
         </p:txBody>
       </p:sp>
@@ -17360,6 +17575,7 @@
           <a:lstStyle/>
           <a:p>
             <a:pPr algn="ctr"/>
+            <a:endParaRPr/>
           </a:p>
         </p:txBody>
       </p:sp>
@@ -17540,6 +17756,7 @@
           <a:lstStyle/>
           <a:p>
             <a:pPr algn="ctr"/>
+            <a:endParaRPr/>
           </a:p>
         </p:txBody>
       </p:sp>
@@ -17583,6 +17800,7 @@
           <a:lstStyle/>
           <a:p>
             <a:pPr algn="ctr"/>
+            <a:endParaRPr/>
           </a:p>
         </p:txBody>
       </p:sp>
@@ -17763,6 +17981,7 @@
           <a:lstStyle/>
           <a:p>
             <a:pPr algn="ctr"/>
+            <a:endParaRPr/>
           </a:p>
         </p:txBody>
       </p:sp>
@@ -17806,6 +18025,7 @@
           <a:lstStyle/>
           <a:p>
             <a:pPr algn="ctr"/>
+            <a:endParaRPr/>
           </a:p>
         </p:txBody>
       </p:sp>
@@ -17986,6 +18206,7 @@
           <a:lstStyle/>
           <a:p>
             <a:pPr algn="ctr"/>
+            <a:endParaRPr/>
           </a:p>
         </p:txBody>
       </p:sp>
@@ -18029,6 +18250,7 @@
           <a:lstStyle/>
           <a:p>
             <a:pPr algn="ctr"/>
+            <a:endParaRPr/>
           </a:p>
         </p:txBody>
       </p:sp>
@@ -18209,6 +18431,7 @@
           <a:lstStyle/>
           <a:p>
             <a:pPr algn="ctr"/>
+            <a:endParaRPr/>
           </a:p>
         </p:txBody>
       </p:sp>
@@ -18252,6 +18475,7 @@
           <a:lstStyle/>
           <a:p>
             <a:pPr algn="ctr"/>
+            <a:endParaRPr/>
           </a:p>
         </p:txBody>
       </p:sp>
@@ -18398,6 +18622,7 @@
           <a:lstStyle/>
           <a:p>
             <a:pPr algn="ctr"/>
+            <a:endParaRPr/>
           </a:p>
         </p:txBody>
       </p:sp>
@@ -18441,6 +18666,7 @@
           <a:lstStyle/>
           <a:p>
             <a:pPr algn="ctr"/>
+            <a:endParaRPr/>
           </a:p>
         </p:txBody>
       </p:sp>
@@ -18552,6 +18778,7 @@
           <a:lstStyle/>
           <a:p>
             <a:pPr algn="ctr"/>
+            <a:endParaRPr/>
           </a:p>
         </p:txBody>
       </p:sp>
@@ -18595,6 +18822,7 @@
           <a:lstStyle/>
           <a:p>
             <a:pPr algn="ctr"/>
+            <a:endParaRPr/>
           </a:p>
         </p:txBody>
       </p:sp>
@@ -18706,6 +18934,7 @@
           <a:lstStyle/>
           <a:p>
             <a:pPr algn="ctr"/>
+            <a:endParaRPr/>
           </a:p>
         </p:txBody>
       </p:sp>
@@ -18749,6 +18978,7 @@
           <a:lstStyle/>
           <a:p>
             <a:pPr algn="ctr"/>
+            <a:endParaRPr/>
           </a:p>
         </p:txBody>
       </p:sp>
@@ -18860,6 +19090,7 @@
           <a:lstStyle/>
           <a:p>
             <a:pPr algn="ctr"/>
+            <a:endParaRPr/>
           </a:p>
         </p:txBody>
       </p:sp>
@@ -18903,6 +19134,7 @@
           <a:lstStyle/>
           <a:p>
             <a:pPr algn="ctr"/>
+            <a:endParaRPr/>
           </a:p>
         </p:txBody>
       </p:sp>
@@ -19017,7 +19249,7 @@
 </file>
 
 <file path=ppt/slides/slide4.xml><?xml version="1.0" encoding="utf-8"?>
-<p:sld xmlns:a="http://schemas.openxmlformats.org/drawingml/2006/main" xmlns:p="http://schemas.openxmlformats.org/presentationml/2006/main" xmlns:r="http://schemas.openxmlformats.org/officeDocument/2006/relationships">
+<p:sld xmlns:a="http://schemas.openxmlformats.org/drawingml/2006/main" xmlns:r="http://schemas.openxmlformats.org/officeDocument/2006/relationships" xmlns:p="http://schemas.openxmlformats.org/presentationml/2006/main">
   <p:cSld>
     <p:bg>
       <p:bgPr>
@@ -19033,7 +19265,14 @@
         <p:cNvGrpSpPr/>
         <p:nvPr/>
       </p:nvGrpSpPr>
-      <p:grpSpPr/>
+      <p:grpSpPr>
+        <a:xfrm>
+          <a:off x="0" y="0"/>
+          <a:ext cx="0" cy="0"/>
+          <a:chOff x="0" y="0"/>
+          <a:chExt cx="0" cy="0"/>
+        </a:xfrm>
+      </p:grpSpPr>
       <p:sp>
         <p:nvSpPr>
           <p:cNvPr id="2" name="Rectangle 1"/>
@@ -19074,6 +19313,7 @@
           <a:lstStyle/>
           <a:p>
             <a:pPr algn="ctr"/>
+            <a:endParaRPr/>
           </a:p>
         </p:txBody>
       </p:sp>
@@ -19117,6 +19357,7 @@
           <a:lstStyle/>
           <a:p>
             <a:pPr algn="ctr"/>
+            <a:endParaRPr/>
           </a:p>
         </p:txBody>
       </p:sp>
@@ -19228,6 +19469,7 @@
           <a:lstStyle/>
           <a:p>
             <a:pPr algn="ctr"/>
+            <a:endParaRPr/>
           </a:p>
         </p:txBody>
       </p:sp>
@@ -19305,6 +19547,7 @@
           <a:lstStyle/>
           <a:p>
             <a:pPr algn="ctr"/>
+            <a:endParaRPr/>
           </a:p>
         </p:txBody>
       </p:sp>
@@ -19348,6 +19591,7 @@
           <a:lstStyle/>
           <a:p>
             <a:pPr algn="ctr"/>
+            <a:endParaRPr/>
           </a:p>
         </p:txBody>
       </p:sp>
@@ -19697,6 +19941,7 @@
           <a:lstStyle/>
           <a:p>
             <a:pPr algn="ctr"/>
+            <a:endParaRPr/>
           </a:p>
         </p:txBody>
       </p:sp>
@@ -19740,6 +19985,7 @@
           <a:lstStyle/>
           <a:p>
             <a:pPr algn="ctr"/>
+            <a:endParaRPr/>
           </a:p>
         </p:txBody>
       </p:sp>
@@ -20089,6 +20335,7 @@
           <a:lstStyle/>
           <a:p>
             <a:pPr algn="ctr"/>
+            <a:endParaRPr/>
           </a:p>
         </p:txBody>
       </p:sp>
@@ -20132,6 +20379,7 @@
           <a:lstStyle/>
           <a:p>
             <a:pPr algn="ctr"/>
+            <a:endParaRPr/>
           </a:p>
         </p:txBody>
       </p:sp>
@@ -20481,6 +20729,7 @@
           <a:lstStyle/>
           <a:p>
             <a:pPr algn="ctr"/>
+            <a:endParaRPr/>
           </a:p>
         </p:txBody>
       </p:sp>
@@ -20524,6 +20773,7 @@
           <a:lstStyle/>
           <a:p>
             <a:pPr algn="ctr"/>
+            <a:endParaRPr/>
           </a:p>
         </p:txBody>
       </p:sp>
@@ -20873,6 +21123,7 @@
           <a:lstStyle/>
           <a:p>
             <a:pPr algn="ctr"/>
+            <a:endParaRPr/>
           </a:p>
         </p:txBody>
       </p:sp>
@@ -21021,7 +21272,7 @@
 </file>
 
 <file path=ppt/slides/slide5.xml><?xml version="1.0" encoding="utf-8"?>
-<p:sld xmlns:a="http://schemas.openxmlformats.org/drawingml/2006/main" xmlns:p="http://schemas.openxmlformats.org/presentationml/2006/main" xmlns:r="http://schemas.openxmlformats.org/officeDocument/2006/relationships">
+<p:sld xmlns:a="http://schemas.openxmlformats.org/drawingml/2006/main" xmlns:r="http://schemas.openxmlformats.org/officeDocument/2006/relationships" xmlns:p="http://schemas.openxmlformats.org/presentationml/2006/main">
   <p:cSld>
     <p:bg>
       <p:bgPr>
@@ -21037,7 +21288,14 @@
         <p:cNvGrpSpPr/>
         <p:nvPr/>
       </p:nvGrpSpPr>
-      <p:grpSpPr/>
+      <p:grpSpPr>
+        <a:xfrm>
+          <a:off x="0" y="0"/>
+          <a:ext cx="0" cy="0"/>
+          <a:chOff x="0" y="0"/>
+          <a:chExt cx="0" cy="0"/>
+        </a:xfrm>
+      </p:grpSpPr>
       <p:sp>
         <p:nvSpPr>
           <p:cNvPr id="2" name="Rectangle 1"/>
@@ -21078,6 +21336,7 @@
           <a:lstStyle/>
           <a:p>
             <a:pPr algn="ctr"/>
+            <a:endParaRPr/>
           </a:p>
         </p:txBody>
       </p:sp>
@@ -21121,6 +21380,7 @@
           <a:lstStyle/>
           <a:p>
             <a:pPr algn="ctr"/>
+            <a:endParaRPr/>
           </a:p>
         </p:txBody>
       </p:sp>
@@ -21232,6 +21492,7 @@
           <a:lstStyle/>
           <a:p>
             <a:pPr algn="ctr"/>
+            <a:endParaRPr/>
           </a:p>
         </p:txBody>
       </p:sp>
@@ -21309,6 +21570,7 @@
           <a:lstStyle/>
           <a:p>
             <a:pPr algn="ctr"/>
+            <a:endParaRPr/>
           </a:p>
         </p:txBody>
       </p:sp>
@@ -21386,6 +21648,7 @@
           <a:lstStyle/>
           <a:p>
             <a:pPr algn="ctr"/>
+            <a:endParaRPr/>
           </a:p>
         </p:txBody>
       </p:sp>
@@ -21497,6 +21760,7 @@
           <a:lstStyle/>
           <a:p>
             <a:pPr algn="ctr"/>
+            <a:endParaRPr/>
           </a:p>
         </p:txBody>
       </p:sp>
@@ -21608,6 +21872,7 @@
           <a:lstStyle/>
           <a:p>
             <a:pPr algn="ctr"/>
+            <a:endParaRPr/>
           </a:p>
         </p:txBody>
       </p:sp>
@@ -21719,6 +21984,7 @@
           <a:lstStyle/>
           <a:p>
             <a:pPr algn="ctr"/>
+            <a:endParaRPr/>
           </a:p>
         </p:txBody>
       </p:sp>
@@ -21830,6 +22096,7 @@
           <a:lstStyle/>
           <a:p>
             <a:pPr algn="ctr"/>
+            <a:endParaRPr/>
           </a:p>
         </p:txBody>
       </p:sp>
@@ -21873,6 +22140,7 @@
           <a:lstStyle/>
           <a:p>
             <a:pPr algn="ctr"/>
+            <a:endParaRPr/>
           </a:p>
         </p:txBody>
       </p:sp>
@@ -21984,6 +22252,7 @@
           <a:lstStyle/>
           <a:p>
             <a:pPr algn="ctr"/>
+            <a:endParaRPr/>
           </a:p>
         </p:txBody>
       </p:sp>
@@ -22061,6 +22330,7 @@
           <a:lstStyle/>
           <a:p>
             <a:pPr algn="ctr"/>
+            <a:endParaRPr/>
           </a:p>
         </p:txBody>
       </p:sp>
@@ -22104,6 +22374,7 @@
           <a:lstStyle/>
           <a:p>
             <a:pPr algn="ctr"/>
+            <a:endParaRPr/>
           </a:p>
         </p:txBody>
       </p:sp>
@@ -22147,6 +22418,7 @@
           <a:lstStyle/>
           <a:p>
             <a:pPr algn="ctr"/>
+            <a:endParaRPr/>
           </a:p>
         </p:txBody>
       </p:sp>
@@ -22190,6 +22462,7 @@
           <a:lstStyle/>
           <a:p>
             <a:pPr algn="ctr"/>
+            <a:endParaRPr/>
           </a:p>
         </p:txBody>
       </p:sp>
@@ -22233,6 +22506,7 @@
           <a:lstStyle/>
           <a:p>
             <a:pPr algn="ctr"/>
+            <a:endParaRPr/>
           </a:p>
         </p:txBody>
       </p:sp>
@@ -22276,6 +22550,7 @@
           <a:lstStyle/>
           <a:p>
             <a:pPr algn="ctr"/>
+            <a:endParaRPr/>
           </a:p>
         </p:txBody>
       </p:sp>
@@ -22319,6 +22594,7 @@
           <a:lstStyle/>
           <a:p>
             <a:pPr algn="ctr"/>
+            <a:endParaRPr/>
           </a:p>
         </p:txBody>
       </p:sp>
@@ -22362,6 +22638,7 @@
           <a:lstStyle/>
           <a:p>
             <a:pPr algn="ctr"/>
+            <a:endParaRPr/>
           </a:p>
         </p:txBody>
       </p:sp>
@@ -22405,6 +22682,7 @@
           <a:lstStyle/>
           <a:p>
             <a:pPr algn="ctr"/>
+            <a:endParaRPr/>
           </a:p>
         </p:txBody>
       </p:sp>
@@ -22482,6 +22760,7 @@
           <a:lstStyle/>
           <a:p>
             <a:pPr algn="ctr"/>
+            <a:endParaRPr/>
           </a:p>
         </p:txBody>
       </p:sp>
@@ -22525,6 +22804,7 @@
           <a:lstStyle/>
           <a:p>
             <a:pPr algn="ctr"/>
+            <a:endParaRPr/>
           </a:p>
         </p:txBody>
       </p:sp>
@@ -22568,6 +22848,7 @@
           <a:lstStyle/>
           <a:p>
             <a:pPr algn="ctr"/>
+            <a:endParaRPr/>
           </a:p>
         </p:txBody>
       </p:sp>
@@ -22645,6 +22926,7 @@
           <a:lstStyle/>
           <a:p>
             <a:pPr algn="ctr"/>
+            <a:endParaRPr/>
           </a:p>
         </p:txBody>
       </p:sp>
@@ -22688,6 +22970,7 @@
           <a:lstStyle/>
           <a:p>
             <a:pPr algn="ctr"/>
+            <a:endParaRPr/>
           </a:p>
         </p:txBody>
       </p:sp>
@@ -22799,6 +23082,7 @@
           <a:lstStyle/>
           <a:p>
             <a:pPr algn="ctr"/>
+            <a:endParaRPr/>
           </a:p>
         </p:txBody>
       </p:sp>
@@ -22842,6 +23126,7 @@
           <a:lstStyle/>
           <a:p>
             <a:pPr algn="ctr"/>
+            <a:endParaRPr/>
           </a:p>
         </p:txBody>
       </p:sp>
@@ -22953,6 +23238,7 @@
           <a:lstStyle/>
           <a:p>
             <a:pPr algn="ctr"/>
+            <a:endParaRPr/>
           </a:p>
         </p:txBody>
       </p:sp>
@@ -22996,6 +23282,7 @@
           <a:lstStyle/>
           <a:p>
             <a:pPr algn="ctr"/>
+            <a:endParaRPr/>
           </a:p>
         </p:txBody>
       </p:sp>
@@ -23107,6 +23394,7 @@
           <a:lstStyle/>
           <a:p>
             <a:pPr algn="ctr"/>
+            <a:endParaRPr/>
           </a:p>
         </p:txBody>
       </p:sp>
@@ -23150,6 +23438,7 @@
           <a:lstStyle/>
           <a:p>
             <a:pPr algn="ctr"/>
+            <a:endParaRPr/>
           </a:p>
         </p:txBody>
       </p:sp>
@@ -23261,6 +23550,7 @@
           <a:lstStyle/>
           <a:p>
             <a:pPr algn="ctr"/>
+            <a:endParaRPr/>
           </a:p>
         </p:txBody>
       </p:sp>
@@ -23304,6 +23594,7 @@
           <a:lstStyle/>
           <a:p>
             <a:pPr algn="ctr"/>
+            <a:endParaRPr/>
           </a:p>
         </p:txBody>
       </p:sp>
@@ -23415,6 +23706,7 @@
           <a:lstStyle/>
           <a:p>
             <a:pPr algn="ctr"/>
+            <a:endParaRPr/>
           </a:p>
         </p:txBody>
       </p:sp>
@@ -23458,6 +23750,7 @@
           <a:lstStyle/>
           <a:p>
             <a:pPr algn="ctr"/>
+            <a:endParaRPr/>
           </a:p>
         </p:txBody>
       </p:sp>
@@ -23538,7 +23831,7 @@
 </file>
 
 <file path=ppt/slides/slide6.xml><?xml version="1.0" encoding="utf-8"?>
-<p:sld xmlns:a="http://schemas.openxmlformats.org/drawingml/2006/main" xmlns:p="http://schemas.openxmlformats.org/presentationml/2006/main" xmlns:r="http://schemas.openxmlformats.org/officeDocument/2006/relationships">
+<p:sld xmlns:a="http://schemas.openxmlformats.org/drawingml/2006/main" xmlns:r="http://schemas.openxmlformats.org/officeDocument/2006/relationships" xmlns:p="http://schemas.openxmlformats.org/presentationml/2006/main">
   <p:cSld>
     <p:bg>
       <p:bgPr>
@@ -23554,7 +23847,14 @@
         <p:cNvGrpSpPr/>
         <p:nvPr/>
       </p:nvGrpSpPr>
-      <p:grpSpPr/>
+      <p:grpSpPr>
+        <a:xfrm>
+          <a:off x="0" y="0"/>
+          <a:ext cx="0" cy="0"/>
+          <a:chOff x="0" y="0"/>
+          <a:chExt cx="0" cy="0"/>
+        </a:xfrm>
+      </p:grpSpPr>
       <p:sp>
         <p:nvSpPr>
           <p:cNvPr id="2" name="Rectangle 1"/>
@@ -23595,6 +23895,7 @@
           <a:lstStyle/>
           <a:p>
             <a:pPr algn="ctr"/>
+            <a:endParaRPr/>
           </a:p>
         </p:txBody>
       </p:sp>
@@ -23638,6 +23939,7 @@
           <a:lstStyle/>
           <a:p>
             <a:pPr algn="ctr"/>
+            <a:endParaRPr/>
           </a:p>
         </p:txBody>
       </p:sp>
@@ -23749,6 +24051,7 @@
           <a:lstStyle/>
           <a:p>
             <a:pPr algn="ctr"/>
+            <a:endParaRPr/>
           </a:p>
         </p:txBody>
       </p:sp>
@@ -23826,6 +24129,7 @@
           <a:lstStyle/>
           <a:p>
             <a:pPr algn="ctr"/>
+            <a:endParaRPr/>
           </a:p>
         </p:txBody>
       </p:sp>
@@ -23903,6 +24207,7 @@
           <a:lstStyle/>
           <a:p>
             <a:pPr algn="ctr"/>
+            <a:endParaRPr/>
           </a:p>
         </p:txBody>
       </p:sp>
@@ -23980,6 +24285,7 @@
           <a:lstStyle/>
           <a:p>
             <a:pPr algn="ctr"/>
+            <a:endParaRPr/>
           </a:p>
         </p:txBody>
       </p:sp>
@@ -24057,6 +24363,7 @@
           <a:lstStyle/>
           <a:p>
             <a:pPr algn="ctr"/>
+            <a:endParaRPr/>
           </a:p>
         </p:txBody>
       </p:sp>
@@ -24134,6 +24441,7 @@
           <a:lstStyle/>
           <a:p>
             <a:pPr algn="ctr"/>
+            <a:endParaRPr/>
           </a:p>
         </p:txBody>
       </p:sp>
@@ -24211,6 +24519,7 @@
           <a:lstStyle/>
           <a:p>
             <a:pPr algn="ctr"/>
+            <a:endParaRPr/>
           </a:p>
         </p:txBody>
       </p:sp>
@@ -24288,6 +24597,7 @@
           <a:lstStyle/>
           <a:p>
             <a:pPr algn="ctr"/>
+            <a:endParaRPr/>
           </a:p>
         </p:txBody>
       </p:sp>
@@ -24365,6 +24675,7 @@
           <a:lstStyle/>
           <a:p>
             <a:pPr algn="ctr"/>
+            <a:endParaRPr/>
           </a:p>
         </p:txBody>
       </p:sp>
@@ -24442,6 +24753,7 @@
           <a:lstStyle/>
           <a:p>
             <a:pPr algn="ctr"/>
+            <a:endParaRPr/>
           </a:p>
         </p:txBody>
       </p:sp>
@@ -24519,6 +24831,7 @@
           <a:lstStyle/>
           <a:p>
             <a:pPr algn="ctr"/>
+            <a:endParaRPr/>
           </a:p>
         </p:txBody>
       </p:sp>
@@ -24596,6 +24909,7 @@
           <a:lstStyle/>
           <a:p>
             <a:pPr algn="ctr"/>
+            <a:endParaRPr/>
           </a:p>
         </p:txBody>
       </p:sp>
@@ -24843,6 +25157,7 @@
           <a:lstStyle/>
           <a:p>
             <a:pPr algn="ctr"/>
+            <a:endParaRPr/>
           </a:p>
         </p:txBody>
       </p:sp>
@@ -25090,6 +25405,7 @@
           <a:lstStyle/>
           <a:p>
             <a:pPr algn="ctr"/>
+            <a:endParaRPr/>
           </a:p>
         </p:txBody>
       </p:sp>
@@ -25337,6 +25653,7 @@
           <a:lstStyle/>
           <a:p>
             <a:pPr algn="ctr"/>
+            <a:endParaRPr/>
           </a:p>
         </p:txBody>
       </p:sp>
@@ -25584,6 +25901,7 @@
           <a:lstStyle/>
           <a:p>
             <a:pPr algn="ctr"/>
+            <a:endParaRPr/>
           </a:p>
         </p:txBody>
       </p:sp>
@@ -25831,6 +26149,7 @@
           <a:lstStyle/>
           <a:p>
             <a:pPr algn="ctr"/>
+            <a:endParaRPr/>
           </a:p>
         </p:txBody>
       </p:sp>
@@ -26146,6 +26465,7 @@
           <a:lstStyle/>
           <a:p>
             <a:pPr algn="ctr"/>
+            <a:endParaRPr/>
           </a:p>
         </p:txBody>
       </p:sp>
@@ -26189,6 +26509,7 @@
           <a:lstStyle/>
           <a:p>
             <a:pPr algn="ctr"/>
+            <a:endParaRPr/>
           </a:p>
         </p:txBody>
       </p:sp>
@@ -26300,6 +26621,7 @@
           <a:lstStyle/>
           <a:p>
             <a:pPr algn="ctr"/>
+            <a:endParaRPr/>
           </a:p>
         </p:txBody>
       </p:sp>
@@ -26343,6 +26665,7 @@
           <a:lstStyle/>
           <a:p>
             <a:pPr algn="ctr"/>
+            <a:endParaRPr/>
           </a:p>
         </p:txBody>
       </p:sp>
@@ -26454,6 +26777,7 @@
           <a:lstStyle/>
           <a:p>
             <a:pPr algn="ctr"/>
+            <a:endParaRPr/>
           </a:p>
         </p:txBody>
       </p:sp>
@@ -26497,6 +26821,7 @@
           <a:lstStyle/>
           <a:p>
             <a:pPr algn="ctr"/>
+            <a:endParaRPr/>
           </a:p>
         </p:txBody>
       </p:sp>
@@ -26608,6 +26933,7 @@
           <a:lstStyle/>
           <a:p>
             <a:pPr algn="ctr"/>
+            <a:endParaRPr/>
           </a:p>
         </p:txBody>
       </p:sp>
@@ -26651,6 +26977,7 @@
           <a:lstStyle/>
           <a:p>
             <a:pPr algn="ctr"/>
+            <a:endParaRPr/>
           </a:p>
         </p:txBody>
       </p:sp>
@@ -26762,6 +27089,7 @@
           <a:lstStyle/>
           <a:p>
             <a:pPr algn="ctr"/>
+            <a:endParaRPr/>
           </a:p>
         </p:txBody>
       </p:sp>
@@ -26805,6 +27133,7 @@
           <a:lstStyle/>
           <a:p>
             <a:pPr algn="ctr"/>
+            <a:endParaRPr/>
           </a:p>
         </p:txBody>
       </p:sp>
@@ -26916,6 +27245,7 @@
           <a:lstStyle/>
           <a:p>
             <a:pPr algn="ctr"/>
+            <a:endParaRPr/>
           </a:p>
         </p:txBody>
       </p:sp>
@@ -26959,6 +27289,7 @@
           <a:lstStyle/>
           <a:p>
             <a:pPr algn="ctr"/>
+            <a:endParaRPr/>
           </a:p>
         </p:txBody>
       </p:sp>
@@ -27039,7 +27370,7 @@
 </file>
 
 <file path=ppt/slides/slide7.xml><?xml version="1.0" encoding="utf-8"?>
-<p:sld xmlns:a="http://schemas.openxmlformats.org/drawingml/2006/main" xmlns:p="http://schemas.openxmlformats.org/presentationml/2006/main" xmlns:r="http://schemas.openxmlformats.org/officeDocument/2006/relationships">
+<p:sld xmlns:a="http://schemas.openxmlformats.org/drawingml/2006/main" xmlns:r="http://schemas.openxmlformats.org/officeDocument/2006/relationships" xmlns:p="http://schemas.openxmlformats.org/presentationml/2006/main">
   <p:cSld>
     <p:bg>
       <p:bgPr>
@@ -27055,7 +27386,14 @@
         <p:cNvGrpSpPr/>
         <p:nvPr/>
       </p:nvGrpSpPr>
-      <p:grpSpPr/>
+      <p:grpSpPr>
+        <a:xfrm>
+          <a:off x="0" y="0"/>
+          <a:ext cx="0" cy="0"/>
+          <a:chOff x="0" y="0"/>
+          <a:chExt cx="0" cy="0"/>
+        </a:xfrm>
+      </p:grpSpPr>
       <p:sp>
         <p:nvSpPr>
           <p:cNvPr id="2" name="Rectangle 1"/>
@@ -27096,6 +27434,7 @@
           <a:lstStyle/>
           <a:p>
             <a:pPr algn="ctr"/>
+            <a:endParaRPr/>
           </a:p>
         </p:txBody>
       </p:sp>
@@ -27139,6 +27478,7 @@
           <a:lstStyle/>
           <a:p>
             <a:pPr algn="ctr"/>
+            <a:endParaRPr/>
           </a:p>
         </p:txBody>
       </p:sp>
@@ -27250,6 +27590,7 @@
           <a:lstStyle/>
           <a:p>
             <a:pPr algn="ctr"/>
+            <a:endParaRPr/>
           </a:p>
         </p:txBody>
       </p:sp>
@@ -27327,6 +27668,7 @@
           <a:lstStyle/>
           <a:p>
             <a:pPr algn="ctr"/>
+            <a:endParaRPr/>
           </a:p>
         </p:txBody>
       </p:sp>
@@ -27404,6 +27746,7 @@
           <a:lstStyle/>
           <a:p>
             <a:pPr algn="ctr"/>
+            <a:endParaRPr/>
           </a:p>
         </p:txBody>
       </p:sp>
@@ -27549,6 +27892,7 @@
           <a:lstStyle/>
           <a:p>
             <a:pPr algn="ctr"/>
+            <a:endParaRPr/>
           </a:p>
         </p:txBody>
       </p:sp>
@@ -27592,6 +27936,7 @@
           <a:lstStyle/>
           <a:p>
             <a:pPr algn="ctr"/>
+            <a:endParaRPr/>
           </a:p>
         </p:txBody>
       </p:sp>
@@ -27635,6 +27980,7 @@
           <a:lstStyle/>
           <a:p>
             <a:pPr algn="ctr"/>
+            <a:endParaRPr/>
           </a:p>
         </p:txBody>
       </p:sp>
@@ -27780,6 +28126,7 @@
           <a:lstStyle/>
           <a:p>
             <a:pPr algn="ctr"/>
+            <a:endParaRPr/>
           </a:p>
         </p:txBody>
       </p:sp>
@@ -27857,6 +28204,7 @@
           <a:lstStyle/>
           <a:p>
             <a:pPr algn="ctr"/>
+            <a:endParaRPr/>
           </a:p>
         </p:txBody>
       </p:sp>
@@ -27934,6 +28282,7 @@
           <a:lstStyle/>
           <a:p>
             <a:pPr algn="ctr"/>
+            <a:endParaRPr/>
           </a:p>
         </p:txBody>
       </p:sp>
@@ -28011,6 +28360,7 @@
           <a:lstStyle/>
           <a:p>
             <a:pPr algn="ctr"/>
+            <a:endParaRPr/>
           </a:p>
         </p:txBody>
       </p:sp>
@@ -28088,6 +28438,7 @@
           <a:lstStyle/>
           <a:p>
             <a:pPr algn="ctr"/>
+            <a:endParaRPr/>
           </a:p>
         </p:txBody>
       </p:sp>
@@ -28165,6 +28516,7 @@
           <a:lstStyle/>
           <a:p>
             <a:pPr algn="ctr"/>
+            <a:endParaRPr/>
           </a:p>
         </p:txBody>
       </p:sp>
@@ -28242,6 +28594,7 @@
           <a:lstStyle/>
           <a:p>
             <a:pPr algn="ctr"/>
+            <a:endParaRPr/>
           </a:p>
         </p:txBody>
       </p:sp>
@@ -28319,6 +28672,7 @@
           <a:lstStyle/>
           <a:p>
             <a:pPr algn="ctr"/>
+            <a:endParaRPr/>
           </a:p>
         </p:txBody>
       </p:sp>
@@ -28430,6 +28784,7 @@
           <a:lstStyle/>
           <a:p>
             <a:pPr algn="ctr"/>
+            <a:endParaRPr/>
           </a:p>
         </p:txBody>
       </p:sp>
@@ -28473,6 +28828,7 @@
           <a:lstStyle/>
           <a:p>
             <a:pPr algn="ctr"/>
+            <a:endParaRPr/>
           </a:p>
         </p:txBody>
       </p:sp>
@@ -28584,6 +28940,7 @@
           <a:lstStyle/>
           <a:p>
             <a:pPr algn="ctr"/>
+            <a:endParaRPr/>
           </a:p>
         </p:txBody>
       </p:sp>
@@ -28627,6 +28984,7 @@
           <a:lstStyle/>
           <a:p>
             <a:pPr algn="ctr"/>
+            <a:endParaRPr/>
           </a:p>
         </p:txBody>
       </p:sp>
@@ -28738,6 +29096,7 @@
           <a:lstStyle/>
           <a:p>
             <a:pPr algn="ctr"/>
+            <a:endParaRPr/>
           </a:p>
         </p:txBody>
       </p:sp>
@@ -28781,6 +29140,7 @@
           <a:lstStyle/>
           <a:p>
             <a:pPr algn="ctr"/>
+            <a:endParaRPr/>
           </a:p>
         </p:txBody>
       </p:sp>
@@ -28892,6 +29252,7 @@
           <a:lstStyle/>
           <a:p>
             <a:pPr algn="ctr"/>
+            <a:endParaRPr/>
           </a:p>
         </p:txBody>
       </p:sp>
@@ -28935,6 +29296,7 @@
           <a:lstStyle/>
           <a:p>
             <a:pPr algn="ctr"/>
+            <a:endParaRPr/>
           </a:p>
         </p:txBody>
       </p:sp>
@@ -29046,6 +29408,7 @@
           <a:lstStyle/>
           <a:p>
             <a:pPr algn="ctr"/>
+            <a:endParaRPr/>
           </a:p>
         </p:txBody>
       </p:sp>
@@ -29089,6 +29452,7 @@
           <a:lstStyle/>
           <a:p>
             <a:pPr algn="ctr"/>
+            <a:endParaRPr/>
           </a:p>
         </p:txBody>
       </p:sp>
@@ -29200,6 +29564,7 @@
           <a:lstStyle/>
           <a:p>
             <a:pPr algn="ctr"/>
+            <a:endParaRPr/>
           </a:p>
         </p:txBody>
       </p:sp>
@@ -29243,6 +29608,7 @@
           <a:lstStyle/>
           <a:p>
             <a:pPr algn="ctr"/>
+            <a:endParaRPr/>
           </a:p>
         </p:txBody>
       </p:sp>
@@ -29354,6 +29720,7 @@
           <a:lstStyle/>
           <a:p>
             <a:pPr algn="ctr"/>
+            <a:endParaRPr/>
           </a:p>
         </p:txBody>
       </p:sp>
@@ -29397,6 +29764,7 @@
           <a:lstStyle/>
           <a:p>
             <a:pPr algn="ctr"/>
+            <a:endParaRPr/>
           </a:p>
         </p:txBody>
       </p:sp>
@@ -29479,7 +29847,7 @@
 </file>
 
 <file path=ppt/slides/slide8.xml><?xml version="1.0" encoding="utf-8"?>
-<p:sld xmlns:a="http://schemas.openxmlformats.org/drawingml/2006/main" xmlns:p="http://schemas.openxmlformats.org/presentationml/2006/main" xmlns:r="http://schemas.openxmlformats.org/officeDocument/2006/relationships">
+<p:sld xmlns:a="http://schemas.openxmlformats.org/drawingml/2006/main" xmlns:r="http://schemas.openxmlformats.org/officeDocument/2006/relationships" xmlns:p="http://schemas.openxmlformats.org/presentationml/2006/main">
   <p:cSld>
     <p:bg>
       <p:bgPr>
@@ -29495,7 +29863,14 @@
         <p:cNvGrpSpPr/>
         <p:nvPr/>
       </p:nvGrpSpPr>
-      <p:grpSpPr/>
+      <p:grpSpPr>
+        <a:xfrm>
+          <a:off x="0" y="0"/>
+          <a:ext cx="0" cy="0"/>
+          <a:chOff x="0" y="0"/>
+          <a:chExt cx="0" cy="0"/>
+        </a:xfrm>
+      </p:grpSpPr>
       <p:sp>
         <p:nvSpPr>
           <p:cNvPr id="2" name="Rectangle 1"/>
@@ -29536,6 +29911,7 @@
           <a:lstStyle/>
           <a:p>
             <a:pPr algn="ctr"/>
+            <a:endParaRPr/>
           </a:p>
         </p:txBody>
       </p:sp>
@@ -29579,6 +29955,7 @@
           <a:lstStyle/>
           <a:p>
             <a:pPr algn="ctr"/>
+            <a:endParaRPr/>
           </a:p>
         </p:txBody>
       </p:sp>
@@ -29690,6 +30067,7 @@
           <a:lstStyle/>
           <a:p>
             <a:pPr algn="ctr"/>
+            <a:endParaRPr/>
           </a:p>
         </p:txBody>
       </p:sp>
@@ -29767,6 +30145,7 @@
           <a:lstStyle/>
           <a:p>
             <a:pPr algn="ctr"/>
+            <a:endParaRPr/>
           </a:p>
         </p:txBody>
       </p:sp>
@@ -29810,6 +30189,7 @@
           <a:lstStyle/>
           <a:p>
             <a:pPr algn="ctr"/>
+            <a:endParaRPr/>
           </a:p>
         </p:txBody>
       </p:sp>
@@ -29853,6 +30233,7 @@
           <a:lstStyle/>
           <a:p>
             <a:pPr algn="ctr"/>
+            <a:endParaRPr/>
           </a:p>
         </p:txBody>
       </p:sp>
@@ -29999,6 +30380,7 @@
           <a:lstStyle/>
           <a:p>
             <a:pPr algn="ctr"/>
+            <a:endParaRPr/>
           </a:p>
         </p:txBody>
       </p:sp>
@@ -30110,6 +30492,7 @@
           <a:lstStyle/>
           <a:p>
             <a:pPr algn="ctr"/>
+            <a:endParaRPr/>
           </a:p>
         </p:txBody>
       </p:sp>
@@ -30221,6 +30604,7 @@
           <a:lstStyle/>
           <a:p>
             <a:pPr algn="ctr"/>
+            <a:endParaRPr/>
           </a:p>
         </p:txBody>
       </p:sp>
@@ -30300,8 +30684,8 @@
         </p:nvSpPr>
         <p:spPr>
           <a:xfrm>
-            <a:off x="3840480" y="1709928"/>
-            <a:ext cx="2011680" cy="384048"/>
+            <a:off x="3977640" y="1188720"/>
+            <a:ext cx="1810512" cy="207749"/>
           </a:xfrm>
           <a:prstGeom prst="rect">
             <a:avLst/>
@@ -30334,8 +30718,8 @@
         </p:nvSpPr>
         <p:spPr>
           <a:xfrm>
-            <a:off x="3840480" y="2139696"/>
-            <a:ext cx="2011680" cy="384048"/>
+            <a:off x="3977640" y="1618488"/>
+            <a:ext cx="1810512" cy="207749"/>
           </a:xfrm>
           <a:prstGeom prst="rect">
             <a:avLst/>
@@ -30368,8 +30752,8 @@
         </p:nvSpPr>
         <p:spPr>
           <a:xfrm>
-            <a:off x="3840480" y="2569464"/>
-            <a:ext cx="2011680" cy="384048"/>
+            <a:off x="3977640" y="2048256"/>
+            <a:ext cx="1810512" cy="207749"/>
           </a:xfrm>
           <a:prstGeom prst="rect">
             <a:avLst/>
@@ -30402,8 +30786,8 @@
         </p:nvSpPr>
         <p:spPr>
           <a:xfrm>
-            <a:off x="3840480" y="2999232"/>
-            <a:ext cx="2011680" cy="384048"/>
+            <a:off x="3977640" y="2478024"/>
+            <a:ext cx="1810512" cy="207749"/>
           </a:xfrm>
           <a:prstGeom prst="rect">
             <a:avLst/>
@@ -30468,6 +30852,7 @@
           <a:lstStyle/>
           <a:p>
             <a:pPr algn="ctr"/>
+            <a:endParaRPr/>
           </a:p>
         </p:txBody>
       </p:sp>
@@ -30511,6 +30896,7 @@
           <a:lstStyle/>
           <a:p>
             <a:pPr algn="ctr"/>
+            <a:endParaRPr/>
           </a:p>
         </p:txBody>
       </p:sp>
@@ -30554,6 +30940,7 @@
           <a:lstStyle/>
           <a:p>
             <a:pPr algn="ctr"/>
+            <a:endParaRPr/>
           </a:p>
         </p:txBody>
       </p:sp>
@@ -30700,6 +31087,7 @@
           <a:lstStyle/>
           <a:p>
             <a:pPr algn="ctr"/>
+            <a:endParaRPr/>
           </a:p>
         </p:txBody>
       </p:sp>
@@ -30811,6 +31199,7 @@
           <a:lstStyle/>
           <a:p>
             <a:pPr algn="ctr"/>
+            <a:endParaRPr/>
           </a:p>
         </p:txBody>
       </p:sp>
@@ -30922,6 +31311,7 @@
           <a:lstStyle/>
           <a:p>
             <a:pPr algn="ctr"/>
+            <a:endParaRPr/>
           </a:p>
         </p:txBody>
       </p:sp>
@@ -31001,7 +31391,7 @@
         </p:nvSpPr>
         <p:spPr>
           <a:xfrm>
-            <a:off x="9692640" y="1709928"/>
+            <a:off x="9875520" y="1204445"/>
             <a:ext cx="2011680" cy="384048"/>
           </a:xfrm>
           <a:prstGeom prst="rect">
@@ -31035,7 +31425,7 @@
         </p:nvSpPr>
         <p:spPr>
           <a:xfrm>
-            <a:off x="9692640" y="2139696"/>
+            <a:off x="9875520" y="1634213"/>
             <a:ext cx="2011680" cy="384048"/>
           </a:xfrm>
           <a:prstGeom prst="rect">
@@ -31069,7 +31459,7 @@
         </p:nvSpPr>
         <p:spPr>
           <a:xfrm>
-            <a:off x="9692640" y="2569464"/>
+            <a:off x="9875520" y="2063981"/>
             <a:ext cx="2011680" cy="384048"/>
           </a:xfrm>
           <a:prstGeom prst="rect">
@@ -31103,7 +31493,7 @@
         </p:nvSpPr>
         <p:spPr>
           <a:xfrm>
-            <a:off x="9692640" y="2999232"/>
+            <a:off x="9875520" y="2493749"/>
             <a:ext cx="2011680" cy="384048"/>
           </a:xfrm>
           <a:prstGeom prst="rect">
@@ -31169,6 +31559,7 @@
           <a:lstStyle/>
           <a:p>
             <a:pPr algn="ctr"/>
+            <a:endParaRPr/>
           </a:p>
         </p:txBody>
       </p:sp>
@@ -31212,6 +31603,7 @@
           <a:lstStyle/>
           <a:p>
             <a:pPr algn="ctr"/>
+            <a:endParaRPr/>
           </a:p>
         </p:txBody>
       </p:sp>
@@ -31255,6 +31647,7 @@
           <a:lstStyle/>
           <a:p>
             <a:pPr algn="ctr"/>
+            <a:endParaRPr/>
           </a:p>
         </p:txBody>
       </p:sp>
@@ -31401,6 +31794,7 @@
           <a:lstStyle/>
           <a:p>
             <a:pPr algn="ctr"/>
+            <a:endParaRPr/>
           </a:p>
         </p:txBody>
       </p:sp>
@@ -31512,6 +31906,7 @@
           <a:lstStyle/>
           <a:p>
             <a:pPr algn="ctr"/>
+            <a:endParaRPr/>
           </a:p>
         </p:txBody>
       </p:sp>
@@ -31623,6 +32018,7 @@
           <a:lstStyle/>
           <a:p>
             <a:pPr algn="ctr"/>
+            <a:endParaRPr/>
           </a:p>
         </p:txBody>
       </p:sp>
@@ -31702,7 +32098,7 @@
         </p:nvSpPr>
         <p:spPr>
           <a:xfrm>
-            <a:off x="3840480" y="4407408"/>
+            <a:off x="4005072" y="3913632"/>
             <a:ext cx="2011680" cy="384048"/>
           </a:xfrm>
           <a:prstGeom prst="rect">
@@ -31718,79 +32114,79 @@
           <a:p>
             <a:pPr algn="l"/>
             <a:r>
+              <a:rPr sz="750" b="0" i="0" dirty="0">
+                <a:solidFill>
+                  <a:srgbClr val="6366F1"/>
+                </a:solidFill>
+              </a:rPr>
+              <a:t>-&gt; 21.4% return rate detected</a:t>
+            </a:r>
+          </a:p>
+        </p:txBody>
+      </p:sp>
+      <p:sp>
+        <p:nvSpPr>
+          <p:cNvPr id="62" name="TextBox 61"/>
+          <p:cNvSpPr txBox="1"/>
+          <p:nvPr/>
+        </p:nvSpPr>
+        <p:spPr>
+          <a:xfrm>
+            <a:off x="4005072" y="4343400"/>
+            <a:ext cx="2011680" cy="384048"/>
+          </a:xfrm>
+          <a:prstGeom prst="rect">
+            <a:avLst/>
+          </a:prstGeom>
+          <a:noFill/>
+        </p:spPr>
+        <p:txBody>
+          <a:bodyPr wrap="square">
+            <a:spAutoFit/>
+          </a:bodyPr>
+          <a:lstStyle/>
+          <a:p>
+            <a:pPr algn="l"/>
+            <a:r>
+              <a:rPr sz="750" b="0" i="0" dirty="0">
+                <a:solidFill>
+                  <a:srgbClr val="6366F1"/>
+                </a:solidFill>
+              </a:rPr>
+              <a:t>-&gt; Top 3 categories nearly equal share</a:t>
+            </a:r>
+          </a:p>
+        </p:txBody>
+      </p:sp>
+      <p:sp>
+        <p:nvSpPr>
+          <p:cNvPr id="63" name="TextBox 62"/>
+          <p:cNvSpPr txBox="1"/>
+          <p:nvPr/>
+        </p:nvSpPr>
+        <p:spPr>
+          <a:xfrm>
+            <a:off x="4005072" y="4773168"/>
+            <a:ext cx="2011680" cy="384048"/>
+          </a:xfrm>
+          <a:prstGeom prst="rect">
+            <a:avLst/>
+          </a:prstGeom>
+          <a:noFill/>
+        </p:spPr>
+        <p:txBody>
+          <a:bodyPr wrap="square">
+            <a:spAutoFit/>
+          </a:bodyPr>
+          <a:lstStyle/>
+          <a:p>
+            <a:pPr algn="l"/>
+            <a:r>
               <a:rPr sz="750" b="0" i="0">
                 <a:solidFill>
                   <a:srgbClr val="6366F1"/>
                 </a:solidFill>
               </a:rPr>
-              <a:t>-&gt; 21.4% return rate detected</a:t>
-            </a:r>
-          </a:p>
-        </p:txBody>
-      </p:sp>
-      <p:sp>
-        <p:nvSpPr>
-          <p:cNvPr id="62" name="TextBox 61"/>
-          <p:cNvSpPr txBox="1"/>
-          <p:nvPr/>
-        </p:nvSpPr>
-        <p:spPr>
-          <a:xfrm>
-            <a:off x="3840480" y="4837176"/>
-            <a:ext cx="2011680" cy="384048"/>
-          </a:xfrm>
-          <a:prstGeom prst="rect">
-            <a:avLst/>
-          </a:prstGeom>
-          <a:noFill/>
-        </p:spPr>
-        <p:txBody>
-          <a:bodyPr wrap="square">
-            <a:spAutoFit/>
-          </a:bodyPr>
-          <a:lstStyle/>
-          <a:p>
-            <a:pPr algn="l"/>
-            <a:r>
-              <a:rPr sz="750" b="0" i="0">
-                <a:solidFill>
-                  <a:srgbClr val="6366F1"/>
-                </a:solidFill>
-              </a:rPr>
-              <a:t>-&gt; Top 3 categories nearly equal share</a:t>
-            </a:r>
-          </a:p>
-        </p:txBody>
-      </p:sp>
-      <p:sp>
-        <p:nvSpPr>
-          <p:cNvPr id="63" name="TextBox 62"/>
-          <p:cNvSpPr txBox="1"/>
-          <p:nvPr/>
-        </p:nvSpPr>
-        <p:spPr>
-          <a:xfrm>
-            <a:off x="3840480" y="5266944"/>
-            <a:ext cx="2011680" cy="384048"/>
-          </a:xfrm>
-          <a:prstGeom prst="rect">
-            <a:avLst/>
-          </a:prstGeom>
-          <a:noFill/>
-        </p:spPr>
-        <p:txBody>
-          <a:bodyPr wrap="square">
-            <a:spAutoFit/>
-          </a:bodyPr>
-          <a:lstStyle/>
-          <a:p>
-            <a:pPr algn="l"/>
-            <a:r>
-              <a:rPr sz="750" b="0" i="0">
-                <a:solidFill>
-                  <a:srgbClr val="6366F1"/>
-                </a:solidFill>
-              </a:rPr>
               <a:t>-&gt; $401.1M total line revenue</a:t>
             </a:r>
           </a:p>
@@ -31804,7 +32200,7 @@
         </p:nvSpPr>
         <p:spPr>
           <a:xfrm>
-            <a:off x="3840480" y="5696712"/>
+            <a:off x="4005072" y="5202936"/>
             <a:ext cx="2011680" cy="384048"/>
           </a:xfrm>
           <a:prstGeom prst="rect">
@@ -31870,6 +32266,7 @@
           <a:lstStyle/>
           <a:p>
             <a:pPr algn="ctr"/>
+            <a:endParaRPr/>
           </a:p>
         </p:txBody>
       </p:sp>
@@ -31913,6 +32310,7 @@
           <a:lstStyle/>
           <a:p>
             <a:pPr algn="ctr"/>
+            <a:endParaRPr/>
           </a:p>
         </p:txBody>
       </p:sp>
@@ -31956,6 +32354,7 @@
           <a:lstStyle/>
           <a:p>
             <a:pPr algn="ctr"/>
+            <a:endParaRPr/>
           </a:p>
         </p:txBody>
       </p:sp>
@@ -32102,6 +32501,7 @@
           <a:lstStyle/>
           <a:p>
             <a:pPr algn="ctr"/>
+            <a:endParaRPr/>
           </a:p>
         </p:txBody>
       </p:sp>
@@ -32213,6 +32613,7 @@
           <a:lstStyle/>
           <a:p>
             <a:pPr algn="ctr"/>
+            <a:endParaRPr/>
           </a:p>
         </p:txBody>
       </p:sp>
@@ -32324,6 +32725,7 @@
           <a:lstStyle/>
           <a:p>
             <a:pPr algn="ctr"/>
+            <a:endParaRPr/>
           </a:p>
         </p:txBody>
       </p:sp>
@@ -32403,7 +32805,7 @@
         </p:nvSpPr>
         <p:spPr>
           <a:xfrm>
-            <a:off x="9692640" y="4407408"/>
+            <a:off x="9875520" y="3904488"/>
             <a:ext cx="2011680" cy="384048"/>
           </a:xfrm>
           <a:prstGeom prst="rect">
@@ -32419,79 +32821,79 @@
           <a:p>
             <a:pPr algn="l"/>
             <a:r>
+              <a:rPr sz="750" b="0" i="0" dirty="0">
+                <a:solidFill>
+                  <a:srgbClr val="F59E0B"/>
+                </a:solidFill>
+              </a:rPr>
+              <a:t>-&gt; 66.8% active employee rate</a:t>
+            </a:r>
+          </a:p>
+        </p:txBody>
+      </p:sp>
+      <p:sp>
+        <p:nvSpPr>
+          <p:cNvPr id="81" name="TextBox 80"/>
+          <p:cNvSpPr txBox="1"/>
+          <p:nvPr/>
+        </p:nvSpPr>
+        <p:spPr>
+          <a:xfrm>
+            <a:off x="9875520" y="4334256"/>
+            <a:ext cx="2011680" cy="384048"/>
+          </a:xfrm>
+          <a:prstGeom prst="rect">
+            <a:avLst/>
+          </a:prstGeom>
+          <a:noFill/>
+        </p:spPr>
+        <p:txBody>
+          <a:bodyPr wrap="square">
+            <a:spAutoFit/>
+          </a:bodyPr>
+          <a:lstStyle/>
+          <a:p>
+            <a:pPr algn="l"/>
+            <a:r>
+              <a:rPr sz="750" b="0" i="0" dirty="0">
+                <a:solidFill>
+                  <a:srgbClr val="F59E0B"/>
+                </a:solidFill>
+              </a:rPr>
+              <a:t>-&gt; 5 departments at attrition risk</a:t>
+            </a:r>
+          </a:p>
+        </p:txBody>
+      </p:sp>
+      <p:sp>
+        <p:nvSpPr>
+          <p:cNvPr id="82" name="TextBox 81"/>
+          <p:cNvSpPr txBox="1"/>
+          <p:nvPr/>
+        </p:nvSpPr>
+        <p:spPr>
+          <a:xfrm>
+            <a:off x="9875520" y="4764024"/>
+            <a:ext cx="2011680" cy="384048"/>
+          </a:xfrm>
+          <a:prstGeom prst="rect">
+            <a:avLst/>
+          </a:prstGeom>
+          <a:noFill/>
+        </p:spPr>
+        <p:txBody>
+          <a:bodyPr wrap="square">
+            <a:spAutoFit/>
+          </a:bodyPr>
+          <a:lstStyle/>
+          <a:p>
+            <a:pPr algn="l"/>
+            <a:r>
               <a:rPr sz="750" b="0" i="0">
                 <a:solidFill>
                   <a:srgbClr val="F59E0B"/>
                 </a:solidFill>
               </a:rPr>
-              <a:t>-&gt; 66.8% active employee rate</a:t>
-            </a:r>
-          </a:p>
-        </p:txBody>
-      </p:sp>
-      <p:sp>
-        <p:nvSpPr>
-          <p:cNvPr id="81" name="TextBox 80"/>
-          <p:cNvSpPr txBox="1"/>
-          <p:nvPr/>
-        </p:nvSpPr>
-        <p:spPr>
-          <a:xfrm>
-            <a:off x="9692640" y="4837176"/>
-            <a:ext cx="2011680" cy="384048"/>
-          </a:xfrm>
-          <a:prstGeom prst="rect">
-            <a:avLst/>
-          </a:prstGeom>
-          <a:noFill/>
-        </p:spPr>
-        <p:txBody>
-          <a:bodyPr wrap="square">
-            <a:spAutoFit/>
-          </a:bodyPr>
-          <a:lstStyle/>
-          <a:p>
-            <a:pPr algn="l"/>
-            <a:r>
-              <a:rPr sz="750" b="0" i="0">
-                <a:solidFill>
-                  <a:srgbClr val="F59E0B"/>
-                </a:solidFill>
-              </a:rPr>
-              <a:t>-&gt; 5 departments at attrition risk</a:t>
-            </a:r>
-          </a:p>
-        </p:txBody>
-      </p:sp>
-      <p:sp>
-        <p:nvSpPr>
-          <p:cNvPr id="82" name="TextBox 81"/>
-          <p:cNvSpPr txBox="1"/>
-          <p:nvPr/>
-        </p:nvSpPr>
-        <p:spPr>
-          <a:xfrm>
-            <a:off x="9692640" y="5266944"/>
-            <a:ext cx="2011680" cy="384048"/>
-          </a:xfrm>
-          <a:prstGeom prst="rect">
-            <a:avLst/>
-          </a:prstGeom>
-          <a:noFill/>
-        </p:spPr>
-        <p:txBody>
-          <a:bodyPr wrap="square">
-            <a:spAutoFit/>
-          </a:bodyPr>
-          <a:lstStyle/>
-          <a:p>
-            <a:pPr algn="l"/>
-            <a:r>
-              <a:rPr sz="750" b="0" i="0">
-                <a:solidFill>
-                  <a:srgbClr val="F59E0B"/>
-                </a:solidFill>
-              </a:rPr>
               <a:t>-&gt; 1.09x gender pay gap detected</a:t>
             </a:r>
           </a:p>
@@ -32505,7 +32907,7 @@
         </p:nvSpPr>
         <p:spPr>
           <a:xfrm>
-            <a:off x="9692640" y="5696712"/>
+            <a:off x="9875520" y="5193792"/>
             <a:ext cx="2011680" cy="384048"/>
           </a:xfrm>
           <a:prstGeom prst="rect">
@@ -32540,7 +32942,7 @@
 </file>
 
 <file path=ppt/slides/slide9.xml><?xml version="1.0" encoding="utf-8"?>
-<p:sld xmlns:a="http://schemas.openxmlformats.org/drawingml/2006/main" xmlns:p="http://schemas.openxmlformats.org/presentationml/2006/main" xmlns:r="http://schemas.openxmlformats.org/officeDocument/2006/relationships">
+<p:sld xmlns:a="http://schemas.openxmlformats.org/drawingml/2006/main" xmlns:r="http://schemas.openxmlformats.org/officeDocument/2006/relationships" xmlns:p="http://schemas.openxmlformats.org/presentationml/2006/main">
   <p:cSld>
     <p:bg>
       <p:bgPr>
@@ -32556,7 +32958,14 @@
         <p:cNvGrpSpPr/>
         <p:nvPr/>
       </p:nvGrpSpPr>
-      <p:grpSpPr/>
+      <p:grpSpPr>
+        <a:xfrm>
+          <a:off x="0" y="0"/>
+          <a:ext cx="0" cy="0"/>
+          <a:chOff x="0" y="0"/>
+          <a:chExt cx="0" cy="0"/>
+        </a:xfrm>
+      </p:grpSpPr>
       <p:sp>
         <p:nvSpPr>
           <p:cNvPr id="2" name="Rectangle 1"/>
@@ -32597,6 +33006,7 @@
           <a:lstStyle/>
           <a:p>
             <a:pPr algn="ctr"/>
+            <a:endParaRPr/>
           </a:p>
         </p:txBody>
       </p:sp>
@@ -32640,6 +33050,7 @@
           <a:lstStyle/>
           <a:p>
             <a:pPr algn="ctr"/>
+            <a:endParaRPr/>
           </a:p>
         </p:txBody>
       </p:sp>
@@ -32751,6 +33162,7 @@
           <a:lstStyle/>
           <a:p>
             <a:pPr algn="ctr"/>
+            <a:endParaRPr/>
           </a:p>
         </p:txBody>
       </p:sp>
@@ -32828,6 +33240,7 @@
           <a:lstStyle/>
           <a:p>
             <a:pPr algn="ctr"/>
+            <a:endParaRPr/>
           </a:p>
         </p:txBody>
       </p:sp>
@@ -32871,6 +33284,7 @@
           <a:lstStyle/>
           <a:p>
             <a:pPr algn="ctr"/>
+            <a:endParaRPr/>
           </a:p>
         </p:txBody>
       </p:sp>
@@ -33016,6 +33430,7 @@
           <a:lstStyle/>
           <a:p>
             <a:pPr algn="ctr"/>
+            <a:endParaRPr/>
           </a:p>
         </p:txBody>
       </p:sp>
@@ -33059,6 +33474,7 @@
           <a:lstStyle/>
           <a:p>
             <a:pPr algn="ctr"/>
+            <a:endParaRPr/>
           </a:p>
         </p:txBody>
       </p:sp>
@@ -33204,6 +33620,7 @@
           <a:lstStyle/>
           <a:p>
             <a:pPr algn="ctr"/>
+            <a:endParaRPr/>
           </a:p>
         </p:txBody>
       </p:sp>
@@ -33247,6 +33664,7 @@
           <a:lstStyle/>
           <a:p>
             <a:pPr algn="ctr"/>
+            <a:endParaRPr/>
           </a:p>
         </p:txBody>
       </p:sp>
@@ -33392,6 +33810,7 @@
           <a:lstStyle/>
           <a:p>
             <a:pPr algn="ctr"/>
+            <a:endParaRPr/>
           </a:p>
         </p:txBody>
       </p:sp>
@@ -33435,6 +33854,7 @@
           <a:lstStyle/>
           <a:p>
             <a:pPr algn="ctr"/>
+            <a:endParaRPr/>
           </a:p>
         </p:txBody>
       </p:sp>
@@ -33580,6 +34000,7 @@
           <a:lstStyle/>
           <a:p>
             <a:pPr algn="ctr"/>
+            <a:endParaRPr/>
           </a:p>
         </p:txBody>
       </p:sp>
@@ -33623,6 +34044,7 @@
           <a:lstStyle/>
           <a:p>
             <a:pPr algn="ctr"/>
+            <a:endParaRPr/>
           </a:p>
         </p:txBody>
       </p:sp>
@@ -33836,6 +34258,7 @@
           <a:lstStyle/>
           <a:p>
             <a:pPr algn="ctr"/>
+            <a:endParaRPr/>
           </a:p>
         </p:txBody>
       </p:sp>
@@ -33879,6 +34302,7 @@
           <a:lstStyle/>
           <a:p>
             <a:pPr algn="ctr"/>
+            <a:endParaRPr/>
           </a:p>
         </p:txBody>
       </p:sp>
@@ -34092,6 +34516,7 @@
           <a:lstStyle/>
           <a:p>
             <a:pPr algn="ctr"/>
+            <a:endParaRPr/>
           </a:p>
         </p:txBody>
       </p:sp>
@@ -34135,6 +34560,7 @@
           <a:lstStyle/>
           <a:p>
             <a:pPr algn="ctr"/>
+            <a:endParaRPr/>
           </a:p>
         </p:txBody>
       </p:sp>
@@ -34348,6 +34774,7 @@
           <a:lstStyle/>
           <a:p>
             <a:pPr algn="ctr"/>
+            <a:endParaRPr/>
           </a:p>
         </p:txBody>
       </p:sp>
@@ -34391,6 +34818,7 @@
           <a:lstStyle/>
           <a:p>
             <a:pPr algn="ctr"/>
+            <a:endParaRPr/>
           </a:p>
         </p:txBody>
       </p:sp>

</xml_diff>